<commit_message>
Add Helping Hands hardship fund, Membership Chair seat, and board recognition slide
- website/hardship.html: program rules (eligibility, rubric with weights,
  cycle deadlines) + confidential application form; linked from Give page
- docs/Hardship-Fund-Application.docx: printable paper application
- Presentation + PPTX (28 slides): hardship fund slide, board & committee
  recognition slide, Membership Chair added to the officer slate, land-back
  fund scope (renovation & revitalization) carried through the WIML slide
- Constitution: Membership Chair added to officers (Art. IV) with duties
  (Bylaws Art. 1.9)

Co-Authored-By: Claude Fable 5 <noreply@anthropic.com>
Claude-Session: https://claude.ai/code/session_01NPnb9BRrqaoMRYjtDyxgui
</commit_message>
<xml_diff>
--- a/presentation/Harris-Nelson-Reunion-2026.pptx
+++ b/presentation/Harris-Nelson-Reunion-2026.pptx
@@ -31,6 +31,8 @@
     <p:sldId id="279" r:id="rId30"/>
     <p:sldId id="280" r:id="rId31"/>
     <p:sldId id="281" r:id="rId32"/>
+    <p:sldId id="282" r:id="rId33"/>
+    <p:sldId id="283" r:id="rId34"/>
   </p:sldIdLst>
   <p:sldSz cx="12191695" cy="6858000" type="screen4x3"/>
   <p:notesSz cx="6858000" cy="9144000"/>
@@ -6219,7 +6221,7 @@
                 <a:gridCol w="2194560"/>
                 <a:gridCol w="5852160"/>
               </a:tblGrid>
-              <a:tr h="467360">
+              <a:tr h="420624">
                 <a:tc>
                   <a:txBody>
                     <a:bodyPr/>
@@ -6284,7 +6286,7 @@
                   </a:tcPr>
                 </a:tc>
               </a:tr>
-              <a:tr h="467360">
+              <a:tr h="420624">
                 <a:tc>
                   <a:txBody>
                     <a:bodyPr/>
@@ -6337,7 +6339,7 @@
                   <a:tcPr/>
                 </a:tc>
               </a:tr>
-              <a:tr h="467360">
+              <a:tr h="420624">
                 <a:tc>
                   <a:txBody>
                     <a:bodyPr/>
@@ -6390,7 +6392,7 @@
                   <a:tcPr/>
                 </a:tc>
               </a:tr>
-              <a:tr h="467360">
+              <a:tr h="420624">
                 <a:tc>
                   <a:txBody>
                     <a:bodyPr/>
@@ -6443,7 +6445,7 @@
                   <a:tcPr/>
                 </a:tc>
               </a:tr>
-              <a:tr h="467360">
+              <a:tr h="420624">
                 <a:tc>
                   <a:txBody>
                     <a:bodyPr/>
@@ -6496,7 +6498,7 @@
                   <a:tcPr/>
                 </a:tc>
               </a:tr>
-              <a:tr h="467360">
+              <a:tr h="420624">
                 <a:tc>
                   <a:txBody>
                     <a:bodyPr/>
@@ -6549,7 +6551,7 @@
                   <a:tcPr/>
                 </a:tc>
               </a:tr>
-              <a:tr h="467360">
+              <a:tr h="420624">
                 <a:tc>
                   <a:txBody>
                     <a:bodyPr/>
@@ -6602,7 +6604,7 @@
                   <a:tcPr/>
                 </a:tc>
               </a:tr>
-              <a:tr h="467360">
+              <a:tr h="420624">
                 <a:tc>
                   <a:txBody>
                     <a:bodyPr/>
@@ -6655,7 +6657,7 @@
                   <a:tcPr/>
                 </a:tc>
               </a:tr>
-              <a:tr h="467360">
+              <a:tr h="420624">
                 <a:tc>
                   <a:txBody>
                     <a:bodyPr/>
@@ -6708,6 +6710,59 @@
                   <a:tcPr/>
                 </a:tc>
               </a:tr>
+              <a:tr h="420624">
+                <a:tc>
+                  <a:txBody>
+                    <a:bodyPr/>
+                    <a:lstStyle/>
+                    <a:p>
+                      <a:r>
+                        <a:rPr sz="1200" b="0">
+                          <a:solidFill>
+                            <a:srgbClr val="26221B"/>
+                          </a:solidFill>
+                        </a:rPr>
+                        <a:t>Membership Chair</a:t>
+                      </a:r>
+                    </a:p>
+                  </a:txBody>
+                  <a:tcPr/>
+                </a:tc>
+                <a:tc>
+                  <a:txBody>
+                    <a:bodyPr/>
+                    <a:lstStyle/>
+                    <a:p>
+                      <a:r>
+                        <a:rPr sz="1200" b="1">
+                          <a:solidFill>
+                            <a:srgbClr val="26221B"/>
+                          </a:solidFill>
+                        </a:rPr>
+                        <a:t>[Open — nominate today!]</a:t>
+                      </a:r>
+                    </a:p>
+                  </a:txBody>
+                  <a:tcPr/>
+                </a:tc>
+                <a:tc>
+                  <a:txBody>
+                    <a:bodyPr/>
+                    <a:lstStyle/>
+                    <a:p>
+                      <a:r>
+                        <a:rPr sz="1200" b="0">
+                          <a:solidFill>
+                            <a:srgbClr val="26221B"/>
+                          </a:solidFill>
+                        </a:rPr>
+                        <a:t>Membership roll &amp; recruitment; matches volunteers to committees</a:t>
+                      </a:r>
+                    </a:p>
+                  </a:txBody>
+                  <a:tcPr/>
+                </a:tc>
+              </a:tr>
             </a:tbl>
           </a:graphicData>
         </a:graphic>
@@ -6811,7 +6866,7 @@
                 </a:solidFill>
                 <a:latin typeface="Verdana"/>
               </a:rPr>
-              <a:t>FAMILY BUSINESS · GOVERNANCE</a:t>
+              <a:t>FAMILY BUSINESS · RECOGNITION</a:t>
             </a:r>
           </a:p>
         </p:txBody>
@@ -6850,7 +6905,7 @@
                 </a:solidFill>
                 <a:latin typeface="Georgia"/>
               </a:rPr>
-              <a:t>Robert's Rules of Order + Our Constitution 📜</a:t>
+              <a:t>Give Our Board &amp; Committee Members Their Flowers 👏</a:t>
             </a:r>
           </a:p>
         </p:txBody>
@@ -6864,7 +6919,7 @@
         <p:spPr>
           <a:xfrm>
             <a:off x="640080" y="1645920"/>
-            <a:ext cx="5486400" cy="4114800"/>
+            <a:ext cx="3657600" cy="4114800"/>
           </a:xfrm>
           <a:prstGeom prst="rect">
             <a:avLst/>
@@ -6883,93 +6938,141 @@
               </a:spcAft>
             </a:pPr>
             <a:r>
-              <a:rPr sz="1700" b="1">
+              <a:rPr sz="1500" b="1">
                 <a:solidFill>
                   <a:srgbClr val="2E7D32"/>
                 </a:solidFill>
                 <a:latin typeface="Georgia"/>
               </a:rPr>
-              <a:t>Meetings stay fair, short &amp; drama-free</a:t>
-            </a:r>
-          </a:p>
-          <a:p>
-            <a:pPr algn="l">
-              <a:spcAft>
-                <a:spcPts val="600"/>
-              </a:spcAft>
-            </a:pPr>
-            <a:r>
-              <a:rPr sz="1500" b="0">
-                <a:solidFill>
-                  <a:srgbClr val="26221B"/>
-                </a:solidFill>
-                <a:latin typeface="Georgia"/>
-              </a:rPr>
-              <a:t>• Quorum — minimum members present to conduct business</a:t>
-            </a:r>
-          </a:p>
-          <a:p>
-            <a:pPr algn="l">
-              <a:spcAft>
-                <a:spcPts val="600"/>
-              </a:spcAft>
-            </a:pPr>
-            <a:r>
-              <a:rPr sz="1500" b="0">
-                <a:solidFill>
-                  <a:srgbClr val="26221B"/>
-                </a:solidFill>
-                <a:latin typeface="Georgia"/>
-              </a:rPr>
-              <a:t>• Motion — “I move that we…” puts an idea on the floor</a:t>
-            </a:r>
-          </a:p>
-          <a:p>
-            <a:pPr algn="l">
-              <a:spcAft>
-                <a:spcPts val="600"/>
-              </a:spcAft>
-            </a:pPr>
-            <a:r>
-              <a:rPr sz="1500" b="0">
-                <a:solidFill>
-                  <a:srgbClr val="26221B"/>
-                </a:solidFill>
-                <a:latin typeface="Georgia"/>
-              </a:rPr>
-              <a:t>• Second — one member seconds to open discussion</a:t>
-            </a:r>
-          </a:p>
-          <a:p>
-            <a:pPr algn="l">
-              <a:spcAft>
-                <a:spcPts val="600"/>
-              </a:spcAft>
-            </a:pPr>
-            <a:r>
-              <a:rPr sz="1500" b="0">
-                <a:solidFill>
-                  <a:srgbClr val="26221B"/>
-                </a:solidFill>
-                <a:latin typeface="Georgia"/>
-              </a:rPr>
-              <a:t>• Discussion — the chair recognizes speakers in turn</a:t>
-            </a:r>
-          </a:p>
-          <a:p>
-            <a:pPr algn="l">
-              <a:spcAft>
-                <a:spcPts val="600"/>
-              </a:spcAft>
-            </a:pPr>
-            <a:r>
-              <a:rPr sz="1500" b="0">
-                <a:solidFill>
-                  <a:srgbClr val="26221B"/>
-                </a:solidFill>
-                <a:latin typeface="Georgia"/>
-              </a:rPr>
-              <a:t>• Vote — majority carries; the Secretary records it</a:t>
+              <a:t>Our current board — thank you!</a:t>
+            </a:r>
+          </a:p>
+          <a:p>
+            <a:pPr algn="l">
+              <a:spcAft>
+                <a:spcPts val="600"/>
+              </a:spcAft>
+            </a:pPr>
+            <a:r>
+              <a:rPr sz="1300" b="0">
+                <a:solidFill>
+                  <a:srgbClr val="26221B"/>
+                </a:solidFill>
+                <a:latin typeface="Georgia"/>
+              </a:rPr>
+              <a:t>• Miesha — President</a:t>
+            </a:r>
+          </a:p>
+          <a:p>
+            <a:pPr algn="l">
+              <a:spcAft>
+                <a:spcPts val="600"/>
+              </a:spcAft>
+            </a:pPr>
+            <a:r>
+              <a:rPr sz="1300" b="0">
+                <a:solidFill>
+                  <a:srgbClr val="26221B"/>
+                </a:solidFill>
+                <a:latin typeface="Georgia"/>
+              </a:rPr>
+              <a:t>• Aunt Shirley — Vice President</a:t>
+            </a:r>
+          </a:p>
+          <a:p>
+            <a:pPr algn="l">
+              <a:spcAft>
+                <a:spcPts val="600"/>
+              </a:spcAft>
+            </a:pPr>
+            <a:r>
+              <a:rPr sz="1300" b="0">
+                <a:solidFill>
+                  <a:srgbClr val="26221B"/>
+                </a:solidFill>
+                <a:latin typeface="Georgia"/>
+              </a:rPr>
+              <a:t>• Marcelette — Secretary</a:t>
+            </a:r>
+          </a:p>
+          <a:p>
+            <a:pPr algn="l">
+              <a:spcAft>
+                <a:spcPts val="600"/>
+              </a:spcAft>
+            </a:pPr>
+            <a:r>
+              <a:rPr sz="1300" b="0">
+                <a:solidFill>
+                  <a:srgbClr val="26221B"/>
+                </a:solidFill>
+                <a:latin typeface="Georgia"/>
+              </a:rPr>
+              <a:t>• Jasmine — Treasurer</a:t>
+            </a:r>
+          </a:p>
+          <a:p>
+            <a:pPr algn="l">
+              <a:spcAft>
+                <a:spcPts val="600"/>
+              </a:spcAft>
+            </a:pPr>
+            <a:r>
+              <a:rPr sz="1300" b="0">
+                <a:solidFill>
+                  <a:srgbClr val="26221B"/>
+                </a:solidFill>
+                <a:latin typeface="Georgia"/>
+              </a:rPr>
+              <a:t>• Aunt Vanessa — Financial Secretary</a:t>
+            </a:r>
+          </a:p>
+          <a:p>
+            <a:pPr algn="l">
+              <a:spcAft>
+                <a:spcPts val="600"/>
+              </a:spcAft>
+            </a:pPr>
+            <a:r>
+              <a:rPr sz="1300" b="0">
+                <a:solidFill>
+                  <a:srgbClr val="26221B"/>
+                </a:solidFill>
+                <a:latin typeface="Georgia"/>
+              </a:rPr>
+              <a:t>• Shone — Historian</a:t>
+            </a:r>
+          </a:p>
+          <a:p>
+            <a:pPr algn="l">
+              <a:spcAft>
+                <a:spcPts val="600"/>
+              </a:spcAft>
+            </a:pPr>
+            <a:r>
+              <a:rPr sz="1300" b="0">
+                <a:solidFill>
+                  <a:srgbClr val="26221B"/>
+                </a:solidFill>
+                <a:latin typeface="Georgia"/>
+              </a:rPr>
+              <a:t>• Loretta — Hospitality</a:t>
+            </a:r>
+          </a:p>
+          <a:p>
+            <a:pPr algn="l">
+              <a:spcAft>
+                <a:spcPts val="600"/>
+              </a:spcAft>
+            </a:pPr>
+            <a:r>
+              <a:rPr sz="1300" b="0">
+                <a:solidFill>
+                  <a:srgbClr val="26221B"/>
+                </a:solidFill>
+                <a:latin typeface="Georgia"/>
+              </a:rPr>
+              <a:t>• Joseph — Sergeant-at-Arms</a:t>
             </a:r>
           </a:p>
         </p:txBody>
@@ -6982,8 +7085,8 @@
         </p:nvSpPr>
         <p:spPr>
           <a:xfrm>
-            <a:off x="6400800" y="1645920"/>
-            <a:ext cx="5120640" cy="4114800"/>
+            <a:off x="4434840" y="1645920"/>
+            <a:ext cx="3657600" cy="4114800"/>
           </a:xfrm>
           <a:prstGeom prst="rect">
             <a:avLst/>
@@ -7002,93 +7105,29 @@
               </a:spcAft>
             </a:pPr>
             <a:r>
-              <a:rPr sz="1700" b="1">
+              <a:rPr sz="1500" b="1">
                 <a:solidFill>
                   <a:srgbClr val="E65100"/>
                 </a:solidFill>
                 <a:latin typeface="Georgia"/>
               </a:rPr>
-              <a:t>Cheat sheet — what do I say?</a:t>
-            </a:r>
-          </a:p>
-          <a:p>
-            <a:pPr algn="l">
-              <a:spcAft>
-                <a:spcPts val="600"/>
-              </a:spcAft>
-            </a:pPr>
-            <a:r>
-              <a:rPr sz="1500" b="0">
-                <a:solidFill>
-                  <a:srgbClr val="26221B"/>
-                </a:solidFill>
-                <a:latin typeface="Georgia"/>
-              </a:rPr>
-              <a:t>• Propose → “I move that…”</a:t>
-            </a:r>
-          </a:p>
-          <a:p>
-            <a:pPr algn="l">
-              <a:spcAft>
-                <a:spcPts val="600"/>
-              </a:spcAft>
-            </a:pPr>
-            <a:r>
-              <a:rPr sz="1500" b="0">
-                <a:solidFill>
-                  <a:srgbClr val="26221B"/>
-                </a:solidFill>
-                <a:latin typeface="Georgia"/>
-              </a:rPr>
-              <a:t>• Support → “Second!”</a:t>
-            </a:r>
-          </a:p>
-          <a:p>
-            <a:pPr algn="l">
-              <a:spcAft>
-                <a:spcPts val="600"/>
-              </a:spcAft>
-            </a:pPr>
-            <a:r>
-              <a:rPr sz="1500" b="0">
-                <a:solidFill>
-                  <a:srgbClr val="26221B"/>
-                </a:solidFill>
-                <a:latin typeface="Georgia"/>
-              </a:rPr>
-              <a:t>• Change wording → “I move to amend…”</a:t>
-            </a:r>
-          </a:p>
-          <a:p>
-            <a:pPr algn="l">
-              <a:spcAft>
-                <a:spcPts val="600"/>
-              </a:spcAft>
-            </a:pPr>
-            <a:r>
-              <a:rPr sz="1500" b="0">
-                <a:solidFill>
-                  <a:srgbClr val="26221B"/>
-                </a:solidFill>
-                <a:latin typeface="Georgia"/>
-              </a:rPr>
-              <a:t>• End debate → “I move the previous question”</a:t>
-            </a:r>
-          </a:p>
-          <a:p>
-            <a:pPr algn="l">
-              <a:spcAft>
-                <a:spcPts val="600"/>
-              </a:spcAft>
-            </a:pPr>
-            <a:r>
-              <a:rPr sz="1500" b="0">
-                <a:solidFill>
-                  <a:srgbClr val="26221B"/>
-                </a:solidFill>
-                <a:latin typeface="Georgia"/>
-              </a:rPr>
-              <a:t>• Wrap up → “I move to adjourn”</a:t>
+              <a:t>Our committee members</a:t>
+            </a:r>
+          </a:p>
+          <a:p>
+            <a:pPr algn="l">
+              <a:spcAft>
+                <a:spcPts val="600"/>
+              </a:spcAft>
+            </a:pPr>
+            <a:r>
+              <a:rPr sz="1300" b="0">
+                <a:solidFill>
+                  <a:srgbClr val="26221B"/>
+                </a:solidFill>
+                <a:latin typeface="Georgia"/>
+              </a:rPr>
+              <a:t>• [Add the names of everyone currently serving on a committee — they get recognized here]</a:t>
             </a:r>
           </a:p>
         </p:txBody>
@@ -7096,6 +7135,77 @@
       <p:sp>
         <p:nvSpPr>
           <p:cNvPr id="6" name="TextBox 5"/>
+          <p:cNvSpPr txBox="1"/>
+          <p:nvPr/>
+        </p:nvSpPr>
+        <p:spPr>
+          <a:xfrm>
+            <a:off x="8229600" y="1645920"/>
+            <a:ext cx="3566160" cy="4114800"/>
+          </a:xfrm>
+          <a:prstGeom prst="rect">
+            <a:avLst/>
+          </a:prstGeom>
+          <a:noFill/>
+        </p:spPr>
+        <p:txBody>
+          <a:bodyPr wrap="square">
+            <a:spAutoFit/>
+          </a:bodyPr>
+          <a:lstStyle/>
+          <a:p>
+            <a:pPr algn="l">
+              <a:spcAft>
+                <a:spcPts val="800"/>
+              </a:spcAft>
+            </a:pPr>
+            <a:r>
+              <a:rPr sz="1500" b="1">
+                <a:solidFill>
+                  <a:srgbClr val="B71C1C"/>
+                </a:solidFill>
+                <a:latin typeface="Georgia"/>
+              </a:rPr>
+              <a:t>We need YOU</a:t>
+            </a:r>
+          </a:p>
+          <a:p>
+            <a:pPr algn="l">
+              <a:spcAft>
+                <a:spcPts val="600"/>
+              </a:spcAft>
+            </a:pPr>
+            <a:r>
+              <a:rPr sz="1300" b="0">
+                <a:solidFill>
+                  <a:srgbClr val="26221B"/>
+                </a:solidFill>
+                <a:latin typeface="Georgia"/>
+              </a:rPr>
+              <a:t>• MEMBERSHIP CHAIR — a new board seat, open for nominations today</a:t>
+            </a:r>
+          </a:p>
+          <a:p>
+            <a:pPr algn="l">
+              <a:spcAft>
+                <a:spcPts val="600"/>
+              </a:spcAft>
+            </a:pPr>
+            <a:r>
+              <a:rPr sz="1300" b="0">
+                <a:solidFill>
+                  <a:srgbClr val="26221B"/>
+                </a:solidFill>
+                <a:latin typeface="Georgia"/>
+              </a:rPr>
+              <a:t>• COMMITTEE MEMBERS — every committee needs 2–5 members to assist its chair; no chair should carry a committee alone</a:t>
+            </a:r>
+          </a:p>
+        </p:txBody>
+      </p:sp>
+      <p:sp>
+        <p:nvSpPr>
+          <p:cNvPr id="7" name="TextBox 6"/>
           <p:cNvSpPr txBox="1"/>
           <p:nvPr/>
         </p:nvSpPr>
@@ -7127,7 +7237,7 @@
                 </a:solidFill>
                 <a:latin typeface="Verdana"/>
               </a:rPr>
-              <a:t>Motion on today's agenda: adopt the Harris-Nelson Constitution &amp; Bylaws — membership, officers &amp; terms, quorum, dues, committees, amendments.</a:t>
+              <a:t>The Membership Chair keeps the family roll, welcomes new members, and matches volunteers to committees. The Secretary is taking nominations right now.</a:t>
             </a:r>
           </a:p>
         </p:txBody>
@@ -7192,7 +7302,7 @@
                 </a:solidFill>
                 <a:latin typeface="Verdana"/>
               </a:rPr>
-              <a:t>FAMILY BUSINESS · COMMITTEES</a:t>
+              <a:t>FAMILY BUSINESS · GOVERNANCE</a:t>
             </a:r>
           </a:p>
         </p:txBody>
@@ -7231,7 +7341,7 @@
                 </a:solidFill>
                 <a:latin typeface="Georgia"/>
               </a:rPr>
-              <a:t>Committees Need Chairs — That Means YOU 🙋</a:t>
+              <a:t>Robert's Rules of Order + Our Constitution 📜</a:t>
             </a:r>
           </a:p>
         </p:txBody>
@@ -7244,663 +7354,271 @@
         </p:nvSpPr>
         <p:spPr>
           <a:xfrm>
-            <a:off x="731520" y="1600200"/>
-            <a:ext cx="3566160" cy="868680"/>
-          </a:xfrm>
-          <a:prstGeom prst="rect">
-            <a:avLst/>
-          </a:prstGeom>
-          <a:noFill/>
-        </p:spPr>
-        <p:txBody>
-          <a:bodyPr wrap="square">
-            <a:spAutoFit/>
-          </a:bodyPr>
-          <a:lstStyle/>
-          <a:p>
-            <a:pPr algn="l">
-              <a:spcAft>
-                <a:spcPts val="100"/>
-              </a:spcAft>
-            </a:pPr>
-            <a:r>
-              <a:rPr sz="1600" b="1">
-                <a:solidFill>
-                  <a:srgbClr val="1B5E20"/>
-                </a:solidFill>
-                <a:latin typeface="Georgia"/>
-              </a:rPr>
-              <a:t>🏈 Sports / Games</a:t>
-            </a:r>
-          </a:p>
-          <a:p>
-            <a:pPr algn="l">
-              <a:spcAft>
-                <a:spcPts val="600"/>
-              </a:spcAft>
-            </a:pPr>
-            <a:r>
-              <a:rPr sz="1200" b="0">
+            <a:off x="640080" y="1645920"/>
+            <a:ext cx="5486400" cy="4114800"/>
+          </a:xfrm>
+          <a:prstGeom prst="rect">
+            <a:avLst/>
+          </a:prstGeom>
+          <a:noFill/>
+        </p:spPr>
+        <p:txBody>
+          <a:bodyPr wrap="square">
+            <a:spAutoFit/>
+          </a:bodyPr>
+          <a:lstStyle/>
+          <a:p>
+            <a:pPr algn="l">
+              <a:spcAft>
+                <a:spcPts val="800"/>
+              </a:spcAft>
+            </a:pPr>
+            <a:r>
+              <a:rPr sz="1700" b="1">
+                <a:solidFill>
+                  <a:srgbClr val="2E7D32"/>
+                </a:solidFill>
+                <a:latin typeface="Georgia"/>
+              </a:rPr>
+              <a:t>Meetings stay fair, short &amp; drama-free</a:t>
+            </a:r>
+          </a:p>
+          <a:p>
+            <a:pPr algn="l">
+              <a:spcAft>
+                <a:spcPts val="600"/>
+              </a:spcAft>
+            </a:pPr>
+            <a:r>
+              <a:rPr sz="1500" b="0">
+                <a:solidFill>
+                  <a:srgbClr val="26221B"/>
+                </a:solidFill>
+                <a:latin typeface="Georgia"/>
+              </a:rPr>
+              <a:t>• Quorum — minimum members present to conduct business</a:t>
+            </a:r>
+          </a:p>
+          <a:p>
+            <a:pPr algn="l">
+              <a:spcAft>
+                <a:spcPts val="600"/>
+              </a:spcAft>
+            </a:pPr>
+            <a:r>
+              <a:rPr sz="1500" b="0">
+                <a:solidFill>
+                  <a:srgbClr val="26221B"/>
+                </a:solidFill>
+                <a:latin typeface="Georgia"/>
+              </a:rPr>
+              <a:t>• Motion — “I move that we…” puts an idea on the floor</a:t>
+            </a:r>
+          </a:p>
+          <a:p>
+            <a:pPr algn="l">
+              <a:spcAft>
+                <a:spcPts val="600"/>
+              </a:spcAft>
+            </a:pPr>
+            <a:r>
+              <a:rPr sz="1500" b="0">
+                <a:solidFill>
+                  <a:srgbClr val="26221B"/>
+                </a:solidFill>
+                <a:latin typeface="Georgia"/>
+              </a:rPr>
+              <a:t>• Second — one member seconds to open discussion</a:t>
+            </a:r>
+          </a:p>
+          <a:p>
+            <a:pPr algn="l">
+              <a:spcAft>
+                <a:spcPts val="600"/>
+              </a:spcAft>
+            </a:pPr>
+            <a:r>
+              <a:rPr sz="1500" b="0">
+                <a:solidFill>
+                  <a:srgbClr val="26221B"/>
+                </a:solidFill>
+                <a:latin typeface="Georgia"/>
+              </a:rPr>
+              <a:t>• Discussion — the chair recognizes speakers in turn</a:t>
+            </a:r>
+          </a:p>
+          <a:p>
+            <a:pPr algn="l">
+              <a:spcAft>
+                <a:spcPts val="600"/>
+              </a:spcAft>
+            </a:pPr>
+            <a:r>
+              <a:rPr sz="1500" b="0">
+                <a:solidFill>
+                  <a:srgbClr val="26221B"/>
+                </a:solidFill>
+                <a:latin typeface="Georgia"/>
+              </a:rPr>
+              <a:t>• Vote — majority carries; the Secretary records it</a:t>
+            </a:r>
+          </a:p>
+        </p:txBody>
+      </p:sp>
+      <p:sp>
+        <p:nvSpPr>
+          <p:cNvPr id="5" name="TextBox 4"/>
+          <p:cNvSpPr txBox="1"/>
+          <p:nvPr/>
+        </p:nvSpPr>
+        <p:spPr>
+          <a:xfrm>
+            <a:off x="6400800" y="1645920"/>
+            <a:ext cx="5120640" cy="4114800"/>
+          </a:xfrm>
+          <a:prstGeom prst="rect">
+            <a:avLst/>
+          </a:prstGeom>
+          <a:noFill/>
+        </p:spPr>
+        <p:txBody>
+          <a:bodyPr wrap="square">
+            <a:spAutoFit/>
+          </a:bodyPr>
+          <a:lstStyle/>
+          <a:p>
+            <a:pPr algn="l">
+              <a:spcAft>
+                <a:spcPts val="800"/>
+              </a:spcAft>
+            </a:pPr>
+            <a:r>
+              <a:rPr sz="1700" b="1">
+                <a:solidFill>
+                  <a:srgbClr val="E65100"/>
+                </a:solidFill>
+                <a:latin typeface="Georgia"/>
+              </a:rPr>
+              <a:t>Cheat sheet — what do I say?</a:t>
+            </a:r>
+          </a:p>
+          <a:p>
+            <a:pPr algn="l">
+              <a:spcAft>
+                <a:spcPts val="600"/>
+              </a:spcAft>
+            </a:pPr>
+            <a:r>
+              <a:rPr sz="1500" b="0">
+                <a:solidFill>
+                  <a:srgbClr val="26221B"/>
+                </a:solidFill>
+                <a:latin typeface="Georgia"/>
+              </a:rPr>
+              <a:t>• Propose → “I move that…”</a:t>
+            </a:r>
+          </a:p>
+          <a:p>
+            <a:pPr algn="l">
+              <a:spcAft>
+                <a:spcPts val="600"/>
+              </a:spcAft>
+            </a:pPr>
+            <a:r>
+              <a:rPr sz="1500" b="0">
+                <a:solidFill>
+                  <a:srgbClr val="26221B"/>
+                </a:solidFill>
+                <a:latin typeface="Georgia"/>
+              </a:rPr>
+              <a:t>• Support → “Second!”</a:t>
+            </a:r>
+          </a:p>
+          <a:p>
+            <a:pPr algn="l">
+              <a:spcAft>
+                <a:spcPts val="600"/>
+              </a:spcAft>
+            </a:pPr>
+            <a:r>
+              <a:rPr sz="1500" b="0">
+                <a:solidFill>
+                  <a:srgbClr val="26221B"/>
+                </a:solidFill>
+                <a:latin typeface="Georgia"/>
+              </a:rPr>
+              <a:t>• Change wording → “I move to amend…”</a:t>
+            </a:r>
+          </a:p>
+          <a:p>
+            <a:pPr algn="l">
+              <a:spcAft>
+                <a:spcPts val="600"/>
+              </a:spcAft>
+            </a:pPr>
+            <a:r>
+              <a:rPr sz="1500" b="0">
+                <a:solidFill>
+                  <a:srgbClr val="26221B"/>
+                </a:solidFill>
+                <a:latin typeface="Georgia"/>
+              </a:rPr>
+              <a:t>• End debate → “I move the previous question”</a:t>
+            </a:r>
+          </a:p>
+          <a:p>
+            <a:pPr algn="l">
+              <a:spcAft>
+                <a:spcPts val="600"/>
+              </a:spcAft>
+            </a:pPr>
+            <a:r>
+              <a:rPr sz="1500" b="0">
+                <a:solidFill>
+                  <a:srgbClr val="26221B"/>
+                </a:solidFill>
+                <a:latin typeface="Georgia"/>
+              </a:rPr>
+              <a:t>• Wrap up → “I move to adjourn”</a:t>
+            </a:r>
+          </a:p>
+        </p:txBody>
+      </p:sp>
+      <p:sp>
+        <p:nvSpPr>
+          <p:cNvPr id="6" name="TextBox 5"/>
+          <p:cNvSpPr txBox="1"/>
+          <p:nvPr/>
+        </p:nvSpPr>
+        <p:spPr>
+          <a:xfrm>
+            <a:off x="640080" y="6291072"/>
+            <a:ext cx="10911535" cy="457200"/>
+          </a:xfrm>
+          <a:prstGeom prst="rect">
+            <a:avLst/>
+          </a:prstGeom>
+          <a:noFill/>
+        </p:spPr>
+        <p:txBody>
+          <a:bodyPr wrap="square">
+            <a:spAutoFit/>
+          </a:bodyPr>
+          <a:lstStyle/>
+          <a:p>
+            <a:pPr algn="l">
+              <a:spcAft>
+                <a:spcPts val="600"/>
+              </a:spcAft>
+            </a:pPr>
+            <a:r>
+              <a:rPr sz="1100" b="0">
                 <a:solidFill>
                   <a:srgbClr val="6B6355"/>
                 </a:solidFill>
-                <a:latin typeface="Georgia"/>
-              </a:rPr>
-              <a:t>Chair: [sign up] · Members: [sign up]</a:t>
-            </a:r>
-          </a:p>
-        </p:txBody>
-      </p:sp>
-      <p:sp>
-        <p:nvSpPr>
-          <p:cNvPr id="5" name="TextBox 4"/>
-          <p:cNvSpPr txBox="1"/>
-          <p:nvPr/>
-        </p:nvSpPr>
-        <p:spPr>
-          <a:xfrm>
-            <a:off x="4480559" y="1600200"/>
-            <a:ext cx="3566160" cy="868680"/>
-          </a:xfrm>
-          <a:prstGeom prst="rect">
-            <a:avLst/>
-          </a:prstGeom>
-          <a:noFill/>
-        </p:spPr>
-        <p:txBody>
-          <a:bodyPr wrap="square">
-            <a:spAutoFit/>
-          </a:bodyPr>
-          <a:lstStyle/>
-          <a:p>
-            <a:pPr algn="l">
-              <a:spcAft>
-                <a:spcPts val="100"/>
-              </a:spcAft>
-            </a:pPr>
-            <a:r>
-              <a:rPr sz="1600" b="1">
-                <a:solidFill>
-                  <a:srgbClr val="1B5E20"/>
-                </a:solidFill>
-                <a:latin typeface="Georgia"/>
-              </a:rPr>
-              <a:t>🎶 Music</a:t>
-            </a:r>
-          </a:p>
-          <a:p>
-            <a:pPr algn="l">
-              <a:spcAft>
-                <a:spcPts val="600"/>
-              </a:spcAft>
-            </a:pPr>
-            <a:r>
-              <a:rPr sz="1200" b="0">
-                <a:solidFill>
-                  <a:srgbClr val="6B6355"/>
-                </a:solidFill>
-                <a:latin typeface="Georgia"/>
-              </a:rPr>
-              <a:t>Chair: [sign up] · Members: [sign up]</a:t>
-            </a:r>
-          </a:p>
-        </p:txBody>
-      </p:sp>
-      <p:sp>
-        <p:nvSpPr>
-          <p:cNvPr id="6" name="TextBox 5"/>
-          <p:cNvSpPr txBox="1"/>
-          <p:nvPr/>
-        </p:nvSpPr>
-        <p:spPr>
-          <a:xfrm>
-            <a:off x="8229600" y="1600200"/>
-            <a:ext cx="3566160" cy="868680"/>
-          </a:xfrm>
-          <a:prstGeom prst="rect">
-            <a:avLst/>
-          </a:prstGeom>
-          <a:noFill/>
-        </p:spPr>
-        <p:txBody>
-          <a:bodyPr wrap="square">
-            <a:spAutoFit/>
-          </a:bodyPr>
-          <a:lstStyle/>
-          <a:p>
-            <a:pPr algn="l">
-              <a:spcAft>
-                <a:spcPts val="100"/>
-              </a:spcAft>
-            </a:pPr>
-            <a:r>
-              <a:rPr sz="1600" b="1">
-                <a:solidFill>
-                  <a:srgbClr val="1B5E20"/>
-                </a:solidFill>
-                <a:latin typeface="Georgia"/>
-              </a:rPr>
-              <a:t>🍽 Food</a:t>
-            </a:r>
-          </a:p>
-          <a:p>
-            <a:pPr algn="l">
-              <a:spcAft>
-                <a:spcPts val="600"/>
-              </a:spcAft>
-            </a:pPr>
-            <a:r>
-              <a:rPr sz="1200" b="0">
-                <a:solidFill>
-                  <a:srgbClr val="6B6355"/>
-                </a:solidFill>
-                <a:latin typeface="Georgia"/>
-              </a:rPr>
-              <a:t>Chair: [sign up] · Members: [sign up]</a:t>
-            </a:r>
-          </a:p>
-        </p:txBody>
-      </p:sp>
-      <p:sp>
-        <p:nvSpPr>
-          <p:cNvPr id="7" name="TextBox 6"/>
-          <p:cNvSpPr txBox="1"/>
-          <p:nvPr/>
-        </p:nvSpPr>
-        <p:spPr>
-          <a:xfrm>
-            <a:off x="731520" y="2560320"/>
-            <a:ext cx="3566160" cy="868680"/>
-          </a:xfrm>
-          <a:prstGeom prst="rect">
-            <a:avLst/>
-          </a:prstGeom>
-          <a:noFill/>
-        </p:spPr>
-        <p:txBody>
-          <a:bodyPr wrap="square">
-            <a:spAutoFit/>
-          </a:bodyPr>
-          <a:lstStyle/>
-          <a:p>
-            <a:pPr algn="l">
-              <a:spcAft>
-                <a:spcPts val="100"/>
-              </a:spcAft>
-            </a:pPr>
-            <a:r>
-              <a:rPr sz="1600" b="1">
-                <a:solidFill>
-                  <a:srgbClr val="1B5E20"/>
-                </a:solidFill>
-                <a:latin typeface="Georgia"/>
-              </a:rPr>
-              <a:t>🦺 Safety</a:t>
-            </a:r>
-          </a:p>
-          <a:p>
-            <a:pPr algn="l">
-              <a:spcAft>
-                <a:spcPts val="600"/>
-              </a:spcAft>
-            </a:pPr>
-            <a:r>
-              <a:rPr sz="1200" b="0">
-                <a:solidFill>
-                  <a:srgbClr val="6B6355"/>
-                </a:solidFill>
-                <a:latin typeface="Georgia"/>
-              </a:rPr>
-              <a:t>Chair: [sign up] · Members: [sign up]</a:t>
-            </a:r>
-          </a:p>
-        </p:txBody>
-      </p:sp>
-      <p:sp>
-        <p:nvSpPr>
-          <p:cNvPr id="8" name="TextBox 7"/>
-          <p:cNvSpPr txBox="1"/>
-          <p:nvPr/>
-        </p:nvSpPr>
-        <p:spPr>
-          <a:xfrm>
-            <a:off x="4480559" y="2560320"/>
-            <a:ext cx="3566160" cy="868680"/>
-          </a:xfrm>
-          <a:prstGeom prst="rect">
-            <a:avLst/>
-          </a:prstGeom>
-          <a:noFill/>
-        </p:spPr>
-        <p:txBody>
-          <a:bodyPr wrap="square">
-            <a:spAutoFit/>
-          </a:bodyPr>
-          <a:lstStyle/>
-          <a:p>
-            <a:pPr algn="l">
-              <a:spcAft>
-                <a:spcPts val="100"/>
-              </a:spcAft>
-            </a:pPr>
-            <a:r>
-              <a:rPr sz="1600" b="1">
-                <a:solidFill>
-                  <a:srgbClr val="1B5E20"/>
-                </a:solidFill>
-                <a:latin typeface="Georgia"/>
-              </a:rPr>
-              <a:t>🙏 Services</a:t>
-            </a:r>
-          </a:p>
-          <a:p>
-            <a:pPr algn="l">
-              <a:spcAft>
-                <a:spcPts val="600"/>
-              </a:spcAft>
-            </a:pPr>
-            <a:r>
-              <a:rPr sz="1200" b="0">
-                <a:solidFill>
-                  <a:srgbClr val="6B6355"/>
-                </a:solidFill>
-                <a:latin typeface="Georgia"/>
-              </a:rPr>
-              <a:t>Chair: [sign up] · Members: [sign up]</a:t>
-            </a:r>
-          </a:p>
-        </p:txBody>
-      </p:sp>
-      <p:sp>
-        <p:nvSpPr>
-          <p:cNvPr id="9" name="TextBox 8"/>
-          <p:cNvSpPr txBox="1"/>
-          <p:nvPr/>
-        </p:nvSpPr>
-        <p:spPr>
-          <a:xfrm>
-            <a:off x="8229600" y="2560320"/>
-            <a:ext cx="3566160" cy="868680"/>
-          </a:xfrm>
-          <a:prstGeom prst="rect">
-            <a:avLst/>
-          </a:prstGeom>
-          <a:noFill/>
-        </p:spPr>
-        <p:txBody>
-          <a:bodyPr wrap="square">
-            <a:spAutoFit/>
-          </a:bodyPr>
-          <a:lstStyle/>
-          <a:p>
-            <a:pPr algn="l">
-              <a:spcAft>
-                <a:spcPts val="100"/>
-              </a:spcAft>
-            </a:pPr>
-            <a:r>
-              <a:rPr sz="1600" b="1">
-                <a:solidFill>
-                  <a:srgbClr val="1B5E20"/>
-                </a:solidFill>
-                <a:latin typeface="Georgia"/>
-              </a:rPr>
-              <a:t>📸 Photography</a:t>
-            </a:r>
-          </a:p>
-          <a:p>
-            <a:pPr algn="l">
-              <a:spcAft>
-                <a:spcPts val="600"/>
-              </a:spcAft>
-            </a:pPr>
-            <a:r>
-              <a:rPr sz="1200" b="0">
-                <a:solidFill>
-                  <a:srgbClr val="6B6355"/>
-                </a:solidFill>
-                <a:latin typeface="Georgia"/>
-              </a:rPr>
-              <a:t>Chair: [sign up] · Members: [sign up]</a:t>
-            </a:r>
-          </a:p>
-        </p:txBody>
-      </p:sp>
-      <p:sp>
-        <p:nvSpPr>
-          <p:cNvPr id="10" name="TextBox 9"/>
-          <p:cNvSpPr txBox="1"/>
-          <p:nvPr/>
-        </p:nvSpPr>
-        <p:spPr>
-          <a:xfrm>
-            <a:off x="731520" y="3520440"/>
-            <a:ext cx="3566160" cy="868680"/>
-          </a:xfrm>
-          <a:prstGeom prst="rect">
-            <a:avLst/>
-          </a:prstGeom>
-          <a:noFill/>
-        </p:spPr>
-        <p:txBody>
-          <a:bodyPr wrap="square">
-            <a:spAutoFit/>
-          </a:bodyPr>
-          <a:lstStyle/>
-          <a:p>
-            <a:pPr algn="l">
-              <a:spcAft>
-                <a:spcPts val="100"/>
-              </a:spcAft>
-            </a:pPr>
-            <a:r>
-              <a:rPr sz="1600" b="1">
-                <a:solidFill>
-                  <a:srgbClr val="1B5E20"/>
-                </a:solidFill>
-                <a:latin typeface="Georgia"/>
-              </a:rPr>
-              <a:t>💝 Philanthropy &amp; Fundraising</a:t>
-            </a:r>
-          </a:p>
-          <a:p>
-            <a:pPr algn="l">
-              <a:spcAft>
-                <a:spcPts val="600"/>
-              </a:spcAft>
-            </a:pPr>
-            <a:r>
-              <a:rPr sz="1200" b="0">
-                <a:solidFill>
-                  <a:srgbClr val="6B6355"/>
-                </a:solidFill>
-                <a:latin typeface="Georgia"/>
-              </a:rPr>
-              <a:t>Chair: [sign up] · Members: [sign up]</a:t>
-            </a:r>
-          </a:p>
-        </p:txBody>
-      </p:sp>
-      <p:sp>
-        <p:nvSpPr>
-          <p:cNvPr id="11" name="TextBox 10"/>
-          <p:cNvSpPr txBox="1"/>
-          <p:nvPr/>
-        </p:nvSpPr>
-        <p:spPr>
-          <a:xfrm>
-            <a:off x="4480559" y="3520440"/>
-            <a:ext cx="3566160" cy="868680"/>
-          </a:xfrm>
-          <a:prstGeom prst="rect">
-            <a:avLst/>
-          </a:prstGeom>
-          <a:noFill/>
-        </p:spPr>
-        <p:txBody>
-          <a:bodyPr wrap="square">
-            <a:spAutoFit/>
-          </a:bodyPr>
-          <a:lstStyle/>
-          <a:p>
-            <a:pPr algn="l">
-              <a:spcAft>
-                <a:spcPts val="100"/>
-              </a:spcAft>
-            </a:pPr>
-            <a:r>
-              <a:rPr sz="1600" b="1">
-                <a:solidFill>
-                  <a:srgbClr val="1B5E20"/>
-                </a:solidFill>
-                <a:latin typeface="Georgia"/>
-              </a:rPr>
-              <a:t>🗓 Planning</a:t>
-            </a:r>
-          </a:p>
-          <a:p>
-            <a:pPr algn="l">
-              <a:spcAft>
-                <a:spcPts val="600"/>
-              </a:spcAft>
-            </a:pPr>
-            <a:r>
-              <a:rPr sz="1200" b="0">
-                <a:solidFill>
-                  <a:srgbClr val="6B6355"/>
-                </a:solidFill>
-                <a:latin typeface="Georgia"/>
-              </a:rPr>
-              <a:t>Chair: [sign up] · Members: [sign up]</a:t>
-            </a:r>
-          </a:p>
-        </p:txBody>
-      </p:sp>
-      <p:sp>
-        <p:nvSpPr>
-          <p:cNvPr id="12" name="TextBox 11"/>
-          <p:cNvSpPr txBox="1"/>
-          <p:nvPr/>
-        </p:nvSpPr>
-        <p:spPr>
-          <a:xfrm>
-            <a:off x="8229600" y="3520440"/>
-            <a:ext cx="3566160" cy="868680"/>
-          </a:xfrm>
-          <a:prstGeom prst="rect">
-            <a:avLst/>
-          </a:prstGeom>
-          <a:noFill/>
-        </p:spPr>
-        <p:txBody>
-          <a:bodyPr wrap="square">
-            <a:spAutoFit/>
-          </a:bodyPr>
-          <a:lstStyle/>
-          <a:p>
-            <a:pPr algn="l">
-              <a:spcAft>
-                <a:spcPts val="100"/>
-              </a:spcAft>
-            </a:pPr>
-            <a:r>
-              <a:rPr sz="1600" b="1">
-                <a:solidFill>
-                  <a:srgbClr val="1B5E20"/>
-                </a:solidFill>
-                <a:latin typeface="Georgia"/>
-              </a:rPr>
-              <a:t>💻 Technology</a:t>
-            </a:r>
-          </a:p>
-          <a:p>
-            <a:pPr algn="l">
-              <a:spcAft>
-                <a:spcPts val="600"/>
-              </a:spcAft>
-            </a:pPr>
-            <a:r>
-              <a:rPr sz="1200" b="0">
-                <a:solidFill>
-                  <a:srgbClr val="6B6355"/>
-                </a:solidFill>
-                <a:latin typeface="Georgia"/>
-              </a:rPr>
-              <a:t>Chair: [sign up] · Members: [sign up]</a:t>
-            </a:r>
-          </a:p>
-        </p:txBody>
-      </p:sp>
-      <p:sp>
-        <p:nvSpPr>
-          <p:cNvPr id="13" name="TextBox 12"/>
-          <p:cNvSpPr txBox="1"/>
-          <p:nvPr/>
-        </p:nvSpPr>
-        <p:spPr>
-          <a:xfrm>
-            <a:off x="640080" y="4572000"/>
-            <a:ext cx="5669280" cy="1828800"/>
-          </a:xfrm>
-          <a:prstGeom prst="rect">
-            <a:avLst/>
-          </a:prstGeom>
-          <a:noFill/>
-        </p:spPr>
-        <p:txBody>
-          <a:bodyPr wrap="square">
-            <a:spAutoFit/>
-          </a:bodyPr>
-          <a:lstStyle/>
-          <a:p>
-            <a:pPr algn="l">
-              <a:spcAft>
-                <a:spcPts val="800"/>
-              </a:spcAft>
-            </a:pPr>
-            <a:r>
-              <a:rPr sz="1500" b="1">
-                <a:solidFill>
-                  <a:srgbClr val="2E7D32"/>
-                </a:solidFill>
-                <a:latin typeface="Georgia"/>
-              </a:rPr>
-              <a:t>How committees operate</a:t>
-            </a:r>
-          </a:p>
-          <a:p>
-            <a:pPr algn="l">
-              <a:spcAft>
-                <a:spcPts val="600"/>
-              </a:spcAft>
-            </a:pPr>
-            <a:r>
-              <a:rPr sz="1300" b="0">
-                <a:solidFill>
-                  <a:srgbClr val="26221B"/>
-                </a:solidFill>
-                <a:latin typeface="Georgia"/>
-              </a:rPr>
-              <a:t>• Chairs appointed by the President, confirmed by member vote</a:t>
-            </a:r>
-          </a:p>
-          <a:p>
-            <a:pPr algn="l">
-              <a:spcAft>
-                <a:spcPts val="600"/>
-              </a:spcAft>
-            </a:pPr>
-            <a:r>
-              <a:rPr sz="1300" b="0">
-                <a:solidFill>
-                  <a:srgbClr val="26221B"/>
-                </a:solidFill>
-                <a:latin typeface="Georgia"/>
-              </a:rPr>
-              <a:t>• Meet monthly · report to the Vice President · 3-minute report each meeting</a:t>
-            </a:r>
-          </a:p>
-          <a:p>
-            <a:pPr algn="l">
-              <a:spcAft>
-                <a:spcPts val="600"/>
-              </a:spcAft>
-            </a:pPr>
-            <a:r>
-              <a:rPr sz="1300" b="0">
-                <a:solidFill>
-                  <a:srgbClr val="26221B"/>
-                </a:solidFill>
-                <a:latin typeface="Georgia"/>
-              </a:rPr>
-              <a:t>• Budget requests in writing to the Treasurer BEFORE spending</a:t>
-            </a:r>
-          </a:p>
-        </p:txBody>
-      </p:sp>
-      <p:sp>
-        <p:nvSpPr>
-          <p:cNvPr id="14" name="TextBox 13"/>
-          <p:cNvSpPr txBox="1"/>
-          <p:nvPr/>
-        </p:nvSpPr>
-        <p:spPr>
-          <a:xfrm>
-            <a:off x="6583680" y="4572000"/>
-            <a:ext cx="4937760" cy="1828800"/>
-          </a:xfrm>
-          <a:prstGeom prst="rect">
-            <a:avLst/>
-          </a:prstGeom>
-          <a:noFill/>
-        </p:spPr>
-        <p:txBody>
-          <a:bodyPr wrap="square">
-            <a:spAutoFit/>
-          </a:bodyPr>
-          <a:lstStyle/>
-          <a:p>
-            <a:pPr algn="l">
-              <a:spcAft>
-                <a:spcPts val="800"/>
-              </a:spcAft>
-            </a:pPr>
-            <a:r>
-              <a:rPr sz="1500" b="1">
-                <a:solidFill>
-                  <a:srgbClr val="E65100"/>
-                </a:solidFill>
-                <a:latin typeface="Georgia"/>
-              </a:rPr>
-              <a:t>Three ways to sign up</a:t>
-            </a:r>
-          </a:p>
-          <a:p>
-            <a:pPr algn="l">
-              <a:spcAft>
-                <a:spcPts val="600"/>
-              </a:spcAft>
-            </a:pPr>
-            <a:r>
-              <a:rPr sz="1300" b="0">
-                <a:solidFill>
-                  <a:srgbClr val="26221B"/>
-                </a:solidFill>
-                <a:latin typeface="Georgia"/>
-              </a:rPr>
-              <a:t>• Paper sheets at the welcome table (write your name under Chair or Member)</a:t>
-            </a:r>
-          </a:p>
-          <a:p>
-            <a:pPr algn="l">
-              <a:spcAft>
-                <a:spcPts val="600"/>
-              </a:spcAft>
-            </a:pPr>
-            <a:r>
-              <a:rPr sz="1300" b="0">
-                <a:solidFill>
-                  <a:srgbClr val="26221B"/>
-                </a:solidFill>
-                <a:latin typeface="Georgia"/>
-              </a:rPr>
-              <a:t>• Online: Committee Sign-Up form on hnfamilyreunion.com</a:t>
-            </a:r>
-          </a:p>
-          <a:p>
-            <a:pPr algn="l">
-              <a:spcAft>
-                <a:spcPts val="600"/>
-              </a:spcAft>
-            </a:pPr>
-            <a:r>
-              <a:rPr sz="1300" b="0">
-                <a:solidFill>
-                  <a:srgbClr val="26221B"/>
-                </a:solidFill>
-                <a:latin typeface="Georgia"/>
-              </a:rPr>
-              <a:t>• Right now: raise your hand when your committee is called</a:t>
+                <a:latin typeface="Verdana"/>
+              </a:rPr>
+              <a:t>Motion on today's agenda: adopt the Harris-Nelson Constitution &amp; Bylaws — membership, officers &amp; terms, quorum, dues, committees, amendments.</a:t>
             </a:r>
           </a:p>
         </p:txBody>
@@ -7965,7 +7683,7 @@
                 </a:solidFill>
                 <a:latin typeface="Verdana"/>
               </a:rPr>
-              <a:t>FAMILY BUSINESS · DECADE PLANNING</a:t>
+              <a:t>FAMILY BUSINESS · COMMITTEES</a:t>
             </a:r>
           </a:p>
         </p:txBody>
@@ -8004,7 +7722,7 @@
                 </a:solidFill>
                 <a:latin typeface="Georgia"/>
               </a:rPr>
-              <a:t>Where We Meet Next 🗺 — Halfway Between Jackson, MS &amp; Cleveland, OH</a:t>
+              <a:t>Committees Need Chairs — That Means YOU 🙋</a:t>
             </a:r>
           </a:p>
         </p:txBody>
@@ -8017,33 +7735,49 @@
         </p:nvSpPr>
         <p:spPr>
           <a:xfrm>
-            <a:off x="640080" y="1554480"/>
-            <a:ext cx="10911535" cy="548640"/>
-          </a:xfrm>
-          <a:prstGeom prst="rect">
-            <a:avLst/>
-          </a:prstGeom>
-          <a:noFill/>
-        </p:spPr>
-        <p:txBody>
-          <a:bodyPr wrap="square">
-            <a:spAutoFit/>
-          </a:bodyPr>
-          <a:lstStyle/>
-          <a:p>
-            <a:pPr algn="l">
-              <a:spcAft>
-                <a:spcPts val="600"/>
-              </a:spcAft>
-            </a:pPr>
-            <a:r>
-              <a:rPr sz="1500" b="0">
+            <a:off x="731520" y="1600200"/>
+            <a:ext cx="3566160" cy="868680"/>
+          </a:xfrm>
+          <a:prstGeom prst="rect">
+            <a:avLst/>
+          </a:prstGeom>
+          <a:noFill/>
+        </p:spPr>
+        <p:txBody>
+          <a:bodyPr wrap="square">
+            <a:spAutoFit/>
+          </a:bodyPr>
+          <a:lstStyle/>
+          <a:p>
+            <a:pPr algn="l">
+              <a:spcAft>
+                <a:spcPts val="100"/>
+              </a:spcAft>
+            </a:pPr>
+            <a:r>
+              <a:rPr sz="1600" b="1">
+                <a:solidFill>
+                  <a:srgbClr val="1B5E20"/>
+                </a:solidFill>
+                <a:latin typeface="Georgia"/>
+              </a:rPr>
+              <a:t>🏈 Sports / Games</a:t>
+            </a:r>
+          </a:p>
+          <a:p>
+            <a:pPr algn="l">
+              <a:spcAft>
+                <a:spcPts val="600"/>
+              </a:spcAft>
+            </a:pPr>
+            <a:r>
+              <a:rPr sz="1200" b="0">
                 <a:solidFill>
                   <a:srgbClr val="6B6355"/>
                 </a:solidFill>
                 <a:latin typeface="Georgia"/>
               </a:rPr>
-              <a:t>The drive is ~930 miles, so the halfway point lands around Nashville, TN / Bowling Green, KY.</a:t>
+              <a:t>Chair: [sign up] · Members: [sign up]</a:t>
             </a:r>
           </a:p>
         </p:txBody>
@@ -8056,8 +7790,448 @@
         </p:nvSpPr>
         <p:spPr>
           <a:xfrm>
-            <a:off x="640080" y="2194560"/>
-            <a:ext cx="3657600" cy="4114800"/>
+            <a:off x="4480559" y="1600200"/>
+            <a:ext cx="3566160" cy="868680"/>
+          </a:xfrm>
+          <a:prstGeom prst="rect">
+            <a:avLst/>
+          </a:prstGeom>
+          <a:noFill/>
+        </p:spPr>
+        <p:txBody>
+          <a:bodyPr wrap="square">
+            <a:spAutoFit/>
+          </a:bodyPr>
+          <a:lstStyle/>
+          <a:p>
+            <a:pPr algn="l">
+              <a:spcAft>
+                <a:spcPts val="100"/>
+              </a:spcAft>
+            </a:pPr>
+            <a:r>
+              <a:rPr sz="1600" b="1">
+                <a:solidFill>
+                  <a:srgbClr val="1B5E20"/>
+                </a:solidFill>
+                <a:latin typeface="Georgia"/>
+              </a:rPr>
+              <a:t>🎶 Music</a:t>
+            </a:r>
+          </a:p>
+          <a:p>
+            <a:pPr algn="l">
+              <a:spcAft>
+                <a:spcPts val="600"/>
+              </a:spcAft>
+            </a:pPr>
+            <a:r>
+              <a:rPr sz="1200" b="0">
+                <a:solidFill>
+                  <a:srgbClr val="6B6355"/>
+                </a:solidFill>
+                <a:latin typeface="Georgia"/>
+              </a:rPr>
+              <a:t>Chair: [sign up] · Members: [sign up]</a:t>
+            </a:r>
+          </a:p>
+        </p:txBody>
+      </p:sp>
+      <p:sp>
+        <p:nvSpPr>
+          <p:cNvPr id="6" name="TextBox 5"/>
+          <p:cNvSpPr txBox="1"/>
+          <p:nvPr/>
+        </p:nvSpPr>
+        <p:spPr>
+          <a:xfrm>
+            <a:off x="8229600" y="1600200"/>
+            <a:ext cx="3566160" cy="868680"/>
+          </a:xfrm>
+          <a:prstGeom prst="rect">
+            <a:avLst/>
+          </a:prstGeom>
+          <a:noFill/>
+        </p:spPr>
+        <p:txBody>
+          <a:bodyPr wrap="square">
+            <a:spAutoFit/>
+          </a:bodyPr>
+          <a:lstStyle/>
+          <a:p>
+            <a:pPr algn="l">
+              <a:spcAft>
+                <a:spcPts val="100"/>
+              </a:spcAft>
+            </a:pPr>
+            <a:r>
+              <a:rPr sz="1600" b="1">
+                <a:solidFill>
+                  <a:srgbClr val="1B5E20"/>
+                </a:solidFill>
+                <a:latin typeface="Georgia"/>
+              </a:rPr>
+              <a:t>🍽 Food</a:t>
+            </a:r>
+          </a:p>
+          <a:p>
+            <a:pPr algn="l">
+              <a:spcAft>
+                <a:spcPts val="600"/>
+              </a:spcAft>
+            </a:pPr>
+            <a:r>
+              <a:rPr sz="1200" b="0">
+                <a:solidFill>
+                  <a:srgbClr val="6B6355"/>
+                </a:solidFill>
+                <a:latin typeface="Georgia"/>
+              </a:rPr>
+              <a:t>Chair: [sign up] · Members: [sign up]</a:t>
+            </a:r>
+          </a:p>
+        </p:txBody>
+      </p:sp>
+      <p:sp>
+        <p:nvSpPr>
+          <p:cNvPr id="7" name="TextBox 6"/>
+          <p:cNvSpPr txBox="1"/>
+          <p:nvPr/>
+        </p:nvSpPr>
+        <p:spPr>
+          <a:xfrm>
+            <a:off x="731520" y="2560320"/>
+            <a:ext cx="3566160" cy="868680"/>
+          </a:xfrm>
+          <a:prstGeom prst="rect">
+            <a:avLst/>
+          </a:prstGeom>
+          <a:noFill/>
+        </p:spPr>
+        <p:txBody>
+          <a:bodyPr wrap="square">
+            <a:spAutoFit/>
+          </a:bodyPr>
+          <a:lstStyle/>
+          <a:p>
+            <a:pPr algn="l">
+              <a:spcAft>
+                <a:spcPts val="100"/>
+              </a:spcAft>
+            </a:pPr>
+            <a:r>
+              <a:rPr sz="1600" b="1">
+                <a:solidFill>
+                  <a:srgbClr val="1B5E20"/>
+                </a:solidFill>
+                <a:latin typeface="Georgia"/>
+              </a:rPr>
+              <a:t>🦺 Safety</a:t>
+            </a:r>
+          </a:p>
+          <a:p>
+            <a:pPr algn="l">
+              <a:spcAft>
+                <a:spcPts val="600"/>
+              </a:spcAft>
+            </a:pPr>
+            <a:r>
+              <a:rPr sz="1200" b="0">
+                <a:solidFill>
+                  <a:srgbClr val="6B6355"/>
+                </a:solidFill>
+                <a:latin typeface="Georgia"/>
+              </a:rPr>
+              <a:t>Chair: [sign up] · Members: [sign up]</a:t>
+            </a:r>
+          </a:p>
+        </p:txBody>
+      </p:sp>
+      <p:sp>
+        <p:nvSpPr>
+          <p:cNvPr id="8" name="TextBox 7"/>
+          <p:cNvSpPr txBox="1"/>
+          <p:nvPr/>
+        </p:nvSpPr>
+        <p:spPr>
+          <a:xfrm>
+            <a:off x="4480559" y="2560320"/>
+            <a:ext cx="3566160" cy="868680"/>
+          </a:xfrm>
+          <a:prstGeom prst="rect">
+            <a:avLst/>
+          </a:prstGeom>
+          <a:noFill/>
+        </p:spPr>
+        <p:txBody>
+          <a:bodyPr wrap="square">
+            <a:spAutoFit/>
+          </a:bodyPr>
+          <a:lstStyle/>
+          <a:p>
+            <a:pPr algn="l">
+              <a:spcAft>
+                <a:spcPts val="100"/>
+              </a:spcAft>
+            </a:pPr>
+            <a:r>
+              <a:rPr sz="1600" b="1">
+                <a:solidFill>
+                  <a:srgbClr val="1B5E20"/>
+                </a:solidFill>
+                <a:latin typeface="Georgia"/>
+              </a:rPr>
+              <a:t>🙏 Services</a:t>
+            </a:r>
+          </a:p>
+          <a:p>
+            <a:pPr algn="l">
+              <a:spcAft>
+                <a:spcPts val="600"/>
+              </a:spcAft>
+            </a:pPr>
+            <a:r>
+              <a:rPr sz="1200" b="0">
+                <a:solidFill>
+                  <a:srgbClr val="6B6355"/>
+                </a:solidFill>
+                <a:latin typeface="Georgia"/>
+              </a:rPr>
+              <a:t>Chair: [sign up] · Members: [sign up]</a:t>
+            </a:r>
+          </a:p>
+        </p:txBody>
+      </p:sp>
+      <p:sp>
+        <p:nvSpPr>
+          <p:cNvPr id="9" name="TextBox 8"/>
+          <p:cNvSpPr txBox="1"/>
+          <p:nvPr/>
+        </p:nvSpPr>
+        <p:spPr>
+          <a:xfrm>
+            <a:off x="8229600" y="2560320"/>
+            <a:ext cx="3566160" cy="868680"/>
+          </a:xfrm>
+          <a:prstGeom prst="rect">
+            <a:avLst/>
+          </a:prstGeom>
+          <a:noFill/>
+        </p:spPr>
+        <p:txBody>
+          <a:bodyPr wrap="square">
+            <a:spAutoFit/>
+          </a:bodyPr>
+          <a:lstStyle/>
+          <a:p>
+            <a:pPr algn="l">
+              <a:spcAft>
+                <a:spcPts val="100"/>
+              </a:spcAft>
+            </a:pPr>
+            <a:r>
+              <a:rPr sz="1600" b="1">
+                <a:solidFill>
+                  <a:srgbClr val="1B5E20"/>
+                </a:solidFill>
+                <a:latin typeface="Georgia"/>
+              </a:rPr>
+              <a:t>📸 Photography</a:t>
+            </a:r>
+          </a:p>
+          <a:p>
+            <a:pPr algn="l">
+              <a:spcAft>
+                <a:spcPts val="600"/>
+              </a:spcAft>
+            </a:pPr>
+            <a:r>
+              <a:rPr sz="1200" b="0">
+                <a:solidFill>
+                  <a:srgbClr val="6B6355"/>
+                </a:solidFill>
+                <a:latin typeface="Georgia"/>
+              </a:rPr>
+              <a:t>Chair: [sign up] · Members: [sign up]</a:t>
+            </a:r>
+          </a:p>
+        </p:txBody>
+      </p:sp>
+      <p:sp>
+        <p:nvSpPr>
+          <p:cNvPr id="10" name="TextBox 9"/>
+          <p:cNvSpPr txBox="1"/>
+          <p:nvPr/>
+        </p:nvSpPr>
+        <p:spPr>
+          <a:xfrm>
+            <a:off x="731520" y="3520440"/>
+            <a:ext cx="3566160" cy="868680"/>
+          </a:xfrm>
+          <a:prstGeom prst="rect">
+            <a:avLst/>
+          </a:prstGeom>
+          <a:noFill/>
+        </p:spPr>
+        <p:txBody>
+          <a:bodyPr wrap="square">
+            <a:spAutoFit/>
+          </a:bodyPr>
+          <a:lstStyle/>
+          <a:p>
+            <a:pPr algn="l">
+              <a:spcAft>
+                <a:spcPts val="100"/>
+              </a:spcAft>
+            </a:pPr>
+            <a:r>
+              <a:rPr sz="1600" b="1">
+                <a:solidFill>
+                  <a:srgbClr val="1B5E20"/>
+                </a:solidFill>
+                <a:latin typeface="Georgia"/>
+              </a:rPr>
+              <a:t>💝 Philanthropy &amp; Fundraising</a:t>
+            </a:r>
+          </a:p>
+          <a:p>
+            <a:pPr algn="l">
+              <a:spcAft>
+                <a:spcPts val="600"/>
+              </a:spcAft>
+            </a:pPr>
+            <a:r>
+              <a:rPr sz="1200" b="0">
+                <a:solidFill>
+                  <a:srgbClr val="6B6355"/>
+                </a:solidFill>
+                <a:latin typeface="Georgia"/>
+              </a:rPr>
+              <a:t>Chair: [sign up] · Members: [sign up]</a:t>
+            </a:r>
+          </a:p>
+        </p:txBody>
+      </p:sp>
+      <p:sp>
+        <p:nvSpPr>
+          <p:cNvPr id="11" name="TextBox 10"/>
+          <p:cNvSpPr txBox="1"/>
+          <p:nvPr/>
+        </p:nvSpPr>
+        <p:spPr>
+          <a:xfrm>
+            <a:off x="4480559" y="3520440"/>
+            <a:ext cx="3566160" cy="868680"/>
+          </a:xfrm>
+          <a:prstGeom prst="rect">
+            <a:avLst/>
+          </a:prstGeom>
+          <a:noFill/>
+        </p:spPr>
+        <p:txBody>
+          <a:bodyPr wrap="square">
+            <a:spAutoFit/>
+          </a:bodyPr>
+          <a:lstStyle/>
+          <a:p>
+            <a:pPr algn="l">
+              <a:spcAft>
+                <a:spcPts val="100"/>
+              </a:spcAft>
+            </a:pPr>
+            <a:r>
+              <a:rPr sz="1600" b="1">
+                <a:solidFill>
+                  <a:srgbClr val="1B5E20"/>
+                </a:solidFill>
+                <a:latin typeface="Georgia"/>
+              </a:rPr>
+              <a:t>🗓 Planning</a:t>
+            </a:r>
+          </a:p>
+          <a:p>
+            <a:pPr algn="l">
+              <a:spcAft>
+                <a:spcPts val="600"/>
+              </a:spcAft>
+            </a:pPr>
+            <a:r>
+              <a:rPr sz="1200" b="0">
+                <a:solidFill>
+                  <a:srgbClr val="6B6355"/>
+                </a:solidFill>
+                <a:latin typeface="Georgia"/>
+              </a:rPr>
+              <a:t>Chair: [sign up] · Members: [sign up]</a:t>
+            </a:r>
+          </a:p>
+        </p:txBody>
+      </p:sp>
+      <p:sp>
+        <p:nvSpPr>
+          <p:cNvPr id="12" name="TextBox 11"/>
+          <p:cNvSpPr txBox="1"/>
+          <p:nvPr/>
+        </p:nvSpPr>
+        <p:spPr>
+          <a:xfrm>
+            <a:off x="8229600" y="3520440"/>
+            <a:ext cx="3566160" cy="868680"/>
+          </a:xfrm>
+          <a:prstGeom prst="rect">
+            <a:avLst/>
+          </a:prstGeom>
+          <a:noFill/>
+        </p:spPr>
+        <p:txBody>
+          <a:bodyPr wrap="square">
+            <a:spAutoFit/>
+          </a:bodyPr>
+          <a:lstStyle/>
+          <a:p>
+            <a:pPr algn="l">
+              <a:spcAft>
+                <a:spcPts val="100"/>
+              </a:spcAft>
+            </a:pPr>
+            <a:r>
+              <a:rPr sz="1600" b="1">
+                <a:solidFill>
+                  <a:srgbClr val="1B5E20"/>
+                </a:solidFill>
+                <a:latin typeface="Georgia"/>
+              </a:rPr>
+              <a:t>💻 Technology</a:t>
+            </a:r>
+          </a:p>
+          <a:p>
+            <a:pPr algn="l">
+              <a:spcAft>
+                <a:spcPts val="600"/>
+              </a:spcAft>
+            </a:pPr>
+            <a:r>
+              <a:rPr sz="1200" b="0">
+                <a:solidFill>
+                  <a:srgbClr val="6B6355"/>
+                </a:solidFill>
+                <a:latin typeface="Georgia"/>
+              </a:rPr>
+              <a:t>Chair: [sign up] · Members: [sign up]</a:t>
+            </a:r>
+          </a:p>
+        </p:txBody>
+      </p:sp>
+      <p:sp>
+        <p:nvSpPr>
+          <p:cNvPr id="13" name="TextBox 12"/>
+          <p:cNvSpPr txBox="1"/>
+          <p:nvPr/>
+        </p:nvSpPr>
+        <p:spPr>
+          <a:xfrm>
+            <a:off x="640080" y="4572000"/>
+            <a:ext cx="5669280" cy="1828800"/>
           </a:xfrm>
           <a:prstGeom prst="rect">
             <a:avLst/>
@@ -8082,7 +8256,7 @@
                 </a:solidFill>
                 <a:latin typeface="Georgia"/>
               </a:rPr>
-              <a:t>🎯 At the halfway mark</a:t>
+              <a:t>How committees operate</a:t>
             </a:r>
           </a:p>
           <a:p>
@@ -8098,7 +8272,7 @@
                 </a:solidFill>
                 <a:latin typeface="Georgia"/>
               </a:rPr>
-              <a:t>• Montgomery Bell State Park — Burns, TN: 117 lakefront lodge rooms, 7,000+ sq ft event space</a:t>
+              <a:t>• Chairs appointed by the President, confirmed by member vote</a:t>
             </a:r>
           </a:p>
           <a:p>
@@ -8114,21 +8288,37 @@
                 </a:solidFill>
                 <a:latin typeface="Georgia"/>
               </a:rPr>
-              <a:t>• Barren River Lake State Resort Park — Bowling Green, KY: banquet room seats 224–400</a:t>
-            </a:r>
-          </a:p>
-        </p:txBody>
-      </p:sp>
-      <p:sp>
-        <p:nvSpPr>
-          <p:cNvPr id="6" name="TextBox 5"/>
-          <p:cNvSpPr txBox="1"/>
-          <p:nvPr/>
-        </p:nvSpPr>
-        <p:spPr>
-          <a:xfrm>
-            <a:off x="4434840" y="2194560"/>
-            <a:ext cx="3657600" cy="4114800"/>
+              <a:t>• Meet monthly · report to the Vice President · 3-minute report each meeting</a:t>
+            </a:r>
+          </a:p>
+          <a:p>
+            <a:pPr algn="l">
+              <a:spcAft>
+                <a:spcPts val="600"/>
+              </a:spcAft>
+            </a:pPr>
+            <a:r>
+              <a:rPr sz="1300" b="0">
+                <a:solidFill>
+                  <a:srgbClr val="26221B"/>
+                </a:solidFill>
+                <a:latin typeface="Georgia"/>
+              </a:rPr>
+              <a:t>• Budget requests in writing to the Treasurer BEFORE spending</a:t>
+            </a:r>
+          </a:p>
+        </p:txBody>
+      </p:sp>
+      <p:sp>
+        <p:nvSpPr>
+          <p:cNvPr id="14" name="TextBox 13"/>
+          <p:cNvSpPr txBox="1"/>
+          <p:nvPr/>
+        </p:nvSpPr>
+        <p:spPr>
+          <a:xfrm>
+            <a:off x="6583680" y="4572000"/>
+            <a:ext cx="4937760" cy="1828800"/>
           </a:xfrm>
           <a:prstGeom prst="rect">
             <a:avLst/>
@@ -8153,7 +8343,7 @@
                 </a:solidFill>
                 <a:latin typeface="Georgia"/>
               </a:rPr>
-              <a:t>🚗 Along the route</a:t>
+              <a:t>Three ways to sign up</a:t>
             </a:r>
           </a:p>
           <a:p>
@@ -8169,7 +8359,7 @@
                 </a:solidFill>
                 <a:latin typeface="Georgia"/>
               </a:rPr>
-              <a:t>• Kentucky Dam Village State Resort Park — Gilbertsville, KY</a:t>
+              <a:t>• Paper sheets at the welcome table (write your name under Chair or Member)</a:t>
             </a:r>
           </a:p>
           <a:p>
@@ -8185,7 +8375,7 @@
                 </a:solidFill>
                 <a:latin typeface="Georgia"/>
               </a:rPr>
-              <a:t>• General Butler State Resort Park — off I-71, Louisville↔Cincinnati</a:t>
+              <a:t>• Online: Committee Sign-Up form on hnfamilyreunion.com</a:t>
             </a:r>
           </a:p>
           <a:p>
@@ -8201,149 +8391,7 @@
                 </a:solidFill>
                 <a:latin typeface="Georgia"/>
               </a:rPr>
-              <a:t>• Brown County / Abe Martin Lodge — IN (indoor water park!)</a:t>
-            </a:r>
-          </a:p>
-          <a:p>
-            <a:pPr algn="l">
-              <a:spcAft>
-                <a:spcPts val="600"/>
-              </a:spcAft>
-            </a:pPr>
-            <a:r>
-              <a:rPr sz="1300" b="0">
-                <a:solidFill>
-                  <a:srgbClr val="26221B"/>
-                </a:solidFill>
-                <a:latin typeface="Georgia"/>
-              </a:rPr>
-              <a:t>• Hueston Woods Lodge — College Corner, OH</a:t>
-            </a:r>
-          </a:p>
-        </p:txBody>
-      </p:sp>
-      <p:sp>
-        <p:nvSpPr>
-          <p:cNvPr id="7" name="TextBox 6"/>
-          <p:cNvSpPr txBox="1"/>
-          <p:nvPr/>
-        </p:nvSpPr>
-        <p:spPr>
-          <a:xfrm>
-            <a:off x="8229600" y="2194560"/>
-            <a:ext cx="3566160" cy="4114800"/>
-          </a:xfrm>
-          <a:prstGeom prst="rect">
-            <a:avLst/>
-          </a:prstGeom>
-          <a:noFill/>
-        </p:spPr>
-        <p:txBody>
-          <a:bodyPr wrap="square">
-            <a:spAutoFit/>
-          </a:bodyPr>
-          <a:lstStyle/>
-          <a:p>
-            <a:pPr algn="l">
-              <a:spcAft>
-                <a:spcPts val="800"/>
-              </a:spcAft>
-            </a:pPr>
-            <a:r>
-              <a:rPr sz="1500" b="1">
-                <a:solidFill>
-                  <a:srgbClr val="B71C1C"/>
-                </a:solidFill>
-                <a:latin typeface="Georgia"/>
-              </a:rPr>
-              <a:t>🏙 Closer to Cleveland</a:t>
-            </a:r>
-          </a:p>
-          <a:p>
-            <a:pPr algn="l">
-              <a:spcAft>
-                <a:spcPts val="600"/>
-              </a:spcAft>
-            </a:pPr>
-            <a:r>
-              <a:rPr sz="1300" b="0">
-                <a:solidFill>
-                  <a:srgbClr val="26221B"/>
-                </a:solidFill>
-                <a:latin typeface="Georgia"/>
-              </a:rPr>
-              <a:t>• Salt Fork State Park Lodge — Lore City, OH</a:t>
-            </a:r>
-          </a:p>
-          <a:p>
-            <a:pPr algn="l">
-              <a:spcAft>
-                <a:spcPts val="600"/>
-              </a:spcAft>
-            </a:pPr>
-            <a:r>
-              <a:rPr sz="1300" b="0">
-                <a:solidFill>
-                  <a:srgbClr val="26221B"/>
-                </a:solidFill>
-                <a:latin typeface="Georgia"/>
-              </a:rPr>
-              <a:t>• Punderson Manor Lodge — Newbury, OH</a:t>
-            </a:r>
-          </a:p>
-          <a:p>
-            <a:pPr algn="l">
-              <a:spcAft>
-                <a:spcPts val="600"/>
-              </a:spcAft>
-            </a:pPr>
-            <a:r>
-              <a:rPr sz="1300" b="0">
-                <a:solidFill>
-                  <a:srgbClr val="26221B"/>
-                </a:solidFill>
-                <a:latin typeface="Georgia"/>
-              </a:rPr>
-              <a:t>• The Lodge at Geneva-on-the-Lake — Lake Erie shore</a:t>
-            </a:r>
-          </a:p>
-        </p:txBody>
-      </p:sp>
-      <p:sp>
-        <p:nvSpPr>
-          <p:cNvPr id="8" name="TextBox 7"/>
-          <p:cNvSpPr txBox="1"/>
-          <p:nvPr/>
-        </p:nvSpPr>
-        <p:spPr>
-          <a:xfrm>
-            <a:off x="640080" y="6291072"/>
-            <a:ext cx="10911535" cy="457200"/>
-          </a:xfrm>
-          <a:prstGeom prst="rect">
-            <a:avLst/>
-          </a:prstGeom>
-          <a:noFill/>
-        </p:spPr>
-        <p:txBody>
-          <a:bodyPr wrap="square">
-            <a:spAutoFit/>
-          </a:bodyPr>
-          <a:lstStyle/>
-          <a:p>
-            <a:pPr algn="l">
-              <a:spcAft>
-                <a:spcPts val="600"/>
-              </a:spcAft>
-            </a:pPr>
-            <a:r>
-              <a:rPr sz="1100" b="0">
-                <a:solidFill>
-                  <a:srgbClr val="6B6355"/>
-                </a:solidFill>
-                <a:latin typeface="Verdana"/>
-              </a:rPr>
-              <a:t>The Planning Committee gets group-rate quotes from the top three picks; we choose by member vote. Decade planning = we rotate.</a:t>
+              <a:t>• Right now: raise your hand when your committee is called</a:t>
             </a:r>
           </a:p>
         </p:txBody>
@@ -8653,7 +8701,7 @@
                 </a:solidFill>
                 <a:latin typeface="Georgia"/>
               </a:rPr>
-              <a:t>10.  Committees &amp; Chair Sign-Ups</a:t>
+              <a:t>10.  Board Recognition, Committees &amp; Sign-Ups</a:t>
             </a:r>
           </a:p>
           <a:p>
@@ -8733,7 +8781,7 @@
                 </a:solidFill>
                 <a:latin typeface="Georgia"/>
               </a:rPr>
-              <a:t>15.  The Family Foundation — Our 501(c)(3)</a:t>
+              <a:t>15.  Helping Hands — Family Hardship Fund</a:t>
             </a:r>
           </a:p>
           <a:p>
@@ -8749,7 +8797,7 @@
                 </a:solidFill>
                 <a:latin typeface="Georgia"/>
               </a:rPr>
-              <a:t>16.  The Family Tree Project — Add Yourself!</a:t>
+              <a:t>16.  The Family Foundation — Our 501(c)(3)</a:t>
             </a:r>
           </a:p>
           <a:p>
@@ -8765,7 +8813,23 @@
                 </a:solidFill>
                 <a:latin typeface="Georgia"/>
               </a:rPr>
-              <a:t>17.  Closing &amp; Next Steps</a:t>
+              <a:t>17.  The Family Tree Project — Add Yourself!</a:t>
+            </a:r>
+          </a:p>
+          <a:p>
+            <a:pPr algn="l">
+              <a:spcAft>
+                <a:spcPts val="1000"/>
+              </a:spcAft>
+            </a:pPr>
+            <a:r>
+              <a:rPr sz="1600" b="0">
+                <a:solidFill>
+                  <a:srgbClr val="26221B"/>
+                </a:solidFill>
+                <a:latin typeface="Georgia"/>
+              </a:rPr>
+              <a:t>18.  Closing &amp; Next Steps</a:t>
             </a:r>
           </a:p>
         </p:txBody>
@@ -8830,7 +8894,7 @@
                 </a:solidFill>
                 <a:latin typeface="Verdana"/>
               </a:rPr>
-              <a:t>FAMILY BUSINESS · TECHNOLOGY</a:t>
+              <a:t>FAMILY BUSINESS · DECADE PLANNING</a:t>
             </a:r>
           </a:p>
         </p:txBody>
@@ -8869,7 +8933,7 @@
                 </a:solidFill>
                 <a:latin typeface="Georgia"/>
               </a:rPr>
-              <a:t>Our New Home Online: hnfamilyreunion.com 💻</a:t>
+              <a:t>Where We Meet Next 🗺 — Halfway Between Jackson, MS &amp; Cleveland, OH</a:t>
             </a:r>
           </a:p>
         </p:txBody>
@@ -8882,7 +8946,46 @@
         </p:nvSpPr>
         <p:spPr>
           <a:xfrm>
-            <a:off x="640080" y="1737360"/>
+            <a:off x="640080" y="1554480"/>
+            <a:ext cx="10911535" cy="548640"/>
+          </a:xfrm>
+          <a:prstGeom prst="rect">
+            <a:avLst/>
+          </a:prstGeom>
+          <a:noFill/>
+        </p:spPr>
+        <p:txBody>
+          <a:bodyPr wrap="square">
+            <a:spAutoFit/>
+          </a:bodyPr>
+          <a:lstStyle/>
+          <a:p>
+            <a:pPr algn="l">
+              <a:spcAft>
+                <a:spcPts val="600"/>
+              </a:spcAft>
+            </a:pPr>
+            <a:r>
+              <a:rPr sz="1500" b="0">
+                <a:solidFill>
+                  <a:srgbClr val="6B6355"/>
+                </a:solidFill>
+                <a:latin typeface="Georgia"/>
+              </a:rPr>
+              <a:t>The drive is ~930 miles, so the halfway point lands around Nashville, TN / Bowling Green, KY.</a:t>
+            </a:r>
+          </a:p>
+        </p:txBody>
+      </p:sp>
+      <p:sp>
+        <p:nvSpPr>
+          <p:cNvPr id="5" name="TextBox 4"/>
+          <p:cNvSpPr txBox="1"/>
+          <p:nvPr/>
+        </p:nvSpPr>
+        <p:spPr>
+          <a:xfrm>
+            <a:off x="640080" y="2194560"/>
             <a:ext cx="3657600" cy="4114800"/>
           </a:xfrm>
           <a:prstGeom prst="rect">
@@ -8902,90 +9005,58 @@
               </a:spcAft>
             </a:pPr>
             <a:r>
-              <a:rPr sz="1600" b="1">
+              <a:rPr sz="1500" b="1">
                 <a:solidFill>
                   <a:srgbClr val="2E7D32"/>
                 </a:solidFill>
                 <a:latin typeface="Georgia"/>
               </a:rPr>
-              <a:t>Everything reunion</a:t>
-            </a:r>
-          </a:p>
-          <a:p>
-            <a:pPr algn="l">
-              <a:spcAft>
-                <a:spcPts val="600"/>
-              </a:spcAft>
-            </a:pPr>
-            <a:r>
-              <a:rPr sz="1400" b="0">
-                <a:solidFill>
-                  <a:srgbClr val="26221B"/>
-                </a:solidFill>
-                <a:latin typeface="Georgia"/>
-              </a:rPr>
-              <a:t>• Announcements &amp; event schedule</a:t>
-            </a:r>
-          </a:p>
-          <a:p>
-            <a:pPr algn="l">
-              <a:spcAft>
-                <a:spcPts val="600"/>
-              </a:spcAft>
-            </a:pPr>
-            <a:r>
-              <a:rPr sz="1400" b="0">
-                <a:solidFill>
-                  <a:srgbClr val="26221B"/>
-                </a:solidFill>
-                <a:latin typeface="Georgia"/>
-              </a:rPr>
-              <a:t>• Family history &amp; photo gallery</a:t>
-            </a:r>
-          </a:p>
-          <a:p>
-            <a:pPr algn="l">
-              <a:spcAft>
-                <a:spcPts val="600"/>
-              </a:spcAft>
-            </a:pPr>
-            <a:r>
-              <a:rPr sz="1400" b="0">
-                <a:solidFill>
-                  <a:srgbClr val="26221B"/>
-                </a:solidFill>
-                <a:latin typeface="Georgia"/>
-              </a:rPr>
-              <a:t>• 2024 slideshow &amp; yearbook archive</a:t>
-            </a:r>
-          </a:p>
-          <a:p>
-            <a:pPr algn="l">
-              <a:spcAft>
-                <a:spcPts val="600"/>
-              </a:spcAft>
-            </a:pPr>
-            <a:r>
-              <a:rPr sz="1400" b="0">
-                <a:solidFill>
-                  <a:srgbClr val="26221B"/>
-                </a:solidFill>
-                <a:latin typeface="Georgia"/>
-              </a:rPr>
-              <a:t>• Memorial page</a:t>
-            </a:r>
-          </a:p>
-        </p:txBody>
-      </p:sp>
-      <p:sp>
-        <p:nvSpPr>
-          <p:cNvPr id="5" name="TextBox 4"/>
-          <p:cNvSpPr txBox="1"/>
-          <p:nvPr/>
-        </p:nvSpPr>
-        <p:spPr>
-          <a:xfrm>
-            <a:off x="4434840" y="1737360"/>
+              <a:t>🎯 At the halfway mark</a:t>
+            </a:r>
+          </a:p>
+          <a:p>
+            <a:pPr algn="l">
+              <a:spcAft>
+                <a:spcPts val="600"/>
+              </a:spcAft>
+            </a:pPr>
+            <a:r>
+              <a:rPr sz="1300" b="0">
+                <a:solidFill>
+                  <a:srgbClr val="26221B"/>
+                </a:solidFill>
+                <a:latin typeface="Georgia"/>
+              </a:rPr>
+              <a:t>• Montgomery Bell State Park — Burns, TN: 117 lakefront lodge rooms, 7,000+ sq ft event space</a:t>
+            </a:r>
+          </a:p>
+          <a:p>
+            <a:pPr algn="l">
+              <a:spcAft>
+                <a:spcPts val="600"/>
+              </a:spcAft>
+            </a:pPr>
+            <a:r>
+              <a:rPr sz="1300" b="0">
+                <a:solidFill>
+                  <a:srgbClr val="26221B"/>
+                </a:solidFill>
+                <a:latin typeface="Georgia"/>
+              </a:rPr>
+              <a:t>• Barren River Lake State Resort Park — Bowling Green, KY: banquet room seats 224–400</a:t>
+            </a:r>
+          </a:p>
+        </p:txBody>
+      </p:sp>
+      <p:sp>
+        <p:nvSpPr>
+          <p:cNvPr id="6" name="TextBox 5"/>
+          <p:cNvSpPr txBox="1"/>
+          <p:nvPr/>
+        </p:nvSpPr>
+        <p:spPr>
+          <a:xfrm>
+            <a:off x="4434840" y="2194560"/>
             <a:ext cx="3657600" cy="4114800"/>
           </a:xfrm>
           <a:prstGeom prst="rect">
@@ -9005,74 +9076,90 @@
               </a:spcAft>
             </a:pPr>
             <a:r>
-              <a:rPr sz="1600" b="1">
+              <a:rPr sz="1500" b="1">
                 <a:solidFill>
                   <a:srgbClr val="E65100"/>
                 </a:solidFill>
                 <a:latin typeface="Georgia"/>
               </a:rPr>
-              <a:t>Payments &amp; shop</a:t>
-            </a:r>
-          </a:p>
-          <a:p>
-            <a:pPr algn="l">
-              <a:spcAft>
-                <a:spcPts val="600"/>
-              </a:spcAft>
-            </a:pPr>
-            <a:r>
-              <a:rPr sz="1400" b="0">
-                <a:solidFill>
-                  <a:srgbClr val="26221B"/>
-                </a:solidFill>
-                <a:latin typeface="Georgia"/>
-              </a:rPr>
-              <a:t>• Registration &amp; dues online</a:t>
-            </a:r>
-          </a:p>
-          <a:p>
-            <a:pPr algn="l">
-              <a:spcAft>
-                <a:spcPts val="600"/>
-              </a:spcAft>
-            </a:pPr>
-            <a:r>
-              <a:rPr sz="1400" b="0">
-                <a:solidFill>
-                  <a:srgbClr val="26221B"/>
-                </a:solidFill>
-                <a:latin typeface="Georgia"/>
-              </a:rPr>
-              <a:t>• T-shirt orders</a:t>
-            </a:r>
-          </a:p>
-          <a:p>
-            <a:pPr algn="l">
-              <a:spcAft>
-                <a:spcPts val="600"/>
-              </a:spcAft>
-            </a:pPr>
-            <a:r>
-              <a:rPr sz="1400" b="0">
-                <a:solidFill>
-                  <a:srgbClr val="26221B"/>
-                </a:solidFill>
-                <a:latin typeface="Georgia"/>
-              </a:rPr>
-              <a:t>• Donations to the Land &amp; Scholarship funds</a:t>
-            </a:r>
-          </a:p>
-        </p:txBody>
-      </p:sp>
-      <p:sp>
-        <p:nvSpPr>
-          <p:cNvPr id="6" name="TextBox 5"/>
-          <p:cNvSpPr txBox="1"/>
-          <p:nvPr/>
-        </p:nvSpPr>
-        <p:spPr>
-          <a:xfrm>
-            <a:off x="8229600" y="1737360"/>
+              <a:t>🚗 Along the route</a:t>
+            </a:r>
+          </a:p>
+          <a:p>
+            <a:pPr algn="l">
+              <a:spcAft>
+                <a:spcPts val="600"/>
+              </a:spcAft>
+            </a:pPr>
+            <a:r>
+              <a:rPr sz="1300" b="0">
+                <a:solidFill>
+                  <a:srgbClr val="26221B"/>
+                </a:solidFill>
+                <a:latin typeface="Georgia"/>
+              </a:rPr>
+              <a:t>• Kentucky Dam Village State Resort Park — Gilbertsville, KY</a:t>
+            </a:r>
+          </a:p>
+          <a:p>
+            <a:pPr algn="l">
+              <a:spcAft>
+                <a:spcPts val="600"/>
+              </a:spcAft>
+            </a:pPr>
+            <a:r>
+              <a:rPr sz="1300" b="0">
+                <a:solidFill>
+                  <a:srgbClr val="26221B"/>
+                </a:solidFill>
+                <a:latin typeface="Georgia"/>
+              </a:rPr>
+              <a:t>• General Butler State Resort Park — off I-71, Louisville↔Cincinnati</a:t>
+            </a:r>
+          </a:p>
+          <a:p>
+            <a:pPr algn="l">
+              <a:spcAft>
+                <a:spcPts val="600"/>
+              </a:spcAft>
+            </a:pPr>
+            <a:r>
+              <a:rPr sz="1300" b="0">
+                <a:solidFill>
+                  <a:srgbClr val="26221B"/>
+                </a:solidFill>
+                <a:latin typeface="Georgia"/>
+              </a:rPr>
+              <a:t>• Brown County / Abe Martin Lodge — IN (indoor water park!)</a:t>
+            </a:r>
+          </a:p>
+          <a:p>
+            <a:pPr algn="l">
+              <a:spcAft>
+                <a:spcPts val="600"/>
+              </a:spcAft>
+            </a:pPr>
+            <a:r>
+              <a:rPr sz="1300" b="0">
+                <a:solidFill>
+                  <a:srgbClr val="26221B"/>
+                </a:solidFill>
+                <a:latin typeface="Georgia"/>
+              </a:rPr>
+              <a:t>• Hueston Woods Lodge — College Corner, OH</a:t>
+            </a:r>
+          </a:p>
+        </p:txBody>
+      </p:sp>
+      <p:sp>
+        <p:nvSpPr>
+          <p:cNvPr id="7" name="TextBox 6"/>
+          <p:cNvSpPr txBox="1"/>
+          <p:nvPr/>
+        </p:nvSpPr>
+        <p:spPr>
+          <a:xfrm>
+            <a:off x="8229600" y="2194560"/>
             <a:ext cx="3566160" cy="4114800"/>
           </a:xfrm>
           <a:prstGeom prst="rect">
@@ -9092,84 +9179,68 @@
               </a:spcAft>
             </a:pPr>
             <a:r>
-              <a:rPr sz="1600" b="1">
+              <a:rPr sz="1500" b="1">
                 <a:solidFill>
                   <a:srgbClr val="B71C1C"/>
                 </a:solidFill>
                 <a:latin typeface="Georgia"/>
               </a:rPr>
-              <a:t>Get involved</a:t>
-            </a:r>
-          </a:p>
-          <a:p>
-            <a:pPr algn="l">
-              <a:spcAft>
-                <a:spcPts val="600"/>
-              </a:spcAft>
-            </a:pPr>
-            <a:r>
-              <a:rPr sz="1400" b="0">
-                <a:solidFill>
-                  <a:srgbClr val="26221B"/>
-                </a:solidFill>
-                <a:latin typeface="Georgia"/>
-              </a:rPr>
-              <a:t>• Committee &amp; chair sign-up</a:t>
-            </a:r>
-          </a:p>
-          <a:p>
-            <a:pPr algn="l">
-              <a:spcAft>
-                <a:spcPts val="600"/>
-              </a:spcAft>
-            </a:pPr>
-            <a:r>
-              <a:rPr sz="1400" b="0">
-                <a:solidFill>
-                  <a:srgbClr val="26221B"/>
-                </a:solidFill>
-                <a:latin typeface="Georgia"/>
-              </a:rPr>
-              <a:t>• Superlatives voting</a:t>
-            </a:r>
-          </a:p>
-          <a:p>
-            <a:pPr algn="l">
-              <a:spcAft>
-                <a:spcPts val="600"/>
-              </a:spcAft>
-            </a:pPr>
-            <a:r>
-              <a:rPr sz="1400" b="0">
-                <a:solidFill>
-                  <a:srgbClr val="26221B"/>
-                </a:solidFill>
-                <a:latin typeface="Georgia"/>
-              </a:rPr>
-              <a:t>• Family tree submission form</a:t>
-            </a:r>
-          </a:p>
-          <a:p>
-            <a:pPr algn="l">
-              <a:spcAft>
-                <a:spcPts val="600"/>
-              </a:spcAft>
-            </a:pPr>
-            <a:r>
-              <a:rPr sz="1400" b="0">
-                <a:solidFill>
-                  <a:srgbClr val="26221B"/>
-                </a:solidFill>
-                <a:latin typeface="Georgia"/>
-              </a:rPr>
-              <a:t>• Contact the officers</a:t>
-            </a:r>
-          </a:p>
-        </p:txBody>
-      </p:sp>
-      <p:sp>
-        <p:nvSpPr>
-          <p:cNvPr id="7" name="TextBox 6"/>
+              <a:t>🏙 Closer to Cleveland</a:t>
+            </a:r>
+          </a:p>
+          <a:p>
+            <a:pPr algn="l">
+              <a:spcAft>
+                <a:spcPts val="600"/>
+              </a:spcAft>
+            </a:pPr>
+            <a:r>
+              <a:rPr sz="1300" b="0">
+                <a:solidFill>
+                  <a:srgbClr val="26221B"/>
+                </a:solidFill>
+                <a:latin typeface="Georgia"/>
+              </a:rPr>
+              <a:t>• Salt Fork State Park Lodge — Lore City, OH</a:t>
+            </a:r>
+          </a:p>
+          <a:p>
+            <a:pPr algn="l">
+              <a:spcAft>
+                <a:spcPts val="600"/>
+              </a:spcAft>
+            </a:pPr>
+            <a:r>
+              <a:rPr sz="1300" b="0">
+                <a:solidFill>
+                  <a:srgbClr val="26221B"/>
+                </a:solidFill>
+                <a:latin typeface="Georgia"/>
+              </a:rPr>
+              <a:t>• Punderson Manor Lodge — Newbury, OH</a:t>
+            </a:r>
+          </a:p>
+          <a:p>
+            <a:pPr algn="l">
+              <a:spcAft>
+                <a:spcPts val="600"/>
+              </a:spcAft>
+            </a:pPr>
+            <a:r>
+              <a:rPr sz="1300" b="0">
+                <a:solidFill>
+                  <a:srgbClr val="26221B"/>
+                </a:solidFill>
+                <a:latin typeface="Georgia"/>
+              </a:rPr>
+              <a:t>• The Lodge at Geneva-on-the-Lake — Lake Erie shore</a:t>
+            </a:r>
+          </a:p>
+        </p:txBody>
+      </p:sp>
+      <p:sp>
+        <p:nvSpPr>
+          <p:cNvPr id="8" name="TextBox 7"/>
           <p:cNvSpPr txBox="1"/>
           <p:nvPr/>
         </p:nvSpPr>
@@ -9201,7 +9272,7 @@
                 </a:solidFill>
                 <a:latin typeface="Verdana"/>
               </a:rPr>
-              <a:t>The Technology Committee launches from starter code already written (in the family GitHub repo). Payments run through Zelle/Cash App and a secure processor — we never store card numbers.</a:t>
+              <a:t>The Planning Committee gets group-rate quotes from the top three picks; we choose by member vote. Decade planning = we rotate.</a:t>
             </a:r>
           </a:p>
         </p:txBody>
@@ -9266,7 +9337,7 @@
                 </a:solidFill>
                 <a:latin typeface="Verdana"/>
               </a:rPr>
-              <a:t>FAMILY BUSINESS · OUR LAND</a:t>
+              <a:t>FAMILY BUSINESS · TECHNOLOGY</a:t>
             </a:r>
           </a:p>
         </p:txBody>
@@ -9305,7 +9376,7 @@
                 </a:solidFill>
                 <a:latin typeface="Georgia"/>
               </a:rPr>
-              <a:t>Getting Our Family Land Back 🏡</a:t>
+              <a:t>Our New Home Online: hnfamilyreunion.com 💻</a:t>
             </a:r>
           </a:p>
         </p:txBody>
@@ -9318,57 +9389,97 @@
         </p:nvSpPr>
         <p:spPr>
           <a:xfrm>
-            <a:off x="640080" y="1645920"/>
-            <a:ext cx="5669280" cy="2377440"/>
-          </a:xfrm>
-          <a:prstGeom prst="rect">
-            <a:avLst/>
-          </a:prstGeom>
-          <a:noFill/>
-        </p:spPr>
-        <p:txBody>
-          <a:bodyPr wrap="square">
-            <a:spAutoFit/>
-          </a:bodyPr>
-          <a:lstStyle/>
-          <a:p>
-            <a:pPr algn="l">
-              <a:spcAft>
-                <a:spcPts val="1000"/>
-              </a:spcAft>
-            </a:pPr>
-            <a:r>
-              <a:rPr sz="1600" b="0">
-                <a:solidFill>
-                  <a:srgbClr val="26221B"/>
-                </a:solidFill>
-                <a:latin typeface="Georgia"/>
-              </a:rPr>
-              <a:t>We are partnering with Where Is My Land (whereismyland.com) — an organization that helps Black families research, document, and reclaim land that was taken from them.</a:t>
-            </a:r>
-          </a:p>
-          <a:p>
-            <a:pPr algn="l">
-              <a:spcAft>
-                <a:spcPts val="600"/>
-              </a:spcAft>
-            </a:pPr>
-            <a:r>
-              <a:rPr sz="1500" b="0">
-                <a:solidFill>
-                  <a:srgbClr val="26221B"/>
-                </a:solidFill>
-                <a:latin typeface="Georgia"/>
-              </a:rPr>
-              <a:t>Step 1: gather deeds, tax records &amp; oral history</a:t>
-            </a:r>
-            <a:br/>
-            <a:r>
-              <a:t>Step 2: fund the RETAINER through reunion fundraising</a:t>
-            </a:r>
-            <a:br/>
-            <a:r>
-              <a:t>Step 3: family volunteers support the research</a:t>
+            <a:off x="640080" y="1737360"/>
+            <a:ext cx="3657600" cy="4114800"/>
+          </a:xfrm>
+          <a:prstGeom prst="rect">
+            <a:avLst/>
+          </a:prstGeom>
+          <a:noFill/>
+        </p:spPr>
+        <p:txBody>
+          <a:bodyPr wrap="square">
+            <a:spAutoFit/>
+          </a:bodyPr>
+          <a:lstStyle/>
+          <a:p>
+            <a:pPr algn="l">
+              <a:spcAft>
+                <a:spcPts val="800"/>
+              </a:spcAft>
+            </a:pPr>
+            <a:r>
+              <a:rPr sz="1600" b="1">
+                <a:solidFill>
+                  <a:srgbClr val="2E7D32"/>
+                </a:solidFill>
+                <a:latin typeface="Georgia"/>
+              </a:rPr>
+              <a:t>Everything reunion</a:t>
+            </a:r>
+          </a:p>
+          <a:p>
+            <a:pPr algn="l">
+              <a:spcAft>
+                <a:spcPts val="600"/>
+              </a:spcAft>
+            </a:pPr>
+            <a:r>
+              <a:rPr sz="1400" b="0">
+                <a:solidFill>
+                  <a:srgbClr val="26221B"/>
+                </a:solidFill>
+                <a:latin typeface="Georgia"/>
+              </a:rPr>
+              <a:t>• Announcements &amp; event schedule</a:t>
+            </a:r>
+          </a:p>
+          <a:p>
+            <a:pPr algn="l">
+              <a:spcAft>
+                <a:spcPts val="600"/>
+              </a:spcAft>
+            </a:pPr>
+            <a:r>
+              <a:rPr sz="1400" b="0">
+                <a:solidFill>
+                  <a:srgbClr val="26221B"/>
+                </a:solidFill>
+                <a:latin typeface="Georgia"/>
+              </a:rPr>
+              <a:t>• Family history &amp; photo gallery</a:t>
+            </a:r>
+          </a:p>
+          <a:p>
+            <a:pPr algn="l">
+              <a:spcAft>
+                <a:spcPts val="600"/>
+              </a:spcAft>
+            </a:pPr>
+            <a:r>
+              <a:rPr sz="1400" b="0">
+                <a:solidFill>
+                  <a:srgbClr val="26221B"/>
+                </a:solidFill>
+                <a:latin typeface="Georgia"/>
+              </a:rPr>
+              <a:t>• 2024 slideshow &amp; yearbook archive</a:t>
+            </a:r>
+          </a:p>
+          <a:p>
+            <a:pPr algn="l">
+              <a:spcAft>
+                <a:spcPts val="600"/>
+              </a:spcAft>
+            </a:pPr>
+            <a:r>
+              <a:rPr sz="1400" b="0">
+                <a:solidFill>
+                  <a:srgbClr val="26221B"/>
+                </a:solidFill>
+                <a:latin typeface="Georgia"/>
+              </a:rPr>
+              <a:t>• Memorial page</a:t>
             </a:r>
           </a:p>
         </p:txBody>
@@ -9381,8 +9492,8 @@
         </p:nvSpPr>
         <p:spPr>
           <a:xfrm>
-            <a:off x="6583680" y="1645920"/>
-            <a:ext cx="4937760" cy="4114800"/>
+            <a:off x="4434840" y="1737360"/>
+            <a:ext cx="3657600" cy="4114800"/>
           </a:xfrm>
           <a:prstGeom prst="rect">
             <a:avLst/>
@@ -9401,77 +9512,61 @@
               </a:spcAft>
             </a:pPr>
             <a:r>
-              <a:rPr sz="1700" b="1">
+              <a:rPr sz="1600" b="1">
                 <a:solidFill>
                   <a:srgbClr val="E65100"/>
                 </a:solidFill>
                 <a:latin typeface="Georgia"/>
               </a:rPr>
-              <a:t>How fundraising is split</a:t>
-            </a:r>
-          </a:p>
-          <a:p>
-            <a:pPr algn="l">
-              <a:spcAft>
-                <a:spcPts val="600"/>
-              </a:spcAft>
-            </a:pPr>
-            <a:r>
-              <a:rPr sz="1500" b="0">
-                <a:solidFill>
-                  <a:srgbClr val="26221B"/>
-                </a:solidFill>
-                <a:latin typeface="Georgia"/>
-              </a:rPr>
-              <a:t>• 🏡 A share of every fundraiser → the land-back retainer</a:t>
-            </a:r>
-          </a:p>
-          <a:p>
-            <a:pPr algn="l">
-              <a:spcAft>
-                <a:spcPts val="600"/>
-              </a:spcAft>
-            </a:pPr>
-            <a:r>
-              <a:rPr sz="1500" b="0">
-                <a:solidFill>
-                  <a:srgbClr val="26221B"/>
-                </a:solidFill>
-                <a:latin typeface="Georgia"/>
-              </a:rPr>
-              <a:t>• 🌱 A share → seed money for future reunions</a:t>
-            </a:r>
-          </a:p>
-          <a:p>
-            <a:pPr algn="l">
-              <a:spcAft>
-                <a:spcPts val="600"/>
-              </a:spcAft>
-            </a:pPr>
-            <a:r>
-              <a:rPr sz="1500" b="0">
-                <a:solidFill>
-                  <a:srgbClr val="26221B"/>
-                </a:solidFill>
-                <a:latin typeface="Georgia"/>
-              </a:rPr>
-              <a:t>• 🎓 A share → the scholarship fund</a:t>
-            </a:r>
-          </a:p>
-          <a:p>
-            <a:pPr algn="l">
-              <a:spcAft>
-                <a:spcPts val="600"/>
-              </a:spcAft>
-            </a:pPr>
-            <a:r>
-              <a:rPr sz="1500" b="0">
-                <a:solidFill>
-                  <a:srgbClr val="26221B"/>
-                </a:solidFill>
-                <a:latin typeface="Georgia"/>
-              </a:rPr>
-              <a:t>• Exact percentages set by member vote today — chair, entertain a motion!</a:t>
+              <a:t>Payments &amp; shop</a:t>
+            </a:r>
+          </a:p>
+          <a:p>
+            <a:pPr algn="l">
+              <a:spcAft>
+                <a:spcPts val="600"/>
+              </a:spcAft>
+            </a:pPr>
+            <a:r>
+              <a:rPr sz="1400" b="0">
+                <a:solidFill>
+                  <a:srgbClr val="26221B"/>
+                </a:solidFill>
+                <a:latin typeface="Georgia"/>
+              </a:rPr>
+              <a:t>• Registration &amp; dues online</a:t>
+            </a:r>
+          </a:p>
+          <a:p>
+            <a:pPr algn="l">
+              <a:spcAft>
+                <a:spcPts val="600"/>
+              </a:spcAft>
+            </a:pPr>
+            <a:r>
+              <a:rPr sz="1400" b="0">
+                <a:solidFill>
+                  <a:srgbClr val="26221B"/>
+                </a:solidFill>
+                <a:latin typeface="Georgia"/>
+              </a:rPr>
+              <a:t>• T-shirt orders</a:t>
+            </a:r>
+          </a:p>
+          <a:p>
+            <a:pPr algn="l">
+              <a:spcAft>
+                <a:spcPts val="600"/>
+              </a:spcAft>
+            </a:pPr>
+            <a:r>
+              <a:rPr sz="1400" b="0">
+                <a:solidFill>
+                  <a:srgbClr val="26221B"/>
+                </a:solidFill>
+                <a:latin typeface="Georgia"/>
+              </a:rPr>
+              <a:t>• Donations to the Land &amp; Scholarship funds</a:t>
             </a:r>
           </a:p>
         </p:txBody>
@@ -9479,6 +9574,109 @@
       <p:sp>
         <p:nvSpPr>
           <p:cNvPr id="6" name="TextBox 5"/>
+          <p:cNvSpPr txBox="1"/>
+          <p:nvPr/>
+        </p:nvSpPr>
+        <p:spPr>
+          <a:xfrm>
+            <a:off x="8229600" y="1737360"/>
+            <a:ext cx="3566160" cy="4114800"/>
+          </a:xfrm>
+          <a:prstGeom prst="rect">
+            <a:avLst/>
+          </a:prstGeom>
+          <a:noFill/>
+        </p:spPr>
+        <p:txBody>
+          <a:bodyPr wrap="square">
+            <a:spAutoFit/>
+          </a:bodyPr>
+          <a:lstStyle/>
+          <a:p>
+            <a:pPr algn="l">
+              <a:spcAft>
+                <a:spcPts val="800"/>
+              </a:spcAft>
+            </a:pPr>
+            <a:r>
+              <a:rPr sz="1600" b="1">
+                <a:solidFill>
+                  <a:srgbClr val="B71C1C"/>
+                </a:solidFill>
+                <a:latin typeface="Georgia"/>
+              </a:rPr>
+              <a:t>Get involved</a:t>
+            </a:r>
+          </a:p>
+          <a:p>
+            <a:pPr algn="l">
+              <a:spcAft>
+                <a:spcPts val="600"/>
+              </a:spcAft>
+            </a:pPr>
+            <a:r>
+              <a:rPr sz="1400" b="0">
+                <a:solidFill>
+                  <a:srgbClr val="26221B"/>
+                </a:solidFill>
+                <a:latin typeface="Georgia"/>
+              </a:rPr>
+              <a:t>• Committee &amp; chair sign-up</a:t>
+            </a:r>
+          </a:p>
+          <a:p>
+            <a:pPr algn="l">
+              <a:spcAft>
+                <a:spcPts val="600"/>
+              </a:spcAft>
+            </a:pPr>
+            <a:r>
+              <a:rPr sz="1400" b="0">
+                <a:solidFill>
+                  <a:srgbClr val="26221B"/>
+                </a:solidFill>
+                <a:latin typeface="Georgia"/>
+              </a:rPr>
+              <a:t>• Superlatives voting</a:t>
+            </a:r>
+          </a:p>
+          <a:p>
+            <a:pPr algn="l">
+              <a:spcAft>
+                <a:spcPts val="600"/>
+              </a:spcAft>
+            </a:pPr>
+            <a:r>
+              <a:rPr sz="1400" b="0">
+                <a:solidFill>
+                  <a:srgbClr val="26221B"/>
+                </a:solidFill>
+                <a:latin typeface="Georgia"/>
+              </a:rPr>
+              <a:t>• Family tree submission form</a:t>
+            </a:r>
+          </a:p>
+          <a:p>
+            <a:pPr algn="l">
+              <a:spcAft>
+                <a:spcPts val="600"/>
+              </a:spcAft>
+            </a:pPr>
+            <a:r>
+              <a:rPr sz="1400" b="0">
+                <a:solidFill>
+                  <a:srgbClr val="26221B"/>
+                </a:solidFill>
+                <a:latin typeface="Georgia"/>
+              </a:rPr>
+              <a:t>• Contact the officers</a:t>
+            </a:r>
+          </a:p>
+        </p:txBody>
+      </p:sp>
+      <p:sp>
+        <p:nvSpPr>
+          <p:cNvPr id="7" name="TextBox 6"/>
           <p:cNvSpPr txBox="1"/>
           <p:nvPr/>
         </p:nvSpPr>
@@ -9510,7 +9708,7 @@
                 </a:solidFill>
                 <a:latin typeface="Verdana"/>
               </a:rPr>
-              <a:t>If our claim succeeds, recovered land/proceeds are stewarded by the family foundation.</a:t>
+              <a:t>The Technology Committee launches from starter code already written (in the family GitHub repo). Payments run through Zelle/Cash App and a secure processor — we never store card numbers.</a:t>
             </a:r>
           </a:p>
         </p:txBody>
@@ -9575,7 +9773,7 @@
                 </a:solidFill>
                 <a:latin typeface="Verdana"/>
               </a:rPr>
-              <a:t>FAMILY BUSINESS · EDUCATION</a:t>
+              <a:t>FAMILY BUSINESS · OUR LAND</a:t>
             </a:r>
           </a:p>
         </p:txBody>
@@ -9614,7 +9812,7 @@
                 </a:solidFill>
                 <a:latin typeface="Georgia"/>
               </a:rPr>
-              <a:t>The Harris-Nelson Scholarship Fund 🎓</a:t>
+              <a:t>Getting Our Family Land Back 🏡</a:t>
             </a:r>
           </a:p>
         </p:txBody>
@@ -9628,7 +9826,70 @@
         <p:spPr>
           <a:xfrm>
             <a:off x="640080" y="1645920"/>
-            <a:ext cx="5486400" cy="4114800"/>
+            <a:ext cx="5669280" cy="2377440"/>
+          </a:xfrm>
+          <a:prstGeom prst="rect">
+            <a:avLst/>
+          </a:prstGeom>
+          <a:noFill/>
+        </p:spPr>
+        <p:txBody>
+          <a:bodyPr wrap="square">
+            <a:spAutoFit/>
+          </a:bodyPr>
+          <a:lstStyle/>
+          <a:p>
+            <a:pPr algn="l">
+              <a:spcAft>
+                <a:spcPts val="1000"/>
+              </a:spcAft>
+            </a:pPr>
+            <a:r>
+              <a:rPr sz="1600" b="0">
+                <a:solidFill>
+                  <a:srgbClr val="26221B"/>
+                </a:solidFill>
+                <a:latin typeface="Georgia"/>
+              </a:rPr>
+              <a:t>We are partnering with Where Is My Land (whereismyland.com) — an organization that helps Black families research, document, and reclaim land that was taken from them.</a:t>
+            </a:r>
+          </a:p>
+          <a:p>
+            <a:pPr algn="l">
+              <a:spcAft>
+                <a:spcPts val="600"/>
+              </a:spcAft>
+            </a:pPr>
+            <a:r>
+              <a:rPr sz="1500" b="0">
+                <a:solidFill>
+                  <a:srgbClr val="26221B"/>
+                </a:solidFill>
+                <a:latin typeface="Georgia"/>
+              </a:rPr>
+              <a:t>Step 1: gather deeds, tax records &amp; oral history</a:t>
+            </a:r>
+            <a:br/>
+            <a:r>
+              <a:t>Step 2: fund the RETAINER through reunion fundraising</a:t>
+            </a:r>
+            <a:br/>
+            <a:r>
+              <a:t>Step 3: family volunteers support the research</a:t>
+            </a:r>
+          </a:p>
+        </p:txBody>
+      </p:sp>
+      <p:sp>
+        <p:nvSpPr>
+          <p:cNvPr id="5" name="TextBox 4"/>
+          <p:cNvSpPr txBox="1"/>
+          <p:nvPr/>
+        </p:nvSpPr>
+        <p:spPr>
+          <a:xfrm>
+            <a:off x="6583680" y="1645920"/>
+            <a:ext cx="4937760" cy="4114800"/>
           </a:xfrm>
           <a:prstGeom prst="rect">
             <a:avLst/>
@@ -9649,11 +9910,11 @@
             <a:r>
               <a:rPr sz="1700" b="1">
                 <a:solidFill>
-                  <a:srgbClr val="2E7D32"/>
-                </a:solidFill>
-                <a:latin typeface="Georgia"/>
-              </a:rPr>
-              <a:t>A scholarship for descendants of our ancestors</a:t>
+                  <a:srgbClr val="E65100"/>
+                </a:solidFill>
+                <a:latin typeface="Georgia"/>
+              </a:rPr>
+              <a:t>How fundraising is split</a:t>
             </a:r>
           </a:p>
           <a:p>
@@ -9669,7 +9930,7 @@
                 </a:solidFill>
                 <a:latin typeface="Georgia"/>
               </a:rPr>
-              <a:t>• Who: any descendant enrolled (or enrolling) in an accredited program — college, trade school, certifications</a:t>
+              <a:t>• 🏡 A share of every fundraiser → the land-back fund (retainer + renovation &amp; revitalization of our land)</a:t>
             </a:r>
           </a:p>
           <a:p>
@@ -9685,7 +9946,7 @@
                 </a:solidFill>
                 <a:latin typeface="Georgia"/>
               </a:rPr>
-              <a:t>• How: short application + one-page essay on what family legacy means to you</a:t>
+              <a:t>• 🌱 A share → seed money for future reunions</a:t>
             </a:r>
           </a:p>
           <a:p>
@@ -9701,46 +9962,7 @@
                 </a:solidFill>
                 <a:latin typeface="Georgia"/>
               </a:rPr>
-              <a:t>• Selection: Philanthropy &amp; Fundraising Committee reviews; officers ratify; awarded at the banquet</a:t>
-            </a:r>
-          </a:p>
-        </p:txBody>
-      </p:sp>
-      <p:sp>
-        <p:nvSpPr>
-          <p:cNvPr id="5" name="TextBox 4"/>
-          <p:cNvSpPr txBox="1"/>
-          <p:nvPr/>
-        </p:nvSpPr>
-        <p:spPr>
-          <a:xfrm>
-            <a:off x="6400800" y="1645920"/>
-            <a:ext cx="5120640" cy="4114800"/>
-          </a:xfrm>
-          <a:prstGeom prst="rect">
-            <a:avLst/>
-          </a:prstGeom>
-          <a:noFill/>
-        </p:spPr>
-        <p:txBody>
-          <a:bodyPr wrap="square">
-            <a:spAutoFit/>
-          </a:bodyPr>
-          <a:lstStyle/>
-          <a:p>
-            <a:pPr algn="l">
-              <a:spcAft>
-                <a:spcPts val="800"/>
-              </a:spcAft>
-            </a:pPr>
-            <a:r>
-              <a:rPr sz="1700" b="1">
-                <a:solidFill>
-                  <a:srgbClr val="B71C1C"/>
-                </a:solidFill>
-                <a:latin typeface="Georgia"/>
-              </a:rPr>
-              <a:t>How we'll fund it</a:t>
+              <a:t>• 🎓 A share → the scholarship fund</a:t>
             </a:r>
           </a:p>
           <a:p>
@@ -9756,55 +9978,7 @@
                 </a:solidFill>
                 <a:latin typeface="Georgia"/>
               </a:rPr>
-              <a:t>• A set share of all reunion fundraising (vote today)</a:t>
-            </a:r>
-          </a:p>
-          <a:p>
-            <a:pPr algn="l">
-              <a:spcAft>
-                <a:spcPts val="600"/>
-              </a:spcAft>
-            </a:pPr>
-            <a:r>
-              <a:rPr sz="1500" b="0">
-                <a:solidFill>
-                  <a:srgbClr val="26221B"/>
-                </a:solidFill>
-                <a:latin typeface="Georgia"/>
-              </a:rPr>
-              <a:t>• Dedicated fundraisers: raffle, fish fry, walk-a-thon, souvenirs</a:t>
-            </a:r>
-          </a:p>
-          <a:p>
-            <a:pPr algn="l">
-              <a:spcAft>
-                <a:spcPts val="600"/>
-              </a:spcAft>
-            </a:pPr>
-            <a:r>
-              <a:rPr sz="1500" b="0">
-                <a:solidFill>
-                  <a:srgbClr val="26221B"/>
-                </a:solidFill>
-                <a:latin typeface="Georgia"/>
-              </a:rPr>
-              <a:t>• Online giving — in honor or in memory of a loved one</a:t>
-            </a:r>
-          </a:p>
-          <a:p>
-            <a:pPr algn="l">
-              <a:spcAft>
-                <a:spcPts val="600"/>
-              </a:spcAft>
-            </a:pPr>
-            <a:r>
-              <a:rPr sz="1500" b="0">
-                <a:solidFill>
-                  <a:srgbClr val="26221B"/>
-                </a:solidFill>
-                <a:latin typeface="Georgia"/>
-              </a:rPr>
-              <a:t>• Tax-deductible once the 501(c)(3) is approved</a:t>
+              <a:t>• Exact percentages set by member vote today — chair, entertain a motion!</a:t>
             </a:r>
           </a:p>
         </p:txBody>
@@ -9843,7 +10017,7 @@
                 </a:solidFill>
                 <a:latin typeface="Verdana"/>
               </a:rPr>
-              <a:t>Goal: award our first scholarship(s) at the next reunion.</a:t>
+              <a:t>If our claim succeeds, recovered land/proceeds are stewarded by the family foundation.</a:t>
             </a:r>
           </a:p>
         </p:txBody>
@@ -9908,7 +10082,7 @@
                 </a:solidFill>
                 <a:latin typeface="Verdana"/>
               </a:rPr>
-              <a:t>FAMILY BUSINESS · THE FOUNDATION</a:t>
+              <a:t>FAMILY BUSINESS · EDUCATION</a:t>
             </a:r>
           </a:p>
         </p:txBody>
@@ -9947,7 +10121,7 @@
                 </a:solidFill>
                 <a:latin typeface="Georgia"/>
               </a:rPr>
-              <a:t>Starting Our Family Foundation — a 501(c)(3) 🏛</a:t>
+              <a:t>The Harris-Nelson Scholarship Fund 🎓</a:t>
             </a:r>
           </a:p>
         </p:txBody>
@@ -9986,7 +10160,7 @@
                 </a:solidFill>
                 <a:latin typeface="Georgia"/>
               </a:rPr>
-              <a:t>The process (next few months)</a:t>
+              <a:t>A scholarship for descendants of our ancestors</a:t>
             </a:r>
           </a:p>
           <a:p>
@@ -10002,7 +10176,7 @@
                 </a:solidFill>
                 <a:latin typeface="Georgia"/>
               </a:rPr>
-              <a:t>• Month 1: choose the name, elect the founding board, draft bylaws &amp; conflict-of-interest policy</a:t>
+              <a:t>• Who: any descendant enrolled (or enrolling) in an accredited program — college, trade school, certifications</a:t>
             </a:r>
           </a:p>
           <a:p>
@@ -10018,7 +10192,7 @@
                 </a:solidFill>
                 <a:latin typeface="Georgia"/>
               </a:rPr>
-              <a:t>• Month 1–2: file Articles of Incorporation; get an EIN (free, IRS.gov)</a:t>
+              <a:t>• How: short application + one-page essay on what family legacy means to you</a:t>
             </a:r>
           </a:p>
           <a:p>
@@ -10034,23 +10208,7 @@
                 </a:solidFill>
                 <a:latin typeface="Georgia"/>
               </a:rPr>
-              <a:t>• Month 2–3: file IRS Form 1023-EZ (if eligible) or Form 1023</a:t>
-            </a:r>
-          </a:p>
-          <a:p>
-            <a:pPr algn="l">
-              <a:spcAft>
-                <a:spcPts val="600"/>
-              </a:spcAft>
-            </a:pPr>
-            <a:r>
-              <a:rPr sz="1500" b="0">
-                <a:solidFill>
-                  <a:srgbClr val="26221B"/>
-                </a:solidFill>
-                <a:latin typeface="Georgia"/>
-              </a:rPr>
-              <a:t>• Month 3+: state charity registration, bank account, annual budget</a:t>
+              <a:t>• Selection: Philanthropy &amp; Fundraising Committee reviews; officers ratify; awarded at the banquet</a:t>
             </a:r>
           </a:p>
         </p:txBody>
@@ -10085,11 +10243,11 @@
             <a:r>
               <a:rPr sz="1700" b="1">
                 <a:solidFill>
-                  <a:srgbClr val="E65100"/>
-                </a:solidFill>
-                <a:latin typeface="Georgia"/>
-              </a:rPr>
-              <a:t>Foundation board (to be elected)</a:t>
+                  <a:srgbClr val="B71C1C"/>
+                </a:solidFill>
+                <a:latin typeface="Georgia"/>
+              </a:rPr>
+              <a:t>How we'll fund it</a:t>
             </a:r>
           </a:p>
           <a:p>
@@ -10105,7 +10263,7 @@
                 </a:solidFill>
                 <a:latin typeface="Georgia"/>
               </a:rPr>
-              <a:t>• Board Chair · Vice Chair · Board Secretary · Board Treasurer</a:t>
+              <a:t>• A set share of all reunion fundraising (vote today)</a:t>
             </a:r>
           </a:p>
           <a:p>
@@ -10121,7 +10279,7 @@
                 </a:solidFill>
                 <a:latin typeface="Georgia"/>
               </a:rPr>
-              <a:t>• 3–5 at-large directors — one from each generation if we can</a:t>
+              <a:t>• Dedicated fundraisers: raffle, fish fry, walk-a-thon, souvenirs</a:t>
             </a:r>
           </a:p>
           <a:p>
@@ -10137,7 +10295,7 @@
                 </a:solidFill>
                 <a:latin typeface="Georgia"/>
               </a:rPr>
-              <a:t>• Its own body with its own votes, separate from reunion officers</a:t>
+              <a:t>• Online giving — in honor or in memory of a loved one</a:t>
             </a:r>
           </a:p>
           <a:p>
@@ -10153,7 +10311,7 @@
                 </a:solidFill>
                 <a:latin typeface="Georgia"/>
               </a:rPr>
-              <a:t>• Board meets quarterly; minutes published to the family</a:t>
+              <a:t>• Tax-deductible once the 501(c)(3) is approved</a:t>
             </a:r>
           </a:p>
         </p:txBody>
@@ -10192,7 +10350,7 @@
                 </a:solidFill>
                 <a:latin typeface="Verdana"/>
               </a:rPr>
-              <a:t>Nominations open today — see the Secretary. We ratify the founding board by motion and vote.</a:t>
+              <a:t>Goal: award our first scholarship(s) at the next reunion.</a:t>
             </a:r>
           </a:p>
         </p:txBody>
@@ -10257,7 +10415,7 @@
                 </a:solidFill>
                 <a:latin typeface="Verdana"/>
               </a:rPr>
-              <a:t>ALL WEEKEND LONG</a:t>
+              <a:t>FAMILY BUSINESS · NEW PROGRAM</a:t>
             </a:r>
           </a:p>
         </p:txBody>
@@ -10296,7 +10454,7 @@
                 </a:solidFill>
                 <a:latin typeface="Georgia"/>
               </a:rPr>
-              <a:t>The Family Tree Project — Add Yourself! 🌳</a:t>
+              <a:t>Helping Hands — the Family Hardship Fund 🤝</a:t>
             </a:r>
           </a:p>
         </p:txBody>
@@ -10310,7 +10468,7 @@
         <p:spPr>
           <a:xfrm>
             <a:off x="640080" y="1645920"/>
-            <a:ext cx="5486400" cy="4114800"/>
+            <a:ext cx="3657600" cy="4114800"/>
           </a:xfrm>
           <a:prstGeom prst="rect">
             <a:avLst/>
@@ -10329,77 +10487,61 @@
               </a:spcAft>
             </a:pPr>
             <a:r>
-              <a:rPr sz="1700" b="1">
+              <a:rPr sz="1500" b="1">
                 <a:solidFill>
                   <a:srgbClr val="2E7D32"/>
                 </a:solidFill>
                 <a:latin typeface="Georgia"/>
               </a:rPr>
-              <a:t>Four easy steps</a:t>
-            </a:r>
-          </a:p>
-          <a:p>
-            <a:pPr algn="l">
-              <a:spcAft>
-                <a:spcPts val="600"/>
-              </a:spcAft>
-            </a:pPr>
-            <a:r>
-              <a:rPr sz="1500" b="0">
-                <a:solidFill>
-                  <a:srgbClr val="26221B"/>
-                </a:solidFill>
-                <a:latin typeface="Georgia"/>
-              </a:rPr>
-              <a:t>• Stop by the Family Tree table (or scan the QR code)</a:t>
-            </a:r>
-          </a:p>
-          <a:p>
-            <a:pPr algn="l">
-              <a:spcAft>
-                <a:spcPts val="600"/>
-              </a:spcAft>
-            </a:pPr>
-            <a:r>
-              <a:rPr sz="1500" b="0">
-                <a:solidFill>
-                  <a:srgbClr val="26221B"/>
-                </a:solidFill>
-                <a:latin typeface="Georgia"/>
-              </a:rPr>
-              <a:t>• Fill out the short form — name, birthday, parents, branch, children</a:t>
-            </a:r>
-          </a:p>
-          <a:p>
-            <a:pPr algn="l">
-              <a:spcAft>
-                <a:spcPts val="600"/>
-              </a:spcAft>
-            </a:pPr>
-            <a:r>
-              <a:rPr sz="1500" b="0">
-                <a:solidFill>
-                  <a:srgbClr val="26221B"/>
-                </a:solidFill>
-                <a:latin typeface="Georgia"/>
-              </a:rPr>
-              <a:t>• The Historian (Shone) adds you to the Ancestry tree</a:t>
-            </a:r>
-          </a:p>
-          <a:p>
-            <a:pPr algn="l">
-              <a:spcAft>
-                <a:spcPts val="600"/>
-              </a:spcAft>
-            </a:pPr>
-            <a:r>
-              <a:rPr sz="1500" b="0">
-                <a:solidFill>
-                  <a:srgbClr val="26221B"/>
-                </a:solidFill>
-                <a:latin typeface="Georgia"/>
-              </a:rPr>
-              <a:t>• A large family tree poster gets printed with EVERYONE listed</a:t>
+              <a:t>Who can apply</a:t>
+            </a:r>
+          </a:p>
+          <a:p>
+            <a:pPr algn="l">
+              <a:spcAft>
+                <a:spcPts val="600"/>
+              </a:spcAft>
+            </a:pPr>
+            <a:r>
+              <a:rPr sz="1300" b="0">
+                <a:solidFill>
+                  <a:srgbClr val="26221B"/>
+                </a:solidFill>
+                <a:latin typeface="Georgia"/>
+              </a:rPr>
+              <a:t>• Any descendant, spouse/partner, or child (minors via a guardian) — or apply on behalf of a relative</a:t>
+            </a:r>
+          </a:p>
+          <a:p>
+            <a:pPr algn="l">
+              <a:spcAft>
+                <a:spcPts val="600"/>
+              </a:spcAft>
+            </a:pPr>
+            <a:r>
+              <a:rPr sz="1300" b="0">
+                <a:solidFill>
+                  <a:srgbClr val="26221B"/>
+                </a:solidFill>
+                <a:latin typeface="Georgia"/>
+              </a:rPr>
+              <a:t>• Hardship within the past 12 months: medical, job loss, housing/disaster, funeral, caregiving, education emergency</a:t>
+            </a:r>
+          </a:p>
+          <a:p>
+            <a:pPr algn="l">
+              <a:spcAft>
+                <a:spcPts val="600"/>
+              </a:spcAft>
+            </a:pPr>
+            <a:r>
+              <a:rPr sz="1300" b="0">
+                <a:solidFill>
+                  <a:srgbClr val="26221B"/>
+                </a:solidFill>
+                <a:latin typeface="Georgia"/>
+              </a:rPr>
+              <a:t>• One award per household per cycle; dues status does NOT affect eligibility</a:t>
             </a:r>
           </a:p>
         </p:txBody>
@@ -10412,8 +10554,8 @@
         </p:nvSpPr>
         <p:spPr>
           <a:xfrm>
-            <a:off x="6400800" y="1645920"/>
-            <a:ext cx="5120640" cy="4114800"/>
+            <a:off x="4434840" y="1645920"/>
+            <a:ext cx="3657600" cy="4114800"/>
           </a:xfrm>
           <a:prstGeom prst="rect">
             <a:avLst/>
@@ -10432,61 +10574,219 @@
               </a:spcAft>
             </a:pPr>
             <a:r>
-              <a:rPr sz="1700" b="1">
+              <a:rPr sz="1500" b="1">
                 <a:solidFill>
                   <a:srgbClr val="E65100"/>
                 </a:solidFill>
                 <a:latin typeface="Georgia"/>
               </a:rPr>
-              <a:t>Ways to submit</a:t>
-            </a:r>
-          </a:p>
-          <a:p>
-            <a:pPr algn="l">
-              <a:spcAft>
-                <a:spcPts val="600"/>
-              </a:spcAft>
-            </a:pPr>
-            <a:r>
-              <a:rPr sz="1500" b="0">
-                <a:solidFill>
-                  <a:srgbClr val="26221B"/>
-                </a:solidFill>
-                <a:latin typeface="Georgia"/>
-              </a:rPr>
-              <a:t>• Online: the Family Tree Google Form, or the matching form on hnfamilyreunion.com</a:t>
-            </a:r>
-          </a:p>
-          <a:p>
-            <a:pPr algn="l">
-              <a:spcAft>
-                <a:spcPts val="600"/>
-              </a:spcAft>
-            </a:pPr>
-            <a:r>
-              <a:rPr sz="1500" b="0">
-                <a:solidFill>
-                  <a:srgbClr val="26221B"/>
-                </a:solidFill>
-                <a:latin typeface="Georgia"/>
-              </a:rPr>
-              <a:t>• Paper: forms at the Family Tree table all weekend</a:t>
-            </a:r>
-          </a:p>
-          <a:p>
-            <a:pPr algn="l">
-              <a:spcAft>
-                <a:spcPts val="600"/>
-              </a:spcAft>
-            </a:pPr>
-            <a:r>
-              <a:rPr sz="1500" b="0">
-                <a:solidFill>
-                  <a:srgbClr val="26221B"/>
-                </a:solidFill>
-                <a:latin typeface="Georgia"/>
-              </a:rPr>
-              <a:t>• Bring old photos, obituaries, bibles, deeds — we scan them on the spot (you keep the originals)</a:t>
+              <a:t>How the recipient is chosen</a:t>
+            </a:r>
+          </a:p>
+          <a:p>
+            <a:pPr algn="l">
+              <a:spcAft>
+                <a:spcPts val="600"/>
+              </a:spcAft>
+            </a:pPr>
+            <a:r>
+              <a:rPr sz="1300" b="0">
+                <a:solidFill>
+                  <a:srgbClr val="26221B"/>
+                </a:solidFill>
+                <a:latin typeface="Georgia"/>
+              </a:rPr>
+              <a:t>• Confidential application → Philanthropy &amp; Fundraising Committee scores it</a:t>
+            </a:r>
+          </a:p>
+          <a:p>
+            <a:pPr algn="l">
+              <a:spcAft>
+                <a:spcPts val="600"/>
+              </a:spcAft>
+            </a:pPr>
+            <a:r>
+              <a:rPr sz="1300" b="0">
+                <a:solidFill>
+                  <a:srgbClr val="26221B"/>
+                </a:solidFill>
+                <a:latin typeface="Georgia"/>
+              </a:rPr>
+              <a:t>• Rubric: severity &amp; urgency 40% · impact 30% · clarity &amp; completeness 20% · discretion 10%</a:t>
+            </a:r>
+          </a:p>
+          <a:p>
+            <a:pPr algn="l">
+              <a:spcAft>
+                <a:spcPts val="600"/>
+              </a:spcAft>
+            </a:pPr>
+            <a:r>
+              <a:rPr sz="1300" b="0">
+                <a:solidFill>
+                  <a:srgbClr val="26221B"/>
+                </a:solidFill>
+                <a:latin typeface="Georgia"/>
+              </a:rPr>
+              <a:t>• 3+ independent scorers; household conflicts recuse; officers ratify</a:t>
+            </a:r>
+          </a:p>
+          <a:p>
+            <a:pPr algn="l">
+              <a:spcAft>
+                <a:spcPts val="600"/>
+              </a:spcAft>
+            </a:pPr>
+            <a:r>
+              <a:rPr sz="1300" b="0">
+                <a:solidFill>
+                  <a:srgbClr val="26221B"/>
+                </a:solidFill>
+                <a:latin typeface="Georgia"/>
+              </a:rPr>
+              <a:t>• Recipient may stay ANONYMOUS — always their choice</a:t>
+            </a:r>
+          </a:p>
+        </p:txBody>
+      </p:sp>
+      <p:sp>
+        <p:nvSpPr>
+          <p:cNvPr id="6" name="TextBox 5"/>
+          <p:cNvSpPr txBox="1"/>
+          <p:nvPr/>
+        </p:nvSpPr>
+        <p:spPr>
+          <a:xfrm>
+            <a:off x="8229600" y="1645920"/>
+            <a:ext cx="3566160" cy="4114800"/>
+          </a:xfrm>
+          <a:prstGeom prst="rect">
+            <a:avLst/>
+          </a:prstGeom>
+          <a:noFill/>
+        </p:spPr>
+        <p:txBody>
+          <a:bodyPr wrap="square">
+            <a:spAutoFit/>
+          </a:bodyPr>
+          <a:lstStyle/>
+          <a:p>
+            <a:pPr algn="l">
+              <a:spcAft>
+                <a:spcPts val="800"/>
+              </a:spcAft>
+            </a:pPr>
+            <a:r>
+              <a:rPr sz="1500" b="1">
+                <a:solidFill>
+                  <a:srgbClr val="B71C1C"/>
+                </a:solidFill>
+                <a:latin typeface="Georgia"/>
+              </a:rPr>
+              <a:t>Deadlines each cycle</a:t>
+            </a:r>
+          </a:p>
+          <a:p>
+            <a:pPr algn="l">
+              <a:spcAft>
+                <a:spcPts val="600"/>
+              </a:spcAft>
+            </a:pPr>
+            <a:r>
+              <a:rPr sz="1300" b="0">
+                <a:solidFill>
+                  <a:srgbClr val="26221B"/>
+                </a:solidFill>
+                <a:latin typeface="Georgia"/>
+              </a:rPr>
+              <a:t>• Applications open January 1 of the reunion year</a:t>
+            </a:r>
+          </a:p>
+          <a:p>
+            <a:pPr algn="l">
+              <a:spcAft>
+                <a:spcPts val="600"/>
+              </a:spcAft>
+            </a:pPr>
+            <a:r>
+              <a:rPr sz="1300" b="0">
+                <a:solidFill>
+                  <a:srgbClr val="26221B"/>
+                </a:solidFill>
+                <a:latin typeface="Georgia"/>
+              </a:rPr>
+              <a:t>• Deadline: 30 days before the reunion</a:t>
+            </a:r>
+          </a:p>
+          <a:p>
+            <a:pPr algn="l">
+              <a:spcAft>
+                <a:spcPts val="600"/>
+              </a:spcAft>
+            </a:pPr>
+            <a:r>
+              <a:rPr sz="1300" b="0">
+                <a:solidFill>
+                  <a:srgbClr val="26221B"/>
+                </a:solidFill>
+                <a:latin typeface="Georgia"/>
+              </a:rPr>
+              <a:t>• Committee scores by 14 days out; officers ratify by 7</a:t>
+            </a:r>
+          </a:p>
+          <a:p>
+            <a:pPr algn="l">
+              <a:spcAft>
+                <a:spcPts val="600"/>
+              </a:spcAft>
+            </a:pPr>
+            <a:r>
+              <a:rPr sz="1300" b="0">
+                <a:solidFill>
+                  <a:srgbClr val="26221B"/>
+                </a:solidFill>
+                <a:latin typeface="Georgia"/>
+              </a:rPr>
+              <a:t>• Award presented at Sunday brunch</a:t>
+            </a:r>
+          </a:p>
+        </p:txBody>
+      </p:sp>
+      <p:sp>
+        <p:nvSpPr>
+          <p:cNvPr id="7" name="TextBox 6"/>
+          <p:cNvSpPr txBox="1"/>
+          <p:nvPr/>
+        </p:nvSpPr>
+        <p:spPr>
+          <a:xfrm>
+            <a:off x="640080" y="6291072"/>
+            <a:ext cx="10911535" cy="457200"/>
+          </a:xfrm>
+          <a:prstGeom prst="rect">
+            <a:avLst/>
+          </a:prstGeom>
+          <a:noFill/>
+        </p:spPr>
+        <p:txBody>
+          <a:bodyPr wrap="square">
+            <a:spAutoFit/>
+          </a:bodyPr>
+          <a:lstStyle/>
+          <a:p>
+            <a:pPr algn="l">
+              <a:spcAft>
+                <a:spcPts val="600"/>
+              </a:spcAft>
+            </a:pPr>
+            <a:r>
+              <a:rPr sz="1100" b="0">
+                <a:solidFill>
+                  <a:srgbClr val="6B6355"/>
+                </a:solidFill>
+                <a:latin typeface="Verdana"/>
+              </a:rPr>
+              <a:t>Apply at hnfamilyreunion.com (Hardship Fund page) or on paper from any officer. Award amount set by the Treasurer's budget each cycle — funded from the fundraising split.</a:t>
             </a:r>
           </a:p>
         </p:txBody>
@@ -10500,6 +10800,649 @@
 </file>
 
 <file path=ppt/slides/slide25.xml><?xml version="1.0" encoding="utf-8"?>
+<p:sld xmlns:a="http://schemas.openxmlformats.org/drawingml/2006/main" xmlns:p="http://schemas.openxmlformats.org/presentationml/2006/main" xmlns:r="http://schemas.openxmlformats.org/officeDocument/2006/relationships">
+  <p:cSld>
+    <p:bg>
+      <p:bgPr>
+        <a:solidFill>
+          <a:srgbClr val="FAF6EE"/>
+        </a:solidFill>
+        <a:effectLst/>
+      </p:bgPr>
+    </p:bg>
+    <p:spTree>
+      <p:nvGrpSpPr>
+        <p:cNvPr id="1" name=""/>
+        <p:cNvGrpSpPr/>
+        <p:nvPr/>
+      </p:nvGrpSpPr>
+      <p:grpSpPr/>
+      <p:sp>
+        <p:nvSpPr>
+          <p:cNvPr id="2" name="TextBox 1"/>
+          <p:cNvSpPr txBox="1"/>
+          <p:nvPr/>
+        </p:nvSpPr>
+        <p:spPr>
+          <a:xfrm>
+            <a:off x="640080" y="320040"/>
+            <a:ext cx="10911535" cy="365760"/>
+          </a:xfrm>
+          <a:prstGeom prst="rect">
+            <a:avLst/>
+          </a:prstGeom>
+          <a:noFill/>
+        </p:spPr>
+        <p:txBody>
+          <a:bodyPr wrap="square">
+            <a:spAutoFit/>
+          </a:bodyPr>
+          <a:lstStyle/>
+          <a:p>
+            <a:pPr algn="l">
+              <a:spcAft>
+                <a:spcPts val="600"/>
+              </a:spcAft>
+            </a:pPr>
+            <a:r>
+              <a:rPr sz="1300" b="1">
+                <a:solidFill>
+                  <a:srgbClr val="E65100"/>
+                </a:solidFill>
+                <a:latin typeface="Verdana"/>
+              </a:rPr>
+              <a:t>FAMILY BUSINESS · THE FOUNDATION</a:t>
+            </a:r>
+          </a:p>
+        </p:txBody>
+      </p:sp>
+      <p:sp>
+        <p:nvSpPr>
+          <p:cNvPr id="3" name="TextBox 2"/>
+          <p:cNvSpPr txBox="1"/>
+          <p:nvPr/>
+        </p:nvSpPr>
+        <p:spPr>
+          <a:xfrm>
+            <a:off x="640080" y="685800"/>
+            <a:ext cx="10911535" cy="822960"/>
+          </a:xfrm>
+          <a:prstGeom prst="rect">
+            <a:avLst/>
+          </a:prstGeom>
+          <a:noFill/>
+        </p:spPr>
+        <p:txBody>
+          <a:bodyPr wrap="square">
+            <a:spAutoFit/>
+          </a:bodyPr>
+          <a:lstStyle/>
+          <a:p>
+            <a:pPr algn="l">
+              <a:spcAft>
+                <a:spcPts val="600"/>
+              </a:spcAft>
+            </a:pPr>
+            <a:r>
+              <a:rPr sz="3400" b="1">
+                <a:solidFill>
+                  <a:srgbClr val="1B5E20"/>
+                </a:solidFill>
+                <a:latin typeface="Georgia"/>
+              </a:rPr>
+              <a:t>Starting Our Family Foundation — a 501(c)(3) 🏛</a:t>
+            </a:r>
+          </a:p>
+        </p:txBody>
+      </p:sp>
+      <p:sp>
+        <p:nvSpPr>
+          <p:cNvPr id="4" name="TextBox 3"/>
+          <p:cNvSpPr txBox="1"/>
+          <p:nvPr/>
+        </p:nvSpPr>
+        <p:spPr>
+          <a:xfrm>
+            <a:off x="640080" y="1645920"/>
+            <a:ext cx="5486400" cy="4114800"/>
+          </a:xfrm>
+          <a:prstGeom prst="rect">
+            <a:avLst/>
+          </a:prstGeom>
+          <a:noFill/>
+        </p:spPr>
+        <p:txBody>
+          <a:bodyPr wrap="square">
+            <a:spAutoFit/>
+          </a:bodyPr>
+          <a:lstStyle/>
+          <a:p>
+            <a:pPr algn="l">
+              <a:spcAft>
+                <a:spcPts val="800"/>
+              </a:spcAft>
+            </a:pPr>
+            <a:r>
+              <a:rPr sz="1700" b="1">
+                <a:solidFill>
+                  <a:srgbClr val="2E7D32"/>
+                </a:solidFill>
+                <a:latin typeface="Georgia"/>
+              </a:rPr>
+              <a:t>The process (next few months)</a:t>
+            </a:r>
+          </a:p>
+          <a:p>
+            <a:pPr algn="l">
+              <a:spcAft>
+                <a:spcPts val="600"/>
+              </a:spcAft>
+            </a:pPr>
+            <a:r>
+              <a:rPr sz="1500" b="0">
+                <a:solidFill>
+                  <a:srgbClr val="26221B"/>
+                </a:solidFill>
+                <a:latin typeface="Georgia"/>
+              </a:rPr>
+              <a:t>• Month 1: choose the name, elect the founding board, draft bylaws &amp; conflict-of-interest policy</a:t>
+            </a:r>
+          </a:p>
+          <a:p>
+            <a:pPr algn="l">
+              <a:spcAft>
+                <a:spcPts val="600"/>
+              </a:spcAft>
+            </a:pPr>
+            <a:r>
+              <a:rPr sz="1500" b="0">
+                <a:solidFill>
+                  <a:srgbClr val="26221B"/>
+                </a:solidFill>
+                <a:latin typeface="Georgia"/>
+              </a:rPr>
+              <a:t>• Month 1–2: file Articles of Incorporation; get an EIN (free, IRS.gov)</a:t>
+            </a:r>
+          </a:p>
+          <a:p>
+            <a:pPr algn="l">
+              <a:spcAft>
+                <a:spcPts val="600"/>
+              </a:spcAft>
+            </a:pPr>
+            <a:r>
+              <a:rPr sz="1500" b="0">
+                <a:solidFill>
+                  <a:srgbClr val="26221B"/>
+                </a:solidFill>
+                <a:latin typeface="Georgia"/>
+              </a:rPr>
+              <a:t>• Month 2–3: file IRS Form 1023-EZ (if eligible) or Form 1023</a:t>
+            </a:r>
+          </a:p>
+          <a:p>
+            <a:pPr algn="l">
+              <a:spcAft>
+                <a:spcPts val="600"/>
+              </a:spcAft>
+            </a:pPr>
+            <a:r>
+              <a:rPr sz="1500" b="0">
+                <a:solidFill>
+                  <a:srgbClr val="26221B"/>
+                </a:solidFill>
+                <a:latin typeface="Georgia"/>
+              </a:rPr>
+              <a:t>• Month 3+: state charity registration, bank account, annual budget</a:t>
+            </a:r>
+          </a:p>
+        </p:txBody>
+      </p:sp>
+      <p:sp>
+        <p:nvSpPr>
+          <p:cNvPr id="5" name="TextBox 4"/>
+          <p:cNvSpPr txBox="1"/>
+          <p:nvPr/>
+        </p:nvSpPr>
+        <p:spPr>
+          <a:xfrm>
+            <a:off x="6400800" y="1645920"/>
+            <a:ext cx="5120640" cy="4114800"/>
+          </a:xfrm>
+          <a:prstGeom prst="rect">
+            <a:avLst/>
+          </a:prstGeom>
+          <a:noFill/>
+        </p:spPr>
+        <p:txBody>
+          <a:bodyPr wrap="square">
+            <a:spAutoFit/>
+          </a:bodyPr>
+          <a:lstStyle/>
+          <a:p>
+            <a:pPr algn="l">
+              <a:spcAft>
+                <a:spcPts val="800"/>
+              </a:spcAft>
+            </a:pPr>
+            <a:r>
+              <a:rPr sz="1700" b="1">
+                <a:solidFill>
+                  <a:srgbClr val="E65100"/>
+                </a:solidFill>
+                <a:latin typeface="Georgia"/>
+              </a:rPr>
+              <a:t>Foundation board (to be elected)</a:t>
+            </a:r>
+          </a:p>
+          <a:p>
+            <a:pPr algn="l">
+              <a:spcAft>
+                <a:spcPts val="600"/>
+              </a:spcAft>
+            </a:pPr>
+            <a:r>
+              <a:rPr sz="1500" b="0">
+                <a:solidFill>
+                  <a:srgbClr val="26221B"/>
+                </a:solidFill>
+                <a:latin typeface="Georgia"/>
+              </a:rPr>
+              <a:t>• Board Chair · Vice Chair · Board Secretary · Board Treasurer</a:t>
+            </a:r>
+          </a:p>
+          <a:p>
+            <a:pPr algn="l">
+              <a:spcAft>
+                <a:spcPts val="600"/>
+              </a:spcAft>
+            </a:pPr>
+            <a:r>
+              <a:rPr sz="1500" b="0">
+                <a:solidFill>
+                  <a:srgbClr val="26221B"/>
+                </a:solidFill>
+                <a:latin typeface="Georgia"/>
+              </a:rPr>
+              <a:t>• 3–5 at-large directors — one from each generation if we can</a:t>
+            </a:r>
+          </a:p>
+          <a:p>
+            <a:pPr algn="l">
+              <a:spcAft>
+                <a:spcPts val="600"/>
+              </a:spcAft>
+            </a:pPr>
+            <a:r>
+              <a:rPr sz="1500" b="0">
+                <a:solidFill>
+                  <a:srgbClr val="26221B"/>
+                </a:solidFill>
+                <a:latin typeface="Georgia"/>
+              </a:rPr>
+              <a:t>• Its own body with its own votes, separate from reunion officers</a:t>
+            </a:r>
+          </a:p>
+          <a:p>
+            <a:pPr algn="l">
+              <a:spcAft>
+                <a:spcPts val="600"/>
+              </a:spcAft>
+            </a:pPr>
+            <a:r>
+              <a:rPr sz="1500" b="0">
+                <a:solidFill>
+                  <a:srgbClr val="26221B"/>
+                </a:solidFill>
+                <a:latin typeface="Georgia"/>
+              </a:rPr>
+              <a:t>• Board meets quarterly; minutes published to the family</a:t>
+            </a:r>
+          </a:p>
+        </p:txBody>
+      </p:sp>
+      <p:sp>
+        <p:nvSpPr>
+          <p:cNvPr id="6" name="TextBox 5"/>
+          <p:cNvSpPr txBox="1"/>
+          <p:nvPr/>
+        </p:nvSpPr>
+        <p:spPr>
+          <a:xfrm>
+            <a:off x="640080" y="6291072"/>
+            <a:ext cx="10911535" cy="457200"/>
+          </a:xfrm>
+          <a:prstGeom prst="rect">
+            <a:avLst/>
+          </a:prstGeom>
+          <a:noFill/>
+        </p:spPr>
+        <p:txBody>
+          <a:bodyPr wrap="square">
+            <a:spAutoFit/>
+          </a:bodyPr>
+          <a:lstStyle/>
+          <a:p>
+            <a:pPr algn="l">
+              <a:spcAft>
+                <a:spcPts val="600"/>
+              </a:spcAft>
+            </a:pPr>
+            <a:r>
+              <a:rPr sz="1100" b="0">
+                <a:solidFill>
+                  <a:srgbClr val="6B6355"/>
+                </a:solidFill>
+                <a:latin typeface="Verdana"/>
+              </a:rPr>
+              <a:t>Nominations open today — see the Secretary. We ratify the founding board by motion and vote.</a:t>
+            </a:r>
+          </a:p>
+        </p:txBody>
+      </p:sp>
+    </p:spTree>
+  </p:cSld>
+  <p:clrMapOvr>
+    <a:masterClrMapping/>
+  </p:clrMapOvr>
+</p:sld>
+</file>
+
+<file path=ppt/slides/slide26.xml><?xml version="1.0" encoding="utf-8"?>
+<p:sld xmlns:a="http://schemas.openxmlformats.org/drawingml/2006/main" xmlns:p="http://schemas.openxmlformats.org/presentationml/2006/main" xmlns:r="http://schemas.openxmlformats.org/officeDocument/2006/relationships">
+  <p:cSld>
+    <p:bg>
+      <p:bgPr>
+        <a:solidFill>
+          <a:srgbClr val="FAF6EE"/>
+        </a:solidFill>
+        <a:effectLst/>
+      </p:bgPr>
+    </p:bg>
+    <p:spTree>
+      <p:nvGrpSpPr>
+        <p:cNvPr id="1" name=""/>
+        <p:cNvGrpSpPr/>
+        <p:nvPr/>
+      </p:nvGrpSpPr>
+      <p:grpSpPr/>
+      <p:sp>
+        <p:nvSpPr>
+          <p:cNvPr id="2" name="TextBox 1"/>
+          <p:cNvSpPr txBox="1"/>
+          <p:nvPr/>
+        </p:nvSpPr>
+        <p:spPr>
+          <a:xfrm>
+            <a:off x="640080" y="320040"/>
+            <a:ext cx="10911535" cy="365760"/>
+          </a:xfrm>
+          <a:prstGeom prst="rect">
+            <a:avLst/>
+          </a:prstGeom>
+          <a:noFill/>
+        </p:spPr>
+        <p:txBody>
+          <a:bodyPr wrap="square">
+            <a:spAutoFit/>
+          </a:bodyPr>
+          <a:lstStyle/>
+          <a:p>
+            <a:pPr algn="l">
+              <a:spcAft>
+                <a:spcPts val="600"/>
+              </a:spcAft>
+            </a:pPr>
+            <a:r>
+              <a:rPr sz="1300" b="1">
+                <a:solidFill>
+                  <a:srgbClr val="E65100"/>
+                </a:solidFill>
+                <a:latin typeface="Verdana"/>
+              </a:rPr>
+              <a:t>ALL WEEKEND LONG</a:t>
+            </a:r>
+          </a:p>
+        </p:txBody>
+      </p:sp>
+      <p:sp>
+        <p:nvSpPr>
+          <p:cNvPr id="3" name="TextBox 2"/>
+          <p:cNvSpPr txBox="1"/>
+          <p:nvPr/>
+        </p:nvSpPr>
+        <p:spPr>
+          <a:xfrm>
+            <a:off x="640080" y="685800"/>
+            <a:ext cx="10911535" cy="822960"/>
+          </a:xfrm>
+          <a:prstGeom prst="rect">
+            <a:avLst/>
+          </a:prstGeom>
+          <a:noFill/>
+        </p:spPr>
+        <p:txBody>
+          <a:bodyPr wrap="square">
+            <a:spAutoFit/>
+          </a:bodyPr>
+          <a:lstStyle/>
+          <a:p>
+            <a:pPr algn="l">
+              <a:spcAft>
+                <a:spcPts val="600"/>
+              </a:spcAft>
+            </a:pPr>
+            <a:r>
+              <a:rPr sz="3400" b="1">
+                <a:solidFill>
+                  <a:srgbClr val="1B5E20"/>
+                </a:solidFill>
+                <a:latin typeface="Georgia"/>
+              </a:rPr>
+              <a:t>The Family Tree Project — Add Yourself! 🌳</a:t>
+            </a:r>
+          </a:p>
+        </p:txBody>
+      </p:sp>
+      <p:sp>
+        <p:nvSpPr>
+          <p:cNvPr id="4" name="TextBox 3"/>
+          <p:cNvSpPr txBox="1"/>
+          <p:nvPr/>
+        </p:nvSpPr>
+        <p:spPr>
+          <a:xfrm>
+            <a:off x="640080" y="1645920"/>
+            <a:ext cx="5486400" cy="4114800"/>
+          </a:xfrm>
+          <a:prstGeom prst="rect">
+            <a:avLst/>
+          </a:prstGeom>
+          <a:noFill/>
+        </p:spPr>
+        <p:txBody>
+          <a:bodyPr wrap="square">
+            <a:spAutoFit/>
+          </a:bodyPr>
+          <a:lstStyle/>
+          <a:p>
+            <a:pPr algn="l">
+              <a:spcAft>
+                <a:spcPts val="800"/>
+              </a:spcAft>
+            </a:pPr>
+            <a:r>
+              <a:rPr sz="1700" b="1">
+                <a:solidFill>
+                  <a:srgbClr val="2E7D32"/>
+                </a:solidFill>
+                <a:latin typeface="Georgia"/>
+              </a:rPr>
+              <a:t>Four easy steps</a:t>
+            </a:r>
+          </a:p>
+          <a:p>
+            <a:pPr algn="l">
+              <a:spcAft>
+                <a:spcPts val="600"/>
+              </a:spcAft>
+            </a:pPr>
+            <a:r>
+              <a:rPr sz="1500" b="0">
+                <a:solidFill>
+                  <a:srgbClr val="26221B"/>
+                </a:solidFill>
+                <a:latin typeface="Georgia"/>
+              </a:rPr>
+              <a:t>• Stop by the Family Tree table (or scan the QR code)</a:t>
+            </a:r>
+          </a:p>
+          <a:p>
+            <a:pPr algn="l">
+              <a:spcAft>
+                <a:spcPts val="600"/>
+              </a:spcAft>
+            </a:pPr>
+            <a:r>
+              <a:rPr sz="1500" b="0">
+                <a:solidFill>
+                  <a:srgbClr val="26221B"/>
+                </a:solidFill>
+                <a:latin typeface="Georgia"/>
+              </a:rPr>
+              <a:t>• Fill out the short form — name, birthday, parents, branch, children</a:t>
+            </a:r>
+          </a:p>
+          <a:p>
+            <a:pPr algn="l">
+              <a:spcAft>
+                <a:spcPts val="600"/>
+              </a:spcAft>
+            </a:pPr>
+            <a:r>
+              <a:rPr sz="1500" b="0">
+                <a:solidFill>
+                  <a:srgbClr val="26221B"/>
+                </a:solidFill>
+                <a:latin typeface="Georgia"/>
+              </a:rPr>
+              <a:t>• The Historian (Shone) adds you to the Ancestry tree</a:t>
+            </a:r>
+          </a:p>
+          <a:p>
+            <a:pPr algn="l">
+              <a:spcAft>
+                <a:spcPts val="600"/>
+              </a:spcAft>
+            </a:pPr>
+            <a:r>
+              <a:rPr sz="1500" b="0">
+                <a:solidFill>
+                  <a:srgbClr val="26221B"/>
+                </a:solidFill>
+                <a:latin typeface="Georgia"/>
+              </a:rPr>
+              <a:t>• A large family tree poster gets printed with EVERYONE listed</a:t>
+            </a:r>
+          </a:p>
+        </p:txBody>
+      </p:sp>
+      <p:sp>
+        <p:nvSpPr>
+          <p:cNvPr id="5" name="TextBox 4"/>
+          <p:cNvSpPr txBox="1"/>
+          <p:nvPr/>
+        </p:nvSpPr>
+        <p:spPr>
+          <a:xfrm>
+            <a:off x="6400800" y="1645920"/>
+            <a:ext cx="5120640" cy="4114800"/>
+          </a:xfrm>
+          <a:prstGeom prst="rect">
+            <a:avLst/>
+          </a:prstGeom>
+          <a:noFill/>
+        </p:spPr>
+        <p:txBody>
+          <a:bodyPr wrap="square">
+            <a:spAutoFit/>
+          </a:bodyPr>
+          <a:lstStyle/>
+          <a:p>
+            <a:pPr algn="l">
+              <a:spcAft>
+                <a:spcPts val="800"/>
+              </a:spcAft>
+            </a:pPr>
+            <a:r>
+              <a:rPr sz="1700" b="1">
+                <a:solidFill>
+                  <a:srgbClr val="E65100"/>
+                </a:solidFill>
+                <a:latin typeface="Georgia"/>
+              </a:rPr>
+              <a:t>Ways to submit</a:t>
+            </a:r>
+          </a:p>
+          <a:p>
+            <a:pPr algn="l">
+              <a:spcAft>
+                <a:spcPts val="600"/>
+              </a:spcAft>
+            </a:pPr>
+            <a:r>
+              <a:rPr sz="1500" b="0">
+                <a:solidFill>
+                  <a:srgbClr val="26221B"/>
+                </a:solidFill>
+                <a:latin typeface="Georgia"/>
+              </a:rPr>
+              <a:t>• Online: the Family Tree Google Form, or the matching form on hnfamilyreunion.com</a:t>
+            </a:r>
+          </a:p>
+          <a:p>
+            <a:pPr algn="l">
+              <a:spcAft>
+                <a:spcPts val="600"/>
+              </a:spcAft>
+            </a:pPr>
+            <a:r>
+              <a:rPr sz="1500" b="0">
+                <a:solidFill>
+                  <a:srgbClr val="26221B"/>
+                </a:solidFill>
+                <a:latin typeface="Georgia"/>
+              </a:rPr>
+              <a:t>• Paper: forms at the Family Tree table all weekend</a:t>
+            </a:r>
+          </a:p>
+          <a:p>
+            <a:pPr algn="l">
+              <a:spcAft>
+                <a:spcPts val="600"/>
+              </a:spcAft>
+            </a:pPr>
+            <a:r>
+              <a:rPr sz="1500" b="0">
+                <a:solidFill>
+                  <a:srgbClr val="26221B"/>
+                </a:solidFill>
+                <a:latin typeface="Georgia"/>
+              </a:rPr>
+              <a:t>• Bring old photos, obituaries, bibles, deeds — we scan them on the spot (you keep the originals)</a:t>
+            </a:r>
+          </a:p>
+        </p:txBody>
+      </p:sp>
+    </p:spTree>
+  </p:cSld>
+  <p:clrMapOvr>
+    <a:masterClrMapping/>
+  </p:clrMapOvr>
+</p:sld>
+</file>
+
+<file path=ppt/slides/slide27.xml><?xml version="1.0" encoding="utf-8"?>
 <p:sld xmlns:a="http://schemas.openxmlformats.org/drawingml/2006/main" xmlns:p="http://schemas.openxmlformats.org/presentationml/2006/main" xmlns:r="http://schemas.openxmlformats.org/officeDocument/2006/relationships">
   <p:cSld>
     <p:bg>
@@ -10997,7 +11940,7 @@
 </p:sld>
 </file>
 
-<file path=ppt/slides/slide26.xml><?xml version="1.0" encoding="utf-8"?>
+<file path=ppt/slides/slide28.xml><?xml version="1.0" encoding="utf-8"?>
 <p:sld xmlns:a="http://schemas.openxmlformats.org/drawingml/2006/main" xmlns:p="http://schemas.openxmlformats.org/presentationml/2006/main" xmlns:r="http://schemas.openxmlformats.org/officeDocument/2006/relationships">
   <p:cSld>
     <p:bg>

</xml_diff>

<commit_message>
Expand board: Parliamentarian, Doorkeeper, Meditation Chair; Courtesy & Protocol committees
- Officers (now 12) each with exact duties: Secretary takes attendance;
  Sergeant-at-Arms guards the door (assisted by the new Doorkeeper);
  Parliamentarian advises on Robert's Rules and chairs the new Protocol
  Committee; Meditation Chair leads prayers, prayer requests, and the
  condolences report
- Hospitality committee renamed Courtesy Committee (still led by the
  Hospitality Chair) and now explicitly covers birthdays & accomplishments
  plus get-well/condolence cards
- Carried through constitution (md + web), deck, PPTX, committees page,
  sign-up form, business page, superlatives page, README

Co-Authored-By: Claude Fable 5 <noreply@anthropic.com>
Claude-Session: https://claude.ai/code/session_01NPnb9BRrqaoMRYjtDyxgui
</commit_message>
<xml_diff>
--- a/presentation/Harris-Nelson-Reunion-2026.pptx
+++ b/presentation/Harris-Nelson-Reunion-2026.pptx
@@ -6207,8 +6207,8 @@
           <p:nvPr/>
         </p:nvGraphicFramePr>
         <p:xfrm>
-          <a:off x="731520" y="1645920"/>
-          <a:ext cx="10698480" cy="4206240"/>
+          <a:off x="731520" y="1417320"/>
+          <a:ext cx="10698480" cy="4846320"/>
         </p:xfrm>
         <a:graphic>
           <a:graphicData uri="http://schemas.openxmlformats.org/drawingml/2006/table">
@@ -6221,7 +6221,7 @@
                 <a:gridCol w="2194560"/>
                 <a:gridCol w="5852160"/>
               </a:tblGrid>
-              <a:tr h="420624">
+              <a:tr h="372793">
                 <a:tc>
                   <a:txBody>
                     <a:bodyPr/>
@@ -6286,14 +6286,14 @@
                   </a:tcPr>
                 </a:tc>
               </a:tr>
-              <a:tr h="420624">
+              <a:tr h="372793">
                 <a:tc>
                   <a:txBody>
                     <a:bodyPr/>
                     <a:lstStyle/>
                     <a:p>
                       <a:r>
-                        <a:rPr sz="1200" b="0">
+                        <a:rPr sz="1000" b="0">
                           <a:solidFill>
                             <a:srgbClr val="26221B"/>
                           </a:solidFill>
@@ -6310,7 +6310,7 @@
                     <a:lstStyle/>
                     <a:p>
                       <a:r>
-                        <a:rPr sz="1200" b="1">
+                        <a:rPr sz="1000" b="1">
                           <a:solidFill>
                             <a:srgbClr val="26221B"/>
                           </a:solidFill>
@@ -6327,7 +6327,7 @@
                     <a:lstStyle/>
                     <a:p>
                       <a:r>
-                        <a:rPr sz="1200" b="0">
+                        <a:rPr sz="1000" b="0">
                           <a:solidFill>
                             <a:srgbClr val="26221B"/>
                           </a:solidFill>
@@ -6339,14 +6339,14 @@
                   <a:tcPr/>
                 </a:tc>
               </a:tr>
-              <a:tr h="420624">
+              <a:tr h="372793">
                 <a:tc>
                   <a:txBody>
                     <a:bodyPr/>
                     <a:lstStyle/>
                     <a:p>
                       <a:r>
-                        <a:rPr sz="1200" b="0">
+                        <a:rPr sz="1000" b="0">
                           <a:solidFill>
                             <a:srgbClr val="26221B"/>
                           </a:solidFill>
@@ -6363,7 +6363,7 @@
                     <a:lstStyle/>
                     <a:p>
                       <a:r>
-                        <a:rPr sz="1200" b="1">
+                        <a:rPr sz="1000" b="1">
                           <a:solidFill>
                             <a:srgbClr val="26221B"/>
                           </a:solidFill>
@@ -6380,7 +6380,7 @@
                     <a:lstStyle/>
                     <a:p>
                       <a:r>
-                        <a:rPr sz="1200" b="0">
+                        <a:rPr sz="1000" b="0">
                           <a:solidFill>
                             <a:srgbClr val="26221B"/>
                           </a:solidFill>
@@ -6392,14 +6392,14 @@
                   <a:tcPr/>
                 </a:tc>
               </a:tr>
-              <a:tr h="420624">
+              <a:tr h="372793">
                 <a:tc>
                   <a:txBody>
                     <a:bodyPr/>
                     <a:lstStyle/>
                     <a:p>
                       <a:r>
-                        <a:rPr sz="1200" b="0">
+                        <a:rPr sz="1000" b="0">
                           <a:solidFill>
                             <a:srgbClr val="26221B"/>
                           </a:solidFill>
@@ -6416,7 +6416,7 @@
                     <a:lstStyle/>
                     <a:p>
                       <a:r>
-                        <a:rPr sz="1200" b="1">
+                        <a:rPr sz="1000" b="1">
                           <a:solidFill>
                             <a:srgbClr val="26221B"/>
                           </a:solidFill>
@@ -6433,26 +6433,26 @@
                     <a:lstStyle/>
                     <a:p>
                       <a:r>
-                        <a:rPr sz="1200" b="0">
+                        <a:rPr sz="1000" b="0">
                           <a:solidFill>
                             <a:srgbClr val="26221B"/>
                           </a:solidFill>
                         </a:rPr>
-                        <a:t>Minutes, records, correspondence, notices</a:t>
+                        <a:t>Minutes; TAKES ATTENDANCE; records, correspondence &amp; notices</a:t>
                       </a:r>
                     </a:p>
                   </a:txBody>
                   <a:tcPr/>
                 </a:tc>
               </a:tr>
-              <a:tr h="420624">
+              <a:tr h="372793">
                 <a:tc>
                   <a:txBody>
                     <a:bodyPr/>
                     <a:lstStyle/>
                     <a:p>
                       <a:r>
-                        <a:rPr sz="1200" b="0">
+                        <a:rPr sz="1000" b="0">
                           <a:solidFill>
                             <a:srgbClr val="26221B"/>
                           </a:solidFill>
@@ -6469,7 +6469,7 @@
                     <a:lstStyle/>
                     <a:p>
                       <a:r>
-                        <a:rPr sz="1200" b="1">
+                        <a:rPr sz="1000" b="1">
                           <a:solidFill>
                             <a:srgbClr val="26221B"/>
                           </a:solidFill>
@@ -6486,7 +6486,7 @@
                     <a:lstStyle/>
                     <a:p>
                       <a:r>
-                        <a:rPr sz="1200" b="0">
+                        <a:rPr sz="1000" b="0">
                           <a:solidFill>
                             <a:srgbClr val="26221B"/>
                           </a:solidFill>
@@ -6498,14 +6498,14 @@
                   <a:tcPr/>
                 </a:tc>
               </a:tr>
-              <a:tr h="420624">
+              <a:tr h="372793">
                 <a:tc>
                   <a:txBody>
                     <a:bodyPr/>
                     <a:lstStyle/>
                     <a:p>
                       <a:r>
-                        <a:rPr sz="1200" b="0">
+                        <a:rPr sz="1000" b="0">
                           <a:solidFill>
                             <a:srgbClr val="26221B"/>
                           </a:solidFill>
@@ -6522,7 +6522,7 @@
                     <a:lstStyle/>
                     <a:p>
                       <a:r>
-                        <a:rPr sz="1200" b="1">
+                        <a:rPr sz="1000" b="1">
                           <a:solidFill>
                             <a:srgbClr val="26221B"/>
                           </a:solidFill>
@@ -6539,7 +6539,7 @@
                     <a:lstStyle/>
                     <a:p>
                       <a:r>
-                        <a:rPr sz="1200" b="0">
+                        <a:rPr sz="1000" b="0">
                           <a:solidFill>
                             <a:srgbClr val="26221B"/>
                           </a:solidFill>
@@ -6551,14 +6551,14 @@
                   <a:tcPr/>
                 </a:tc>
               </a:tr>
-              <a:tr h="420624">
+              <a:tr h="372793">
                 <a:tc>
                   <a:txBody>
                     <a:bodyPr/>
                     <a:lstStyle/>
                     <a:p>
                       <a:r>
-                        <a:rPr sz="1200" b="0">
+                        <a:rPr sz="1000" b="0">
                           <a:solidFill>
                             <a:srgbClr val="26221B"/>
                           </a:solidFill>
@@ -6575,7 +6575,7 @@
                     <a:lstStyle/>
                     <a:p>
                       <a:r>
-                        <a:rPr sz="1200" b="1">
+                        <a:rPr sz="1000" b="1">
                           <a:solidFill>
                             <a:srgbClr val="26221B"/>
                           </a:solidFill>
@@ -6592,7 +6592,7 @@
                     <a:lstStyle/>
                     <a:p>
                       <a:r>
-                        <a:rPr sz="1200" b="0">
+                        <a:rPr sz="1000" b="0">
                           <a:solidFill>
                             <a:srgbClr val="26221B"/>
                           </a:solidFill>
@@ -6604,19 +6604,19 @@
                   <a:tcPr/>
                 </a:tc>
               </a:tr>
-              <a:tr h="420624">
+              <a:tr h="372793">
                 <a:tc>
                   <a:txBody>
                     <a:bodyPr/>
                     <a:lstStyle/>
                     <a:p>
                       <a:r>
-                        <a:rPr sz="1200" b="0">
+                        <a:rPr sz="1000" b="0">
                           <a:solidFill>
                             <a:srgbClr val="26221B"/>
                           </a:solidFill>
                         </a:rPr>
-                        <a:t>Hospitality</a:t>
+                        <a:t>Hospitality Chair</a:t>
                       </a:r>
                     </a:p>
                   </a:txBody>
@@ -6628,7 +6628,7 @@
                     <a:lstStyle/>
                     <a:p>
                       <a:r>
-                        <a:rPr sz="1200" b="1">
+                        <a:rPr sz="1000" b="1">
                           <a:solidFill>
                             <a:srgbClr val="26221B"/>
                           </a:solidFill>
@@ -6645,26 +6645,26 @@
                     <a:lstStyle/>
                     <a:p>
                       <a:r>
-                        <a:rPr sz="1200" b="0">
+                        <a:rPr sz="1000" b="0">
                           <a:solidFill>
                             <a:srgbClr val="26221B"/>
                           </a:solidFill>
                         </a:rPr>
-                        <a:t>Welcome, elders' care, tables &amp; ushers</a:t>
+                        <a:t>Leads the COURTESY COMMITTEE: welcome, elders' care, tables &amp; ushers, birthdays &amp; accomplishments</a:t>
                       </a:r>
                     </a:p>
                   </a:txBody>
                   <a:tcPr/>
                 </a:tc>
               </a:tr>
-              <a:tr h="420624">
+              <a:tr h="372793">
                 <a:tc>
                   <a:txBody>
                     <a:bodyPr/>
                     <a:lstStyle/>
                     <a:p>
                       <a:r>
-                        <a:rPr sz="1200" b="0">
+                        <a:rPr sz="1000" b="0">
                           <a:solidFill>
                             <a:srgbClr val="26221B"/>
                           </a:solidFill>
@@ -6681,7 +6681,7 @@
                     <a:lstStyle/>
                     <a:p>
                       <a:r>
-                        <a:rPr sz="1200" b="1">
+                        <a:rPr sz="1000" b="1">
                           <a:solidFill>
                             <a:srgbClr val="26221B"/>
                           </a:solidFill>
@@ -6698,26 +6698,26 @@
                     <a:lstStyle/>
                     <a:p>
                       <a:r>
-                        <a:rPr sz="1200" b="0">
+                        <a:rPr sz="1000" b="0">
                           <a:solidFill>
                             <a:srgbClr val="26221B"/>
                           </a:solidFill>
                         </a:rPr>
-                        <a:t>Order at meetings &amp; events, safety</a:t>
+                        <a:t>Keeps order; GUARDS THE DOOR (assisted by the Doorkeeper); safety</a:t>
                       </a:r>
                     </a:p>
                   </a:txBody>
                   <a:tcPr/>
                 </a:tc>
               </a:tr>
-              <a:tr h="420624">
+              <a:tr h="372793">
                 <a:tc>
                   <a:txBody>
                     <a:bodyPr/>
                     <a:lstStyle/>
                     <a:p>
                       <a:r>
-                        <a:rPr sz="1200" b="0">
+                        <a:rPr sz="1000" b="0">
                           <a:solidFill>
                             <a:srgbClr val="26221B"/>
                           </a:solidFill>
@@ -6734,12 +6734,12 @@
                     <a:lstStyle/>
                     <a:p>
                       <a:r>
-                        <a:rPr sz="1200" b="1">
+                        <a:rPr sz="1000" b="1">
                           <a:solidFill>
                             <a:srgbClr val="26221B"/>
                           </a:solidFill>
                         </a:rPr>
-                        <a:t>[Open — nominate today!]</a:t>
+                        <a:t>[Open — vote today]</a:t>
                       </a:r>
                     </a:p>
                   </a:txBody>
@@ -6751,12 +6751,171 @@
                     <a:lstStyle/>
                     <a:p>
                       <a:r>
-                        <a:rPr sz="1200" b="0">
+                        <a:rPr sz="1000" b="0">
                           <a:solidFill>
                             <a:srgbClr val="26221B"/>
                           </a:solidFill>
                         </a:rPr>
                         <a:t>Membership roll &amp; recruitment; matches volunteers to committees</a:t>
+                      </a:r>
+                    </a:p>
+                  </a:txBody>
+                  <a:tcPr/>
+                </a:tc>
+              </a:tr>
+              <a:tr h="372793">
+                <a:tc>
+                  <a:txBody>
+                    <a:bodyPr/>
+                    <a:lstStyle/>
+                    <a:p>
+                      <a:r>
+                        <a:rPr sz="1000" b="0">
+                          <a:solidFill>
+                            <a:srgbClr val="26221B"/>
+                          </a:solidFill>
+                        </a:rPr>
+                        <a:t>Parliamentarian</a:t>
+                      </a:r>
+                    </a:p>
+                  </a:txBody>
+                  <a:tcPr/>
+                </a:tc>
+                <a:tc>
+                  <a:txBody>
+                    <a:bodyPr/>
+                    <a:lstStyle/>
+                    <a:p>
+                      <a:r>
+                        <a:rPr sz="1000" b="1">
+                          <a:solidFill>
+                            <a:srgbClr val="26221B"/>
+                          </a:solidFill>
+                        </a:rPr>
+                        <a:t>[Open — vote today]</a:t>
+                      </a:r>
+                    </a:p>
+                  </a:txBody>
+                  <a:tcPr/>
+                </a:tc>
+                <a:tc>
+                  <a:txBody>
+                    <a:bodyPr/>
+                    <a:lstStyle/>
+                    <a:p>
+                      <a:r>
+                        <a:rPr sz="1000" b="0">
+                          <a:solidFill>
+                            <a:srgbClr val="26221B"/>
+                          </a:solidFill>
+                        </a:rPr>
+                        <a:t>Advises on Robert's Rules; rules on points of order; CHAIRS THE PROTOCOL COMMITTEE</a:t>
+                      </a:r>
+                    </a:p>
+                  </a:txBody>
+                  <a:tcPr/>
+                </a:tc>
+              </a:tr>
+              <a:tr h="372793">
+                <a:tc>
+                  <a:txBody>
+                    <a:bodyPr/>
+                    <a:lstStyle/>
+                    <a:p>
+                      <a:r>
+                        <a:rPr sz="1000" b="0">
+                          <a:solidFill>
+                            <a:srgbClr val="26221B"/>
+                          </a:solidFill>
+                        </a:rPr>
+                        <a:t>Doorkeeper</a:t>
+                      </a:r>
+                    </a:p>
+                  </a:txBody>
+                  <a:tcPr/>
+                </a:tc>
+                <a:tc>
+                  <a:txBody>
+                    <a:bodyPr/>
+                    <a:lstStyle/>
+                    <a:p>
+                      <a:r>
+                        <a:rPr sz="1000" b="1">
+                          <a:solidFill>
+                            <a:srgbClr val="26221B"/>
+                          </a:solidFill>
+                        </a:rPr>
+                        <a:t>[Open — vote today]</a:t>
+                      </a:r>
+                    </a:p>
+                  </a:txBody>
+                  <a:tcPr/>
+                </a:tc>
+                <a:tc>
+                  <a:txBody>
+                    <a:bodyPr/>
+                    <a:lstStyle/>
+                    <a:p>
+                      <a:r>
+                        <a:rPr sz="1000" b="0">
+                          <a:solidFill>
+                            <a:srgbClr val="26221B"/>
+                          </a:solidFill>
+                        </a:rPr>
+                        <a:t>Assists the Sergeant-at-Arms: door check-in, controls entry during votes, carries messages</a:t>
+                      </a:r>
+                    </a:p>
+                  </a:txBody>
+                  <a:tcPr/>
+                </a:tc>
+              </a:tr>
+              <a:tr h="372804">
+                <a:tc>
+                  <a:txBody>
+                    <a:bodyPr/>
+                    <a:lstStyle/>
+                    <a:p>
+                      <a:r>
+                        <a:rPr sz="1000" b="0">
+                          <a:solidFill>
+                            <a:srgbClr val="26221B"/>
+                          </a:solidFill>
+                        </a:rPr>
+                        <a:t>Meditation Chair</a:t>
+                      </a:r>
+                    </a:p>
+                  </a:txBody>
+                  <a:tcPr/>
+                </a:tc>
+                <a:tc>
+                  <a:txBody>
+                    <a:bodyPr/>
+                    <a:lstStyle/>
+                    <a:p>
+                      <a:r>
+                        <a:rPr sz="1000" b="1">
+                          <a:solidFill>
+                            <a:srgbClr val="26221B"/>
+                          </a:solidFill>
+                        </a:rPr>
+                        <a:t>[Open — vote today]</a:t>
+                      </a:r>
+                    </a:p>
+                  </a:txBody>
+                  <a:tcPr/>
+                </a:tc>
+                <a:tc>
+                  <a:txBody>
+                    <a:bodyPr/>
+                    <a:lstStyle/>
+                    <a:p>
+                      <a:r>
+                        <a:rPr sz="1000" b="0">
+                          <a:solidFill>
+                            <a:srgbClr val="26221B"/>
+                          </a:solidFill>
+                        </a:rPr>
+                        <a:t>Leads prayers &amp; prayer requests; delivers the condolences report; memorials with Services</a:t>
                       </a:r>
                     </a:p>
                   </a:txBody>
@@ -7182,7 +7341,71 @@
                 </a:solidFill>
                 <a:latin typeface="Georgia"/>
               </a:rPr>
-              <a:t>• MEMBERSHIP CHAIR — a new board seat, open for nominations today</a:t>
+              <a:t>• Four new board seats, open for votes today:</a:t>
+            </a:r>
+          </a:p>
+          <a:p>
+            <a:pPr algn="l">
+              <a:spcAft>
+                <a:spcPts val="600"/>
+              </a:spcAft>
+            </a:pPr>
+            <a:r>
+              <a:rPr sz="1300" b="0">
+                <a:solidFill>
+                  <a:srgbClr val="26221B"/>
+                </a:solidFill>
+                <a:latin typeface="Georgia"/>
+              </a:rPr>
+              <a:t>• MEMBERSHIP CHAIR — roll &amp; recruitment</a:t>
+            </a:r>
+          </a:p>
+          <a:p>
+            <a:pPr algn="l">
+              <a:spcAft>
+                <a:spcPts val="600"/>
+              </a:spcAft>
+            </a:pPr>
+            <a:r>
+              <a:rPr sz="1300" b="0">
+                <a:solidFill>
+                  <a:srgbClr val="26221B"/>
+                </a:solidFill>
+                <a:latin typeface="Georgia"/>
+              </a:rPr>
+              <a:t>• PARLIAMENTARIAN — Robert's Rules + Protocol Committee</a:t>
+            </a:r>
+          </a:p>
+          <a:p>
+            <a:pPr algn="l">
+              <a:spcAft>
+                <a:spcPts val="600"/>
+              </a:spcAft>
+            </a:pPr>
+            <a:r>
+              <a:rPr sz="1300" b="0">
+                <a:solidFill>
+                  <a:srgbClr val="26221B"/>
+                </a:solidFill>
+                <a:latin typeface="Georgia"/>
+              </a:rPr>
+              <a:t>• DOORKEEPER — assists the Sergeant-at-Arms</a:t>
+            </a:r>
+          </a:p>
+          <a:p>
+            <a:pPr algn="l">
+              <a:spcAft>
+                <a:spcPts val="600"/>
+              </a:spcAft>
+            </a:pPr>
+            <a:r>
+              <a:rPr sz="1300" b="0">
+                <a:solidFill>
+                  <a:srgbClr val="26221B"/>
+                </a:solidFill>
+                <a:latin typeface="Georgia"/>
+              </a:rPr>
+              <a:t>• MEDITATION CHAIR — prayers &amp; condolences report</a:t>
             </a:r>
           </a:p>
           <a:p>
@@ -7735,7 +7958,7 @@
         </p:nvSpPr>
         <p:spPr>
           <a:xfrm>
-            <a:off x="731520" y="1600200"/>
+            <a:off x="731520" y="1554480"/>
             <a:ext cx="3566160" cy="868680"/>
           </a:xfrm>
           <a:prstGeom prst="rect">
@@ -7790,7 +8013,7 @@
         </p:nvSpPr>
         <p:spPr>
           <a:xfrm>
-            <a:off x="4480559" y="1600200"/>
+            <a:off x="4480559" y="1554480"/>
             <a:ext cx="3566160" cy="868680"/>
           </a:xfrm>
           <a:prstGeom prst="rect">
@@ -7845,7 +8068,7 @@
         </p:nvSpPr>
         <p:spPr>
           <a:xfrm>
-            <a:off x="8229600" y="1600200"/>
+            <a:off x="8229600" y="1554480"/>
             <a:ext cx="3566160" cy="868680"/>
           </a:xfrm>
           <a:prstGeom prst="rect">
@@ -7900,7 +8123,7 @@
         </p:nvSpPr>
         <p:spPr>
           <a:xfrm>
-            <a:off x="731520" y="2560320"/>
+            <a:off x="731520" y="2331720"/>
             <a:ext cx="3566160" cy="868680"/>
           </a:xfrm>
           <a:prstGeom prst="rect">
@@ -7955,7 +8178,7 @@
         </p:nvSpPr>
         <p:spPr>
           <a:xfrm>
-            <a:off x="4480559" y="2560320"/>
+            <a:off x="4480559" y="2331720"/>
             <a:ext cx="3566160" cy="868680"/>
           </a:xfrm>
           <a:prstGeom prst="rect">
@@ -8010,7 +8233,7 @@
         </p:nvSpPr>
         <p:spPr>
           <a:xfrm>
-            <a:off x="8229600" y="2560320"/>
+            <a:off x="8229600" y="2331720"/>
             <a:ext cx="3566160" cy="868680"/>
           </a:xfrm>
           <a:prstGeom prst="rect">
@@ -8065,7 +8288,7 @@
         </p:nvSpPr>
         <p:spPr>
           <a:xfrm>
-            <a:off x="731520" y="3520440"/>
+            <a:off x="731520" y="3108960"/>
             <a:ext cx="3566160" cy="868680"/>
           </a:xfrm>
           <a:prstGeom prst="rect">
@@ -8120,7 +8343,7 @@
         </p:nvSpPr>
         <p:spPr>
           <a:xfrm>
-            <a:off x="4480559" y="3520440"/>
+            <a:off x="4480559" y="3108960"/>
             <a:ext cx="3566160" cy="868680"/>
           </a:xfrm>
           <a:prstGeom prst="rect">
@@ -8175,7 +8398,7 @@
         </p:nvSpPr>
         <p:spPr>
           <a:xfrm>
-            <a:off x="8229600" y="3520440"/>
+            <a:off x="8229600" y="3108960"/>
             <a:ext cx="3566160" cy="868680"/>
           </a:xfrm>
           <a:prstGeom prst="rect">
@@ -8230,7 +8453,117 @@
         </p:nvSpPr>
         <p:spPr>
           <a:xfrm>
-            <a:off x="640080" y="4572000"/>
+            <a:off x="731520" y="3886200"/>
+            <a:ext cx="3566160" cy="868680"/>
+          </a:xfrm>
+          <a:prstGeom prst="rect">
+            <a:avLst/>
+          </a:prstGeom>
+          <a:noFill/>
+        </p:spPr>
+        <p:txBody>
+          <a:bodyPr wrap="square">
+            <a:spAutoFit/>
+          </a:bodyPr>
+          <a:lstStyle/>
+          <a:p>
+            <a:pPr algn="l">
+              <a:spcAft>
+                <a:spcPts val="100"/>
+              </a:spcAft>
+            </a:pPr>
+            <a:r>
+              <a:rPr sz="1600" b="1">
+                <a:solidFill>
+                  <a:srgbClr val="1B5E20"/>
+                </a:solidFill>
+                <a:latin typeface="Georgia"/>
+              </a:rPr>
+              <a:t>💐 Courtesy (led by the Hospitality Chair)</a:t>
+            </a:r>
+          </a:p>
+          <a:p>
+            <a:pPr algn="l">
+              <a:spcAft>
+                <a:spcPts val="600"/>
+              </a:spcAft>
+            </a:pPr>
+            <a:r>
+              <a:rPr sz="1200" b="0">
+                <a:solidFill>
+                  <a:srgbClr val="6B6355"/>
+                </a:solidFill>
+                <a:latin typeface="Georgia"/>
+              </a:rPr>
+              <a:t>Chair: [sign up] · Members: [sign up]</a:t>
+            </a:r>
+          </a:p>
+        </p:txBody>
+      </p:sp>
+      <p:sp>
+        <p:nvSpPr>
+          <p:cNvPr id="14" name="TextBox 13"/>
+          <p:cNvSpPr txBox="1"/>
+          <p:nvPr/>
+        </p:nvSpPr>
+        <p:spPr>
+          <a:xfrm>
+            <a:off x="4480559" y="3886200"/>
+            <a:ext cx="3566160" cy="868680"/>
+          </a:xfrm>
+          <a:prstGeom prst="rect">
+            <a:avLst/>
+          </a:prstGeom>
+          <a:noFill/>
+        </p:spPr>
+        <p:txBody>
+          <a:bodyPr wrap="square">
+            <a:spAutoFit/>
+          </a:bodyPr>
+          <a:lstStyle/>
+          <a:p>
+            <a:pPr algn="l">
+              <a:spcAft>
+                <a:spcPts val="100"/>
+              </a:spcAft>
+            </a:pPr>
+            <a:r>
+              <a:rPr sz="1600" b="1">
+                <a:solidFill>
+                  <a:srgbClr val="1B5E20"/>
+                </a:solidFill>
+                <a:latin typeface="Georgia"/>
+              </a:rPr>
+              <a:t>📜 Protocol (chaired by the Parliamentarian)</a:t>
+            </a:r>
+          </a:p>
+          <a:p>
+            <a:pPr algn="l">
+              <a:spcAft>
+                <a:spcPts val="600"/>
+              </a:spcAft>
+            </a:pPr>
+            <a:r>
+              <a:rPr sz="1200" b="0">
+                <a:solidFill>
+                  <a:srgbClr val="6B6355"/>
+                </a:solidFill>
+                <a:latin typeface="Georgia"/>
+              </a:rPr>
+              <a:t>Chair: [sign up] · Members: [sign up]</a:t>
+            </a:r>
+          </a:p>
+        </p:txBody>
+      </p:sp>
+      <p:sp>
+        <p:nvSpPr>
+          <p:cNvPr id="15" name="TextBox 14"/>
+          <p:cNvSpPr txBox="1"/>
+          <p:nvPr/>
+        </p:nvSpPr>
+        <p:spPr>
+          <a:xfrm>
+            <a:off x="640080" y="4800600"/>
             <a:ext cx="5669280" cy="1828800"/>
           </a:xfrm>
           <a:prstGeom prst="rect">
@@ -8311,13 +8644,13 @@
       </p:sp>
       <p:sp>
         <p:nvSpPr>
-          <p:cNvPr id="14" name="TextBox 13"/>
-          <p:cNvSpPr txBox="1"/>
-          <p:nvPr/>
-        </p:nvSpPr>
-        <p:spPr>
-          <a:xfrm>
-            <a:off x="6583680" y="4572000"/>
+          <p:cNvPr id="16" name="TextBox 15"/>
+          <p:cNvSpPr txBox="1"/>
+          <p:nvPr/>
+        </p:nvSpPr>
+        <p:spPr>
+          <a:xfrm>
+            <a:off x="6583680" y="4800600"/>
             <a:ext cx="4937760" cy="1828800"/>
           </a:xfrm>
           <a:prstGeom prst="rect">

</xml_diff>

<commit_message>
Add open-chairs slide: the nine unassigned committee chair seats with duties
Co-Authored-By: Claude Fable 5 <noreply@anthropic.com>
Claude-Session: https://claude.ai/code/session_01NPnb9BRrqaoMRYjtDyxgui
</commit_message>
<xml_diff>
--- a/presentation/Harris-Nelson-Reunion-2026.pptx
+++ b/presentation/Harris-Nelson-Reunion-2026.pptx
@@ -33,6 +33,7 @@
     <p:sldId id="281" r:id="rId32"/>
     <p:sldId id="282" r:id="rId33"/>
     <p:sldId id="283" r:id="rId34"/>
+    <p:sldId id="284" r:id="rId35"/>
   </p:sldIdLst>
   <p:sldSz cx="12191695" cy="6858000" type="screen4x3"/>
   <p:notesSz cx="6858000" cy="9144000"/>
@@ -7906,7 +7907,7 @@
                 </a:solidFill>
                 <a:latin typeface="Verdana"/>
               </a:rPr>
-              <a:t>FAMILY BUSINESS · COMMITTEES</a:t>
+              <a:t>FAMILY BUSINESS · OPEN SEATS</a:t>
             </a:r>
           </a:p>
         </p:txBody>
@@ -7945,7 +7946,7 @@
                 </a:solidFill>
                 <a:latin typeface="Georgia"/>
               </a:rPr>
-              <a:t>Committees Need Chairs — That Means YOU 🙋</a:t>
+              <a:t>Nine Committee Chairs Still Need a Name Next to Them 📋</a:t>
             </a:r>
           </a:p>
         </p:txBody>
@@ -7958,8 +7959,8 @@
         </p:nvSpPr>
         <p:spPr>
           <a:xfrm>
-            <a:off x="731520" y="1554480"/>
-            <a:ext cx="3566160" cy="868680"/>
+            <a:off x="731520" y="1600200"/>
+            <a:ext cx="3566160" cy="1280160"/>
           </a:xfrm>
           <a:prstGeom prst="rect">
             <a:avLst/>
@@ -7978,29 +7979,29 @@
               </a:spcAft>
             </a:pPr>
             <a:r>
-              <a:rPr sz="1600" b="1">
-                <a:solidFill>
-                  <a:srgbClr val="1B5E20"/>
-                </a:solidFill>
-                <a:latin typeface="Georgia"/>
-              </a:rPr>
-              <a:t>🏈 Sports / Games</a:t>
-            </a:r>
-          </a:p>
-          <a:p>
-            <a:pPr algn="l">
-              <a:spcAft>
-                <a:spcPts val="600"/>
-              </a:spcAft>
-            </a:pPr>
-            <a:r>
-              <a:rPr sz="1200" b="0">
+              <a:rPr sz="1400" b="1">
+                <a:solidFill>
+                  <a:srgbClr val="E65100"/>
+                </a:solidFill>
+                <a:latin typeface="Georgia"/>
+              </a:rPr>
+              <a:t>🏈 Sports / Games Chair — OPEN</a:t>
+            </a:r>
+          </a:p>
+          <a:p>
+            <a:pPr algn="l">
+              <a:spcAft>
+                <a:spcPts val="600"/>
+              </a:spcAft>
+            </a:pPr>
+            <a:r>
+              <a:rPr sz="1100" b="0">
                 <a:solidFill>
                   <a:srgbClr val="6B6355"/>
                 </a:solidFill>
                 <a:latin typeface="Georgia"/>
               </a:rPr>
-              <a:t>Chair: [sign up] · Members: [sign up]</a:t>
+              <a:t>tournaments, kids' games, family Olympics, spades &amp; dominoes brackets</a:t>
             </a:r>
           </a:p>
         </p:txBody>
@@ -8013,8 +8014,8 @@
         </p:nvSpPr>
         <p:spPr>
           <a:xfrm>
-            <a:off x="4480559" y="1554480"/>
-            <a:ext cx="3566160" cy="868680"/>
+            <a:off x="4480559" y="1600200"/>
+            <a:ext cx="3566160" cy="1280160"/>
           </a:xfrm>
           <a:prstGeom prst="rect">
             <a:avLst/>
@@ -8033,29 +8034,29 @@
               </a:spcAft>
             </a:pPr>
             <a:r>
-              <a:rPr sz="1600" b="1">
-                <a:solidFill>
-                  <a:srgbClr val="1B5E20"/>
-                </a:solidFill>
-                <a:latin typeface="Georgia"/>
-              </a:rPr>
-              <a:t>🎶 Music</a:t>
-            </a:r>
-          </a:p>
-          <a:p>
-            <a:pPr algn="l">
-              <a:spcAft>
-                <a:spcPts val="600"/>
-              </a:spcAft>
-            </a:pPr>
-            <a:r>
-              <a:rPr sz="1200" b="0">
+              <a:rPr sz="1400" b="1">
+                <a:solidFill>
+                  <a:srgbClr val="E65100"/>
+                </a:solidFill>
+                <a:latin typeface="Georgia"/>
+              </a:rPr>
+              <a:t>🎶 Music Chair — OPEN</a:t>
+            </a:r>
+          </a:p>
+          <a:p>
+            <a:pPr algn="l">
+              <a:spcAft>
+                <a:spcPts val="600"/>
+              </a:spcAft>
+            </a:pPr>
+            <a:r>
+              <a:rPr sz="1100" b="0">
                 <a:solidFill>
                   <a:srgbClr val="6B6355"/>
                 </a:solidFill>
                 <a:latin typeface="Georgia"/>
               </a:rPr>
-              <a:t>Chair: [sign up] · Members: [sign up]</a:t>
+              <a:t>DJ &amp; playlists, line-dance sets, old-school hour, banquet music</a:t>
             </a:r>
           </a:p>
         </p:txBody>
@@ -8068,8 +8069,8 @@
         </p:nvSpPr>
         <p:spPr>
           <a:xfrm>
-            <a:off x="8229600" y="1554480"/>
-            <a:ext cx="3566160" cy="868680"/>
+            <a:off x="8229600" y="1600200"/>
+            <a:ext cx="3566160" cy="1280160"/>
           </a:xfrm>
           <a:prstGeom prst="rect">
             <a:avLst/>
@@ -8088,29 +8089,29 @@
               </a:spcAft>
             </a:pPr>
             <a:r>
-              <a:rPr sz="1600" b="1">
-                <a:solidFill>
-                  <a:srgbClr val="1B5E20"/>
-                </a:solidFill>
-                <a:latin typeface="Georgia"/>
-              </a:rPr>
-              <a:t>🍽 Food</a:t>
-            </a:r>
-          </a:p>
-          <a:p>
-            <a:pPr algn="l">
-              <a:spcAft>
-                <a:spcPts val="600"/>
-              </a:spcAft>
-            </a:pPr>
-            <a:r>
-              <a:rPr sz="1200" b="0">
+              <a:rPr sz="1400" b="1">
+                <a:solidFill>
+                  <a:srgbClr val="E65100"/>
+                </a:solidFill>
+                <a:latin typeface="Georgia"/>
+              </a:rPr>
+              <a:t>🍽 Food Chair — OPEN</a:t>
+            </a:r>
+          </a:p>
+          <a:p>
+            <a:pPr algn="l">
+              <a:spcAft>
+                <a:spcPts val="600"/>
+              </a:spcAft>
+            </a:pPr>
+            <a:r>
+              <a:rPr sz="1100" b="0">
                 <a:solidFill>
                   <a:srgbClr val="6B6355"/>
                 </a:solidFill>
                 <a:latin typeface="Georgia"/>
               </a:rPr>
-              <a:t>Chair: [sign up] · Members: [sign up]</a:t>
+              <a:t>caterers, menus, the cookout &amp; potluck, family cookbook</a:t>
             </a:r>
           </a:p>
         </p:txBody>
@@ -8123,8 +8124,8 @@
         </p:nvSpPr>
         <p:spPr>
           <a:xfrm>
-            <a:off x="731520" y="2331720"/>
-            <a:ext cx="3566160" cy="868680"/>
+            <a:off x="731520" y="2971800"/>
+            <a:ext cx="3566160" cy="1280160"/>
           </a:xfrm>
           <a:prstGeom prst="rect">
             <a:avLst/>
@@ -8143,29 +8144,29 @@
               </a:spcAft>
             </a:pPr>
             <a:r>
-              <a:rPr sz="1600" b="1">
-                <a:solidFill>
-                  <a:srgbClr val="1B5E20"/>
-                </a:solidFill>
-                <a:latin typeface="Georgia"/>
-              </a:rPr>
-              <a:t>🦺 Safety</a:t>
-            </a:r>
-          </a:p>
-          <a:p>
-            <a:pPr algn="l">
-              <a:spcAft>
-                <a:spcPts val="600"/>
-              </a:spcAft>
-            </a:pPr>
-            <a:r>
-              <a:rPr sz="1200" b="0">
+              <a:rPr sz="1400" b="1">
+                <a:solidFill>
+                  <a:srgbClr val="E65100"/>
+                </a:solidFill>
+                <a:latin typeface="Georgia"/>
+              </a:rPr>
+              <a:t>🦺 Safety Chair — OPEN</a:t>
+            </a:r>
+          </a:p>
+          <a:p>
+            <a:pPr algn="l">
+              <a:spcAft>
+                <a:spcPts val="600"/>
+              </a:spcAft>
+            </a:pPr>
+            <a:r>
+              <a:rPr sz="1100" b="0">
                 <a:solidFill>
                   <a:srgbClr val="6B6355"/>
                 </a:solidFill>
                 <a:latin typeface="Georgia"/>
               </a:rPr>
-              <a:t>Chair: [sign up] · Members: [sign up]</a:t>
+              <a:t>first aid, headcounts, weather plans — with the Sergeant-at-Arms</a:t>
             </a:r>
           </a:p>
         </p:txBody>
@@ -8178,8 +8179,8 @@
         </p:nvSpPr>
         <p:spPr>
           <a:xfrm>
-            <a:off x="4480559" y="2331720"/>
-            <a:ext cx="3566160" cy="868680"/>
+            <a:off x="4480559" y="2971800"/>
+            <a:ext cx="3566160" cy="1280160"/>
           </a:xfrm>
           <a:prstGeom prst="rect">
             <a:avLst/>
@@ -8198,29 +8199,29 @@
               </a:spcAft>
             </a:pPr>
             <a:r>
-              <a:rPr sz="1600" b="1">
-                <a:solidFill>
-                  <a:srgbClr val="1B5E20"/>
-                </a:solidFill>
-                <a:latin typeface="Georgia"/>
-              </a:rPr>
-              <a:t>🙏 Services</a:t>
-            </a:r>
-          </a:p>
-          <a:p>
-            <a:pPr algn="l">
-              <a:spcAft>
-                <a:spcPts val="600"/>
-              </a:spcAft>
-            </a:pPr>
-            <a:r>
-              <a:rPr sz="1200" b="0">
+              <a:rPr sz="1400" b="1">
+                <a:solidFill>
+                  <a:srgbClr val="E65100"/>
+                </a:solidFill>
+                <a:latin typeface="Georgia"/>
+              </a:rPr>
+              <a:t>🙏 Services Chair — OPEN</a:t>
+            </a:r>
+          </a:p>
+          <a:p>
+            <a:pPr algn="l">
+              <a:spcAft>
+                <a:spcPts val="600"/>
+              </a:spcAft>
+            </a:pPr>
+            <a:r>
+              <a:rPr sz="1100" b="0">
                 <a:solidFill>
                   <a:srgbClr val="6B6355"/>
                 </a:solidFill>
                 <a:latin typeface="Georgia"/>
               </a:rPr>
-              <a:t>Chair: [sign up] · Members: [sign up]</a:t>
+              <a:t>Sunday worship, memorial tribute, elder care — with the Meditation Chair</a:t>
             </a:r>
           </a:p>
         </p:txBody>
@@ -8233,8 +8234,8 @@
         </p:nvSpPr>
         <p:spPr>
           <a:xfrm>
-            <a:off x="8229600" y="2331720"/>
-            <a:ext cx="3566160" cy="868680"/>
+            <a:off x="8229600" y="2971800"/>
+            <a:ext cx="3566160" cy="1280160"/>
           </a:xfrm>
           <a:prstGeom prst="rect">
             <a:avLst/>
@@ -8253,29 +8254,29 @@
               </a:spcAft>
             </a:pPr>
             <a:r>
-              <a:rPr sz="1600" b="1">
-                <a:solidFill>
-                  <a:srgbClr val="1B5E20"/>
-                </a:solidFill>
-                <a:latin typeface="Georgia"/>
-              </a:rPr>
-              <a:t>📸 Photography</a:t>
-            </a:r>
-          </a:p>
-          <a:p>
-            <a:pPr algn="l">
-              <a:spcAft>
-                <a:spcPts val="600"/>
-              </a:spcAft>
-            </a:pPr>
-            <a:r>
-              <a:rPr sz="1200" b="0">
+              <a:rPr sz="1400" b="1">
+                <a:solidFill>
+                  <a:srgbClr val="E65100"/>
+                </a:solidFill>
+                <a:latin typeface="Georgia"/>
+              </a:rPr>
+              <a:t>📸 Photography Chair — OPEN</a:t>
+            </a:r>
+          </a:p>
+          <a:p>
+            <a:pPr algn="l">
+              <a:spcAft>
+                <a:spcPts val="600"/>
+              </a:spcAft>
+            </a:pPr>
+            <a:r>
+              <a:rPr sz="1100" b="0">
                 <a:solidFill>
                   <a:srgbClr val="6B6355"/>
                 </a:solidFill>
                 <a:latin typeface="Georgia"/>
               </a:rPr>
-              <a:t>Chair: [sign up] · Members: [sign up]</a:t>
+              <a:t>photographer &amp; videographer, branch portraits, yearbook photos</a:t>
             </a:r>
           </a:p>
         </p:txBody>
@@ -8288,8 +8289,8 @@
         </p:nvSpPr>
         <p:spPr>
           <a:xfrm>
-            <a:off x="731520" y="3108960"/>
-            <a:ext cx="3566160" cy="868680"/>
+            <a:off x="731520" y="4343400"/>
+            <a:ext cx="3566160" cy="1280160"/>
           </a:xfrm>
           <a:prstGeom prst="rect">
             <a:avLst/>
@@ -8308,29 +8309,29 @@
               </a:spcAft>
             </a:pPr>
             <a:r>
-              <a:rPr sz="1600" b="1">
-                <a:solidFill>
-                  <a:srgbClr val="1B5E20"/>
-                </a:solidFill>
-                <a:latin typeface="Georgia"/>
-              </a:rPr>
-              <a:t>💝 Philanthropy &amp; Fundraising</a:t>
-            </a:r>
-          </a:p>
-          <a:p>
-            <a:pPr algn="l">
-              <a:spcAft>
-                <a:spcPts val="600"/>
-              </a:spcAft>
-            </a:pPr>
-            <a:r>
-              <a:rPr sz="1200" b="0">
+              <a:rPr sz="1400" b="1">
+                <a:solidFill>
+                  <a:srgbClr val="E65100"/>
+                </a:solidFill>
+                <a:latin typeface="Georgia"/>
+              </a:rPr>
+              <a:t>💝 Philanthropy &amp; Fundraising Chair — OPEN</a:t>
+            </a:r>
+          </a:p>
+          <a:p>
+            <a:pPr algn="l">
+              <a:spcAft>
+                <a:spcPts val="600"/>
+              </a:spcAft>
+            </a:pPr>
+            <a:r>
+              <a:rPr sz="1100" b="0">
                 <a:solidFill>
                   <a:srgbClr val="6B6355"/>
                 </a:solidFill>
                 <a:latin typeface="Georgia"/>
               </a:rPr>
-              <a:t>Chair: [sign up] · Members: [sign up]</a:t>
+              <a:t>fundraisers for all three funds; scholarship &amp; hardship review</a:t>
             </a:r>
           </a:p>
         </p:txBody>
@@ -8343,8 +8344,8 @@
         </p:nvSpPr>
         <p:spPr>
           <a:xfrm>
-            <a:off x="4480559" y="3108960"/>
-            <a:ext cx="3566160" cy="868680"/>
+            <a:off x="4480559" y="4343400"/>
+            <a:ext cx="3566160" cy="1280160"/>
           </a:xfrm>
           <a:prstGeom prst="rect">
             <a:avLst/>
@@ -8363,29 +8364,29 @@
               </a:spcAft>
             </a:pPr>
             <a:r>
-              <a:rPr sz="1600" b="1">
-                <a:solidFill>
-                  <a:srgbClr val="1B5E20"/>
-                </a:solidFill>
-                <a:latin typeface="Georgia"/>
-              </a:rPr>
-              <a:t>🗓 Planning</a:t>
-            </a:r>
-          </a:p>
-          <a:p>
-            <a:pPr algn="l">
-              <a:spcAft>
-                <a:spcPts val="600"/>
-              </a:spcAft>
-            </a:pPr>
-            <a:r>
-              <a:rPr sz="1200" b="0">
+              <a:rPr sz="1400" b="1">
+                <a:solidFill>
+                  <a:srgbClr val="E65100"/>
+                </a:solidFill>
+                <a:latin typeface="Georgia"/>
+              </a:rPr>
+              <a:t>🗓 Planning Chair — OPEN</a:t>
+            </a:r>
+          </a:p>
+          <a:p>
+            <a:pPr algn="l">
+              <a:spcAft>
+                <a:spcPts val="600"/>
+              </a:spcAft>
+            </a:pPr>
+            <a:r>
+              <a:rPr sz="1100" b="0">
                 <a:solidFill>
                   <a:srgbClr val="6B6355"/>
                 </a:solidFill>
                 <a:latin typeface="Georgia"/>
               </a:rPr>
-              <a:t>Chair: [sign up] · Members: [sign up]</a:t>
+              <a:t>dates, venues, decade planning, budgets, registration</a:t>
             </a:r>
           </a:p>
         </p:txBody>
@@ -8398,8 +8399,8 @@
         </p:nvSpPr>
         <p:spPr>
           <a:xfrm>
-            <a:off x="8229600" y="3108960"/>
-            <a:ext cx="3566160" cy="868680"/>
+            <a:off x="8229600" y="4343400"/>
+            <a:ext cx="3566160" cy="1280160"/>
           </a:xfrm>
           <a:prstGeom prst="rect">
             <a:avLst/>
@@ -8418,29 +8419,29 @@
               </a:spcAft>
             </a:pPr>
             <a:r>
-              <a:rPr sz="1600" b="1">
-                <a:solidFill>
-                  <a:srgbClr val="1B5E20"/>
-                </a:solidFill>
-                <a:latin typeface="Georgia"/>
-              </a:rPr>
-              <a:t>💻 Technology</a:t>
-            </a:r>
-          </a:p>
-          <a:p>
-            <a:pPr algn="l">
-              <a:spcAft>
-                <a:spcPts val="600"/>
-              </a:spcAft>
-            </a:pPr>
-            <a:r>
-              <a:rPr sz="1200" b="0">
+              <a:rPr sz="1400" b="1">
+                <a:solidFill>
+                  <a:srgbClr val="E65100"/>
+                </a:solidFill>
+                <a:latin typeface="Georgia"/>
+              </a:rPr>
+              <a:t>💻 Technology Chair — OPEN</a:t>
+            </a:r>
+          </a:p>
+          <a:p>
+            <a:pPr algn="l">
+              <a:spcAft>
+                <a:spcPts val="600"/>
+              </a:spcAft>
+            </a:pPr>
+            <a:r>
+              <a:rPr sz="1100" b="0">
                 <a:solidFill>
                   <a:srgbClr val="6B6355"/>
                 </a:solidFill>
                 <a:latin typeface="Georgia"/>
               </a:rPr>
-              <a:t>Chair: [sign up] · Members: [sign up]</a:t>
+              <a:t>hnfamilyreunion.com, online payments &amp; shirts, tree tools</a:t>
             </a:r>
           </a:p>
         </p:txBody>
@@ -8453,278 +8454,33 @@
         </p:nvSpPr>
         <p:spPr>
           <a:xfrm>
-            <a:off x="731520" y="3886200"/>
-            <a:ext cx="3566160" cy="868680"/>
-          </a:xfrm>
-          <a:prstGeom prst="rect">
-            <a:avLst/>
-          </a:prstGeom>
-          <a:noFill/>
-        </p:spPr>
-        <p:txBody>
-          <a:bodyPr wrap="square">
-            <a:spAutoFit/>
-          </a:bodyPr>
-          <a:lstStyle/>
-          <a:p>
-            <a:pPr algn="l">
-              <a:spcAft>
-                <a:spcPts val="100"/>
-              </a:spcAft>
-            </a:pPr>
-            <a:r>
-              <a:rPr sz="1600" b="1">
-                <a:solidFill>
-                  <a:srgbClr val="1B5E20"/>
-                </a:solidFill>
-                <a:latin typeface="Georgia"/>
-              </a:rPr>
-              <a:t>💐 Courtesy (led by the Hospitality Chair)</a:t>
-            </a:r>
-          </a:p>
-          <a:p>
-            <a:pPr algn="l">
-              <a:spcAft>
-                <a:spcPts val="600"/>
-              </a:spcAft>
-            </a:pPr>
-            <a:r>
-              <a:rPr sz="1200" b="0">
+            <a:off x="640080" y="6291072"/>
+            <a:ext cx="10911535" cy="457200"/>
+          </a:xfrm>
+          <a:prstGeom prst="rect">
+            <a:avLst/>
+          </a:prstGeom>
+          <a:noFill/>
+        </p:spPr>
+        <p:txBody>
+          <a:bodyPr wrap="square">
+            <a:spAutoFit/>
+          </a:bodyPr>
+          <a:lstStyle/>
+          <a:p>
+            <a:pPr algn="l">
+              <a:spcAft>
+                <a:spcPts val="600"/>
+              </a:spcAft>
+            </a:pPr>
+            <a:r>
+              <a:rPr sz="1100" b="0">
                 <a:solidFill>
                   <a:srgbClr val="6B6355"/>
                 </a:solidFill>
-                <a:latin typeface="Georgia"/>
-              </a:rPr>
-              <a:t>Chair: [sign up] · Members: [sign up]</a:t>
-            </a:r>
-          </a:p>
-        </p:txBody>
-      </p:sp>
-      <p:sp>
-        <p:nvSpPr>
-          <p:cNvPr id="14" name="TextBox 13"/>
-          <p:cNvSpPr txBox="1"/>
-          <p:nvPr/>
-        </p:nvSpPr>
-        <p:spPr>
-          <a:xfrm>
-            <a:off x="4480559" y="3886200"/>
-            <a:ext cx="3566160" cy="868680"/>
-          </a:xfrm>
-          <a:prstGeom prst="rect">
-            <a:avLst/>
-          </a:prstGeom>
-          <a:noFill/>
-        </p:spPr>
-        <p:txBody>
-          <a:bodyPr wrap="square">
-            <a:spAutoFit/>
-          </a:bodyPr>
-          <a:lstStyle/>
-          <a:p>
-            <a:pPr algn="l">
-              <a:spcAft>
-                <a:spcPts val="100"/>
-              </a:spcAft>
-            </a:pPr>
-            <a:r>
-              <a:rPr sz="1600" b="1">
-                <a:solidFill>
-                  <a:srgbClr val="1B5E20"/>
-                </a:solidFill>
-                <a:latin typeface="Georgia"/>
-              </a:rPr>
-              <a:t>📜 Protocol (chaired by the Parliamentarian)</a:t>
-            </a:r>
-          </a:p>
-          <a:p>
-            <a:pPr algn="l">
-              <a:spcAft>
-                <a:spcPts val="600"/>
-              </a:spcAft>
-            </a:pPr>
-            <a:r>
-              <a:rPr sz="1200" b="0">
-                <a:solidFill>
-                  <a:srgbClr val="6B6355"/>
-                </a:solidFill>
-                <a:latin typeface="Georgia"/>
-              </a:rPr>
-              <a:t>Chair: [sign up] · Members: [sign up]</a:t>
-            </a:r>
-          </a:p>
-        </p:txBody>
-      </p:sp>
-      <p:sp>
-        <p:nvSpPr>
-          <p:cNvPr id="15" name="TextBox 14"/>
-          <p:cNvSpPr txBox="1"/>
-          <p:nvPr/>
-        </p:nvSpPr>
-        <p:spPr>
-          <a:xfrm>
-            <a:off x="640080" y="4800600"/>
-            <a:ext cx="5669280" cy="1828800"/>
-          </a:xfrm>
-          <a:prstGeom prst="rect">
-            <a:avLst/>
-          </a:prstGeom>
-          <a:noFill/>
-        </p:spPr>
-        <p:txBody>
-          <a:bodyPr wrap="square">
-            <a:spAutoFit/>
-          </a:bodyPr>
-          <a:lstStyle/>
-          <a:p>
-            <a:pPr algn="l">
-              <a:spcAft>
-                <a:spcPts val="800"/>
-              </a:spcAft>
-            </a:pPr>
-            <a:r>
-              <a:rPr sz="1500" b="1">
-                <a:solidFill>
-                  <a:srgbClr val="2E7D32"/>
-                </a:solidFill>
-                <a:latin typeface="Georgia"/>
-              </a:rPr>
-              <a:t>How committees operate</a:t>
-            </a:r>
-          </a:p>
-          <a:p>
-            <a:pPr algn="l">
-              <a:spcAft>
-                <a:spcPts val="600"/>
-              </a:spcAft>
-            </a:pPr>
-            <a:r>
-              <a:rPr sz="1300" b="0">
-                <a:solidFill>
-                  <a:srgbClr val="26221B"/>
-                </a:solidFill>
-                <a:latin typeface="Georgia"/>
-              </a:rPr>
-              <a:t>• Chairs appointed by the President, confirmed by member vote</a:t>
-            </a:r>
-          </a:p>
-          <a:p>
-            <a:pPr algn="l">
-              <a:spcAft>
-                <a:spcPts val="600"/>
-              </a:spcAft>
-            </a:pPr>
-            <a:r>
-              <a:rPr sz="1300" b="0">
-                <a:solidFill>
-                  <a:srgbClr val="26221B"/>
-                </a:solidFill>
-                <a:latin typeface="Georgia"/>
-              </a:rPr>
-              <a:t>• Meet monthly · report to the Vice President · 3-minute report each meeting</a:t>
-            </a:r>
-          </a:p>
-          <a:p>
-            <a:pPr algn="l">
-              <a:spcAft>
-                <a:spcPts val="600"/>
-              </a:spcAft>
-            </a:pPr>
-            <a:r>
-              <a:rPr sz="1300" b="0">
-                <a:solidFill>
-                  <a:srgbClr val="26221B"/>
-                </a:solidFill>
-                <a:latin typeface="Georgia"/>
-              </a:rPr>
-              <a:t>• Budget requests in writing to the Treasurer BEFORE spending</a:t>
-            </a:r>
-          </a:p>
-        </p:txBody>
-      </p:sp>
-      <p:sp>
-        <p:nvSpPr>
-          <p:cNvPr id="16" name="TextBox 15"/>
-          <p:cNvSpPr txBox="1"/>
-          <p:nvPr/>
-        </p:nvSpPr>
-        <p:spPr>
-          <a:xfrm>
-            <a:off x="6583680" y="4800600"/>
-            <a:ext cx="4937760" cy="1828800"/>
-          </a:xfrm>
-          <a:prstGeom prst="rect">
-            <a:avLst/>
-          </a:prstGeom>
-          <a:noFill/>
-        </p:spPr>
-        <p:txBody>
-          <a:bodyPr wrap="square">
-            <a:spAutoFit/>
-          </a:bodyPr>
-          <a:lstStyle/>
-          <a:p>
-            <a:pPr algn="l">
-              <a:spcAft>
-                <a:spcPts val="800"/>
-              </a:spcAft>
-            </a:pPr>
-            <a:r>
-              <a:rPr sz="1500" b="1">
-                <a:solidFill>
-                  <a:srgbClr val="E65100"/>
-                </a:solidFill>
-                <a:latin typeface="Georgia"/>
-              </a:rPr>
-              <a:t>Three ways to sign up</a:t>
-            </a:r>
-          </a:p>
-          <a:p>
-            <a:pPr algn="l">
-              <a:spcAft>
-                <a:spcPts val="600"/>
-              </a:spcAft>
-            </a:pPr>
-            <a:r>
-              <a:rPr sz="1300" b="0">
-                <a:solidFill>
-                  <a:srgbClr val="26221B"/>
-                </a:solidFill>
-                <a:latin typeface="Georgia"/>
-              </a:rPr>
-              <a:t>• Paper sheets at the welcome table (write your name under Chair or Member)</a:t>
-            </a:r>
-          </a:p>
-          <a:p>
-            <a:pPr algn="l">
-              <a:spcAft>
-                <a:spcPts val="600"/>
-              </a:spcAft>
-            </a:pPr>
-            <a:r>
-              <a:rPr sz="1300" b="0">
-                <a:solidFill>
-                  <a:srgbClr val="26221B"/>
-                </a:solidFill>
-                <a:latin typeface="Georgia"/>
-              </a:rPr>
-              <a:t>• Online: Committee Sign-Up form on hnfamilyreunion.com</a:t>
-            </a:r>
-          </a:p>
-          <a:p>
-            <a:pPr algn="l">
-              <a:spcAft>
-                <a:spcPts val="600"/>
-              </a:spcAft>
-            </a:pPr>
-            <a:r>
-              <a:rPr sz="1300" b="0">
-                <a:solidFill>
-                  <a:srgbClr val="26221B"/>
-                </a:solidFill>
-                <a:latin typeface="Georgia"/>
-              </a:rPr>
-              <a:t>• Right now: raise your hand when your committee is called</a:t>
+                <a:latin typeface="Verdana"/>
+              </a:rPr>
+              <a:t>Courtesy (Loretta) and Protocol (Parliamentarian) are covered. Chairs appointed by the President, confirmed by member vote — raise your hand or check 'I want to chair' on the sign-up form.</a:t>
             </a:r>
           </a:p>
         </p:txBody>
@@ -9227,7 +8983,7 @@
                 </a:solidFill>
                 <a:latin typeface="Verdana"/>
               </a:rPr>
-              <a:t>FAMILY BUSINESS · DECADE PLANNING</a:t>
+              <a:t>FAMILY BUSINESS · COMMITTEES</a:t>
             </a:r>
           </a:p>
         </p:txBody>
@@ -9266,7 +9022,7 @@
                 </a:solidFill>
                 <a:latin typeface="Georgia"/>
               </a:rPr>
-              <a:t>Where We Meet Next 🗺 — Halfway Between Jackson, MS &amp; Cleveland, OH</a:t>
+              <a:t>Committees Need Chairs — That Means YOU 🙋</a:t>
             </a:r>
           </a:p>
         </p:txBody>
@@ -9279,33 +9035,49 @@
         </p:nvSpPr>
         <p:spPr>
           <a:xfrm>
-            <a:off x="640080" y="1554480"/>
-            <a:ext cx="10911535" cy="548640"/>
-          </a:xfrm>
-          <a:prstGeom prst="rect">
-            <a:avLst/>
-          </a:prstGeom>
-          <a:noFill/>
-        </p:spPr>
-        <p:txBody>
-          <a:bodyPr wrap="square">
-            <a:spAutoFit/>
-          </a:bodyPr>
-          <a:lstStyle/>
-          <a:p>
-            <a:pPr algn="l">
-              <a:spcAft>
-                <a:spcPts val="600"/>
-              </a:spcAft>
-            </a:pPr>
-            <a:r>
-              <a:rPr sz="1500" b="0">
+            <a:off x="731520" y="1554480"/>
+            <a:ext cx="3566160" cy="868680"/>
+          </a:xfrm>
+          <a:prstGeom prst="rect">
+            <a:avLst/>
+          </a:prstGeom>
+          <a:noFill/>
+        </p:spPr>
+        <p:txBody>
+          <a:bodyPr wrap="square">
+            <a:spAutoFit/>
+          </a:bodyPr>
+          <a:lstStyle/>
+          <a:p>
+            <a:pPr algn="l">
+              <a:spcAft>
+                <a:spcPts val="100"/>
+              </a:spcAft>
+            </a:pPr>
+            <a:r>
+              <a:rPr sz="1600" b="1">
+                <a:solidFill>
+                  <a:srgbClr val="1B5E20"/>
+                </a:solidFill>
+                <a:latin typeface="Georgia"/>
+              </a:rPr>
+              <a:t>🏈 Sports / Games</a:t>
+            </a:r>
+          </a:p>
+          <a:p>
+            <a:pPr algn="l">
+              <a:spcAft>
+                <a:spcPts val="600"/>
+              </a:spcAft>
+            </a:pPr>
+            <a:r>
+              <a:rPr sz="1200" b="0">
                 <a:solidFill>
                   <a:srgbClr val="6B6355"/>
                 </a:solidFill>
                 <a:latin typeface="Georgia"/>
               </a:rPr>
-              <a:t>The drive is ~930 miles, so the halfway point lands around Nashville, TN / Bowling Green, KY.</a:t>
+              <a:t>Chair: [sign up] · Members: [sign up]</a:t>
             </a:r>
           </a:p>
         </p:txBody>
@@ -9318,8 +9090,558 @@
         </p:nvSpPr>
         <p:spPr>
           <a:xfrm>
-            <a:off x="640080" y="2194560"/>
-            <a:ext cx="3657600" cy="4114800"/>
+            <a:off x="4480559" y="1554480"/>
+            <a:ext cx="3566160" cy="868680"/>
+          </a:xfrm>
+          <a:prstGeom prst="rect">
+            <a:avLst/>
+          </a:prstGeom>
+          <a:noFill/>
+        </p:spPr>
+        <p:txBody>
+          <a:bodyPr wrap="square">
+            <a:spAutoFit/>
+          </a:bodyPr>
+          <a:lstStyle/>
+          <a:p>
+            <a:pPr algn="l">
+              <a:spcAft>
+                <a:spcPts val="100"/>
+              </a:spcAft>
+            </a:pPr>
+            <a:r>
+              <a:rPr sz="1600" b="1">
+                <a:solidFill>
+                  <a:srgbClr val="1B5E20"/>
+                </a:solidFill>
+                <a:latin typeface="Georgia"/>
+              </a:rPr>
+              <a:t>🎶 Music</a:t>
+            </a:r>
+          </a:p>
+          <a:p>
+            <a:pPr algn="l">
+              <a:spcAft>
+                <a:spcPts val="600"/>
+              </a:spcAft>
+            </a:pPr>
+            <a:r>
+              <a:rPr sz="1200" b="0">
+                <a:solidFill>
+                  <a:srgbClr val="6B6355"/>
+                </a:solidFill>
+                <a:latin typeface="Georgia"/>
+              </a:rPr>
+              <a:t>Chair: [sign up] · Members: [sign up]</a:t>
+            </a:r>
+          </a:p>
+        </p:txBody>
+      </p:sp>
+      <p:sp>
+        <p:nvSpPr>
+          <p:cNvPr id="6" name="TextBox 5"/>
+          <p:cNvSpPr txBox="1"/>
+          <p:nvPr/>
+        </p:nvSpPr>
+        <p:spPr>
+          <a:xfrm>
+            <a:off x="8229600" y="1554480"/>
+            <a:ext cx="3566160" cy="868680"/>
+          </a:xfrm>
+          <a:prstGeom prst="rect">
+            <a:avLst/>
+          </a:prstGeom>
+          <a:noFill/>
+        </p:spPr>
+        <p:txBody>
+          <a:bodyPr wrap="square">
+            <a:spAutoFit/>
+          </a:bodyPr>
+          <a:lstStyle/>
+          <a:p>
+            <a:pPr algn="l">
+              <a:spcAft>
+                <a:spcPts val="100"/>
+              </a:spcAft>
+            </a:pPr>
+            <a:r>
+              <a:rPr sz="1600" b="1">
+                <a:solidFill>
+                  <a:srgbClr val="1B5E20"/>
+                </a:solidFill>
+                <a:latin typeface="Georgia"/>
+              </a:rPr>
+              <a:t>🍽 Food</a:t>
+            </a:r>
+          </a:p>
+          <a:p>
+            <a:pPr algn="l">
+              <a:spcAft>
+                <a:spcPts val="600"/>
+              </a:spcAft>
+            </a:pPr>
+            <a:r>
+              <a:rPr sz="1200" b="0">
+                <a:solidFill>
+                  <a:srgbClr val="6B6355"/>
+                </a:solidFill>
+                <a:latin typeface="Georgia"/>
+              </a:rPr>
+              <a:t>Chair: [sign up] · Members: [sign up]</a:t>
+            </a:r>
+          </a:p>
+        </p:txBody>
+      </p:sp>
+      <p:sp>
+        <p:nvSpPr>
+          <p:cNvPr id="7" name="TextBox 6"/>
+          <p:cNvSpPr txBox="1"/>
+          <p:nvPr/>
+        </p:nvSpPr>
+        <p:spPr>
+          <a:xfrm>
+            <a:off x="731520" y="2331720"/>
+            <a:ext cx="3566160" cy="868680"/>
+          </a:xfrm>
+          <a:prstGeom prst="rect">
+            <a:avLst/>
+          </a:prstGeom>
+          <a:noFill/>
+        </p:spPr>
+        <p:txBody>
+          <a:bodyPr wrap="square">
+            <a:spAutoFit/>
+          </a:bodyPr>
+          <a:lstStyle/>
+          <a:p>
+            <a:pPr algn="l">
+              <a:spcAft>
+                <a:spcPts val="100"/>
+              </a:spcAft>
+            </a:pPr>
+            <a:r>
+              <a:rPr sz="1600" b="1">
+                <a:solidFill>
+                  <a:srgbClr val="1B5E20"/>
+                </a:solidFill>
+                <a:latin typeface="Georgia"/>
+              </a:rPr>
+              <a:t>🦺 Safety</a:t>
+            </a:r>
+          </a:p>
+          <a:p>
+            <a:pPr algn="l">
+              <a:spcAft>
+                <a:spcPts val="600"/>
+              </a:spcAft>
+            </a:pPr>
+            <a:r>
+              <a:rPr sz="1200" b="0">
+                <a:solidFill>
+                  <a:srgbClr val="6B6355"/>
+                </a:solidFill>
+                <a:latin typeface="Georgia"/>
+              </a:rPr>
+              <a:t>Chair: [sign up] · Members: [sign up]</a:t>
+            </a:r>
+          </a:p>
+        </p:txBody>
+      </p:sp>
+      <p:sp>
+        <p:nvSpPr>
+          <p:cNvPr id="8" name="TextBox 7"/>
+          <p:cNvSpPr txBox="1"/>
+          <p:nvPr/>
+        </p:nvSpPr>
+        <p:spPr>
+          <a:xfrm>
+            <a:off x="4480559" y="2331720"/>
+            <a:ext cx="3566160" cy="868680"/>
+          </a:xfrm>
+          <a:prstGeom prst="rect">
+            <a:avLst/>
+          </a:prstGeom>
+          <a:noFill/>
+        </p:spPr>
+        <p:txBody>
+          <a:bodyPr wrap="square">
+            <a:spAutoFit/>
+          </a:bodyPr>
+          <a:lstStyle/>
+          <a:p>
+            <a:pPr algn="l">
+              <a:spcAft>
+                <a:spcPts val="100"/>
+              </a:spcAft>
+            </a:pPr>
+            <a:r>
+              <a:rPr sz="1600" b="1">
+                <a:solidFill>
+                  <a:srgbClr val="1B5E20"/>
+                </a:solidFill>
+                <a:latin typeface="Georgia"/>
+              </a:rPr>
+              <a:t>🙏 Services</a:t>
+            </a:r>
+          </a:p>
+          <a:p>
+            <a:pPr algn="l">
+              <a:spcAft>
+                <a:spcPts val="600"/>
+              </a:spcAft>
+            </a:pPr>
+            <a:r>
+              <a:rPr sz="1200" b="0">
+                <a:solidFill>
+                  <a:srgbClr val="6B6355"/>
+                </a:solidFill>
+                <a:latin typeface="Georgia"/>
+              </a:rPr>
+              <a:t>Chair: [sign up] · Members: [sign up]</a:t>
+            </a:r>
+          </a:p>
+        </p:txBody>
+      </p:sp>
+      <p:sp>
+        <p:nvSpPr>
+          <p:cNvPr id="9" name="TextBox 8"/>
+          <p:cNvSpPr txBox="1"/>
+          <p:nvPr/>
+        </p:nvSpPr>
+        <p:spPr>
+          <a:xfrm>
+            <a:off x="8229600" y="2331720"/>
+            <a:ext cx="3566160" cy="868680"/>
+          </a:xfrm>
+          <a:prstGeom prst="rect">
+            <a:avLst/>
+          </a:prstGeom>
+          <a:noFill/>
+        </p:spPr>
+        <p:txBody>
+          <a:bodyPr wrap="square">
+            <a:spAutoFit/>
+          </a:bodyPr>
+          <a:lstStyle/>
+          <a:p>
+            <a:pPr algn="l">
+              <a:spcAft>
+                <a:spcPts val="100"/>
+              </a:spcAft>
+            </a:pPr>
+            <a:r>
+              <a:rPr sz="1600" b="1">
+                <a:solidFill>
+                  <a:srgbClr val="1B5E20"/>
+                </a:solidFill>
+                <a:latin typeface="Georgia"/>
+              </a:rPr>
+              <a:t>📸 Photography</a:t>
+            </a:r>
+          </a:p>
+          <a:p>
+            <a:pPr algn="l">
+              <a:spcAft>
+                <a:spcPts val="600"/>
+              </a:spcAft>
+            </a:pPr>
+            <a:r>
+              <a:rPr sz="1200" b="0">
+                <a:solidFill>
+                  <a:srgbClr val="6B6355"/>
+                </a:solidFill>
+                <a:latin typeface="Georgia"/>
+              </a:rPr>
+              <a:t>Chair: [sign up] · Members: [sign up]</a:t>
+            </a:r>
+          </a:p>
+        </p:txBody>
+      </p:sp>
+      <p:sp>
+        <p:nvSpPr>
+          <p:cNvPr id="10" name="TextBox 9"/>
+          <p:cNvSpPr txBox="1"/>
+          <p:nvPr/>
+        </p:nvSpPr>
+        <p:spPr>
+          <a:xfrm>
+            <a:off x="731520" y="3108960"/>
+            <a:ext cx="3566160" cy="868680"/>
+          </a:xfrm>
+          <a:prstGeom prst="rect">
+            <a:avLst/>
+          </a:prstGeom>
+          <a:noFill/>
+        </p:spPr>
+        <p:txBody>
+          <a:bodyPr wrap="square">
+            <a:spAutoFit/>
+          </a:bodyPr>
+          <a:lstStyle/>
+          <a:p>
+            <a:pPr algn="l">
+              <a:spcAft>
+                <a:spcPts val="100"/>
+              </a:spcAft>
+            </a:pPr>
+            <a:r>
+              <a:rPr sz="1600" b="1">
+                <a:solidFill>
+                  <a:srgbClr val="1B5E20"/>
+                </a:solidFill>
+                <a:latin typeface="Georgia"/>
+              </a:rPr>
+              <a:t>💝 Philanthropy &amp; Fundraising</a:t>
+            </a:r>
+          </a:p>
+          <a:p>
+            <a:pPr algn="l">
+              <a:spcAft>
+                <a:spcPts val="600"/>
+              </a:spcAft>
+            </a:pPr>
+            <a:r>
+              <a:rPr sz="1200" b="0">
+                <a:solidFill>
+                  <a:srgbClr val="6B6355"/>
+                </a:solidFill>
+                <a:latin typeface="Georgia"/>
+              </a:rPr>
+              <a:t>Chair: [sign up] · Members: [sign up]</a:t>
+            </a:r>
+          </a:p>
+        </p:txBody>
+      </p:sp>
+      <p:sp>
+        <p:nvSpPr>
+          <p:cNvPr id="11" name="TextBox 10"/>
+          <p:cNvSpPr txBox="1"/>
+          <p:nvPr/>
+        </p:nvSpPr>
+        <p:spPr>
+          <a:xfrm>
+            <a:off x="4480559" y="3108960"/>
+            <a:ext cx="3566160" cy="868680"/>
+          </a:xfrm>
+          <a:prstGeom prst="rect">
+            <a:avLst/>
+          </a:prstGeom>
+          <a:noFill/>
+        </p:spPr>
+        <p:txBody>
+          <a:bodyPr wrap="square">
+            <a:spAutoFit/>
+          </a:bodyPr>
+          <a:lstStyle/>
+          <a:p>
+            <a:pPr algn="l">
+              <a:spcAft>
+                <a:spcPts val="100"/>
+              </a:spcAft>
+            </a:pPr>
+            <a:r>
+              <a:rPr sz="1600" b="1">
+                <a:solidFill>
+                  <a:srgbClr val="1B5E20"/>
+                </a:solidFill>
+                <a:latin typeface="Georgia"/>
+              </a:rPr>
+              <a:t>🗓 Planning</a:t>
+            </a:r>
+          </a:p>
+          <a:p>
+            <a:pPr algn="l">
+              <a:spcAft>
+                <a:spcPts val="600"/>
+              </a:spcAft>
+            </a:pPr>
+            <a:r>
+              <a:rPr sz="1200" b="0">
+                <a:solidFill>
+                  <a:srgbClr val="6B6355"/>
+                </a:solidFill>
+                <a:latin typeface="Georgia"/>
+              </a:rPr>
+              <a:t>Chair: [sign up] · Members: [sign up]</a:t>
+            </a:r>
+          </a:p>
+        </p:txBody>
+      </p:sp>
+      <p:sp>
+        <p:nvSpPr>
+          <p:cNvPr id="12" name="TextBox 11"/>
+          <p:cNvSpPr txBox="1"/>
+          <p:nvPr/>
+        </p:nvSpPr>
+        <p:spPr>
+          <a:xfrm>
+            <a:off x="8229600" y="3108960"/>
+            <a:ext cx="3566160" cy="868680"/>
+          </a:xfrm>
+          <a:prstGeom prst="rect">
+            <a:avLst/>
+          </a:prstGeom>
+          <a:noFill/>
+        </p:spPr>
+        <p:txBody>
+          <a:bodyPr wrap="square">
+            <a:spAutoFit/>
+          </a:bodyPr>
+          <a:lstStyle/>
+          <a:p>
+            <a:pPr algn="l">
+              <a:spcAft>
+                <a:spcPts val="100"/>
+              </a:spcAft>
+            </a:pPr>
+            <a:r>
+              <a:rPr sz="1600" b="1">
+                <a:solidFill>
+                  <a:srgbClr val="1B5E20"/>
+                </a:solidFill>
+                <a:latin typeface="Georgia"/>
+              </a:rPr>
+              <a:t>💻 Technology</a:t>
+            </a:r>
+          </a:p>
+          <a:p>
+            <a:pPr algn="l">
+              <a:spcAft>
+                <a:spcPts val="600"/>
+              </a:spcAft>
+            </a:pPr>
+            <a:r>
+              <a:rPr sz="1200" b="0">
+                <a:solidFill>
+                  <a:srgbClr val="6B6355"/>
+                </a:solidFill>
+                <a:latin typeface="Georgia"/>
+              </a:rPr>
+              <a:t>Chair: [sign up] · Members: [sign up]</a:t>
+            </a:r>
+          </a:p>
+        </p:txBody>
+      </p:sp>
+      <p:sp>
+        <p:nvSpPr>
+          <p:cNvPr id="13" name="TextBox 12"/>
+          <p:cNvSpPr txBox="1"/>
+          <p:nvPr/>
+        </p:nvSpPr>
+        <p:spPr>
+          <a:xfrm>
+            <a:off x="731520" y="3886200"/>
+            <a:ext cx="3566160" cy="868680"/>
+          </a:xfrm>
+          <a:prstGeom prst="rect">
+            <a:avLst/>
+          </a:prstGeom>
+          <a:noFill/>
+        </p:spPr>
+        <p:txBody>
+          <a:bodyPr wrap="square">
+            <a:spAutoFit/>
+          </a:bodyPr>
+          <a:lstStyle/>
+          <a:p>
+            <a:pPr algn="l">
+              <a:spcAft>
+                <a:spcPts val="100"/>
+              </a:spcAft>
+            </a:pPr>
+            <a:r>
+              <a:rPr sz="1600" b="1">
+                <a:solidFill>
+                  <a:srgbClr val="1B5E20"/>
+                </a:solidFill>
+                <a:latin typeface="Georgia"/>
+              </a:rPr>
+              <a:t>💐 Courtesy (led by the Hospitality Chair)</a:t>
+            </a:r>
+          </a:p>
+          <a:p>
+            <a:pPr algn="l">
+              <a:spcAft>
+                <a:spcPts val="600"/>
+              </a:spcAft>
+            </a:pPr>
+            <a:r>
+              <a:rPr sz="1200" b="0">
+                <a:solidFill>
+                  <a:srgbClr val="6B6355"/>
+                </a:solidFill>
+                <a:latin typeface="Georgia"/>
+              </a:rPr>
+              <a:t>Chair: [sign up] · Members: [sign up]</a:t>
+            </a:r>
+          </a:p>
+        </p:txBody>
+      </p:sp>
+      <p:sp>
+        <p:nvSpPr>
+          <p:cNvPr id="14" name="TextBox 13"/>
+          <p:cNvSpPr txBox="1"/>
+          <p:nvPr/>
+        </p:nvSpPr>
+        <p:spPr>
+          <a:xfrm>
+            <a:off x="4480559" y="3886200"/>
+            <a:ext cx="3566160" cy="868680"/>
+          </a:xfrm>
+          <a:prstGeom prst="rect">
+            <a:avLst/>
+          </a:prstGeom>
+          <a:noFill/>
+        </p:spPr>
+        <p:txBody>
+          <a:bodyPr wrap="square">
+            <a:spAutoFit/>
+          </a:bodyPr>
+          <a:lstStyle/>
+          <a:p>
+            <a:pPr algn="l">
+              <a:spcAft>
+                <a:spcPts val="100"/>
+              </a:spcAft>
+            </a:pPr>
+            <a:r>
+              <a:rPr sz="1600" b="1">
+                <a:solidFill>
+                  <a:srgbClr val="1B5E20"/>
+                </a:solidFill>
+                <a:latin typeface="Georgia"/>
+              </a:rPr>
+              <a:t>📜 Protocol (chaired by the Parliamentarian)</a:t>
+            </a:r>
+          </a:p>
+          <a:p>
+            <a:pPr algn="l">
+              <a:spcAft>
+                <a:spcPts val="600"/>
+              </a:spcAft>
+            </a:pPr>
+            <a:r>
+              <a:rPr sz="1200" b="0">
+                <a:solidFill>
+                  <a:srgbClr val="6B6355"/>
+                </a:solidFill>
+                <a:latin typeface="Georgia"/>
+              </a:rPr>
+              <a:t>Chair: [sign up] · Members: [sign up]</a:t>
+            </a:r>
+          </a:p>
+        </p:txBody>
+      </p:sp>
+      <p:sp>
+        <p:nvSpPr>
+          <p:cNvPr id="15" name="TextBox 14"/>
+          <p:cNvSpPr txBox="1"/>
+          <p:nvPr/>
+        </p:nvSpPr>
+        <p:spPr>
+          <a:xfrm>
+            <a:off x="640080" y="4800600"/>
+            <a:ext cx="5669280" cy="1828800"/>
           </a:xfrm>
           <a:prstGeom prst="rect">
             <a:avLst/>
@@ -9344,7 +9666,7 @@
                 </a:solidFill>
                 <a:latin typeface="Georgia"/>
               </a:rPr>
-              <a:t>🎯 At the halfway mark</a:t>
+              <a:t>How committees operate</a:t>
             </a:r>
           </a:p>
           <a:p>
@@ -9360,7 +9682,7 @@
                 </a:solidFill>
                 <a:latin typeface="Georgia"/>
               </a:rPr>
-              <a:t>• Montgomery Bell State Park — Burns, TN: 117 lakefront lodge rooms, 7,000+ sq ft event space</a:t>
+              <a:t>• Chairs appointed by the President, confirmed by member vote</a:t>
             </a:r>
           </a:p>
           <a:p>
@@ -9376,21 +9698,37 @@
                 </a:solidFill>
                 <a:latin typeface="Georgia"/>
               </a:rPr>
-              <a:t>• Barren River Lake State Resort Park — Bowling Green, KY: banquet room seats 224–400</a:t>
-            </a:r>
-          </a:p>
-        </p:txBody>
-      </p:sp>
-      <p:sp>
-        <p:nvSpPr>
-          <p:cNvPr id="6" name="TextBox 5"/>
-          <p:cNvSpPr txBox="1"/>
-          <p:nvPr/>
-        </p:nvSpPr>
-        <p:spPr>
-          <a:xfrm>
-            <a:off x="4434840" y="2194560"/>
-            <a:ext cx="3657600" cy="4114800"/>
+              <a:t>• Meet monthly · report to the Vice President · 3-minute report each meeting</a:t>
+            </a:r>
+          </a:p>
+          <a:p>
+            <a:pPr algn="l">
+              <a:spcAft>
+                <a:spcPts val="600"/>
+              </a:spcAft>
+            </a:pPr>
+            <a:r>
+              <a:rPr sz="1300" b="0">
+                <a:solidFill>
+                  <a:srgbClr val="26221B"/>
+                </a:solidFill>
+                <a:latin typeface="Georgia"/>
+              </a:rPr>
+              <a:t>• Budget requests in writing to the Treasurer BEFORE spending</a:t>
+            </a:r>
+          </a:p>
+        </p:txBody>
+      </p:sp>
+      <p:sp>
+        <p:nvSpPr>
+          <p:cNvPr id="16" name="TextBox 15"/>
+          <p:cNvSpPr txBox="1"/>
+          <p:nvPr/>
+        </p:nvSpPr>
+        <p:spPr>
+          <a:xfrm>
+            <a:off x="6583680" y="4800600"/>
+            <a:ext cx="4937760" cy="1828800"/>
           </a:xfrm>
           <a:prstGeom prst="rect">
             <a:avLst/>
@@ -9415,7 +9753,7 @@
                 </a:solidFill>
                 <a:latin typeface="Georgia"/>
               </a:rPr>
-              <a:t>🚗 Along the route</a:t>
+              <a:t>Three ways to sign up</a:t>
             </a:r>
           </a:p>
           <a:p>
@@ -9431,7 +9769,7 @@
                 </a:solidFill>
                 <a:latin typeface="Georgia"/>
               </a:rPr>
-              <a:t>• Kentucky Dam Village State Resort Park — Gilbertsville, KY</a:t>
+              <a:t>• Paper sheets at the welcome table (write your name under Chair or Member)</a:t>
             </a:r>
           </a:p>
           <a:p>
@@ -9447,7 +9785,7 @@
                 </a:solidFill>
                 <a:latin typeface="Georgia"/>
               </a:rPr>
-              <a:t>• General Butler State Resort Park — off I-71, Louisville↔Cincinnati</a:t>
+              <a:t>• Online: Committee Sign-Up form on hnfamilyreunion.com</a:t>
             </a:r>
           </a:p>
           <a:p>
@@ -9463,149 +9801,7 @@
                 </a:solidFill>
                 <a:latin typeface="Georgia"/>
               </a:rPr>
-              <a:t>• Brown County / Abe Martin Lodge — IN (indoor water park!)</a:t>
-            </a:r>
-          </a:p>
-          <a:p>
-            <a:pPr algn="l">
-              <a:spcAft>
-                <a:spcPts val="600"/>
-              </a:spcAft>
-            </a:pPr>
-            <a:r>
-              <a:rPr sz="1300" b="0">
-                <a:solidFill>
-                  <a:srgbClr val="26221B"/>
-                </a:solidFill>
-                <a:latin typeface="Georgia"/>
-              </a:rPr>
-              <a:t>• Hueston Woods Lodge — College Corner, OH</a:t>
-            </a:r>
-          </a:p>
-        </p:txBody>
-      </p:sp>
-      <p:sp>
-        <p:nvSpPr>
-          <p:cNvPr id="7" name="TextBox 6"/>
-          <p:cNvSpPr txBox="1"/>
-          <p:nvPr/>
-        </p:nvSpPr>
-        <p:spPr>
-          <a:xfrm>
-            <a:off x="8229600" y="2194560"/>
-            <a:ext cx="3566160" cy="4114800"/>
-          </a:xfrm>
-          <a:prstGeom prst="rect">
-            <a:avLst/>
-          </a:prstGeom>
-          <a:noFill/>
-        </p:spPr>
-        <p:txBody>
-          <a:bodyPr wrap="square">
-            <a:spAutoFit/>
-          </a:bodyPr>
-          <a:lstStyle/>
-          <a:p>
-            <a:pPr algn="l">
-              <a:spcAft>
-                <a:spcPts val="800"/>
-              </a:spcAft>
-            </a:pPr>
-            <a:r>
-              <a:rPr sz="1500" b="1">
-                <a:solidFill>
-                  <a:srgbClr val="B71C1C"/>
-                </a:solidFill>
-                <a:latin typeface="Georgia"/>
-              </a:rPr>
-              <a:t>🏙 Closer to Cleveland</a:t>
-            </a:r>
-          </a:p>
-          <a:p>
-            <a:pPr algn="l">
-              <a:spcAft>
-                <a:spcPts val="600"/>
-              </a:spcAft>
-            </a:pPr>
-            <a:r>
-              <a:rPr sz="1300" b="0">
-                <a:solidFill>
-                  <a:srgbClr val="26221B"/>
-                </a:solidFill>
-                <a:latin typeface="Georgia"/>
-              </a:rPr>
-              <a:t>• Salt Fork State Park Lodge — Lore City, OH</a:t>
-            </a:r>
-          </a:p>
-          <a:p>
-            <a:pPr algn="l">
-              <a:spcAft>
-                <a:spcPts val="600"/>
-              </a:spcAft>
-            </a:pPr>
-            <a:r>
-              <a:rPr sz="1300" b="0">
-                <a:solidFill>
-                  <a:srgbClr val="26221B"/>
-                </a:solidFill>
-                <a:latin typeface="Georgia"/>
-              </a:rPr>
-              <a:t>• Punderson Manor Lodge — Newbury, OH</a:t>
-            </a:r>
-          </a:p>
-          <a:p>
-            <a:pPr algn="l">
-              <a:spcAft>
-                <a:spcPts val="600"/>
-              </a:spcAft>
-            </a:pPr>
-            <a:r>
-              <a:rPr sz="1300" b="0">
-                <a:solidFill>
-                  <a:srgbClr val="26221B"/>
-                </a:solidFill>
-                <a:latin typeface="Georgia"/>
-              </a:rPr>
-              <a:t>• The Lodge at Geneva-on-the-Lake — Lake Erie shore</a:t>
-            </a:r>
-          </a:p>
-        </p:txBody>
-      </p:sp>
-      <p:sp>
-        <p:nvSpPr>
-          <p:cNvPr id="8" name="TextBox 7"/>
-          <p:cNvSpPr txBox="1"/>
-          <p:nvPr/>
-        </p:nvSpPr>
-        <p:spPr>
-          <a:xfrm>
-            <a:off x="640080" y="6291072"/>
-            <a:ext cx="10911535" cy="457200"/>
-          </a:xfrm>
-          <a:prstGeom prst="rect">
-            <a:avLst/>
-          </a:prstGeom>
-          <a:noFill/>
-        </p:spPr>
-        <p:txBody>
-          <a:bodyPr wrap="square">
-            <a:spAutoFit/>
-          </a:bodyPr>
-          <a:lstStyle/>
-          <a:p>
-            <a:pPr algn="l">
-              <a:spcAft>
-                <a:spcPts val="600"/>
-              </a:spcAft>
-            </a:pPr>
-            <a:r>
-              <a:rPr sz="1100" b="0">
-                <a:solidFill>
-                  <a:srgbClr val="6B6355"/>
-                </a:solidFill>
-                <a:latin typeface="Verdana"/>
-              </a:rPr>
-              <a:t>The Planning Committee gets group-rate quotes from the top three picks; we choose by member vote. Decade planning = we rotate.</a:t>
+              <a:t>• Right now: raise your hand when your committee is called</a:t>
             </a:r>
           </a:p>
         </p:txBody>
@@ -9670,7 +9866,7 @@
                 </a:solidFill>
                 <a:latin typeface="Verdana"/>
               </a:rPr>
-              <a:t>FAMILY BUSINESS · TECHNOLOGY</a:t>
+              <a:t>FAMILY BUSINESS · DECADE PLANNING</a:t>
             </a:r>
           </a:p>
         </p:txBody>
@@ -9709,7 +9905,7 @@
                 </a:solidFill>
                 <a:latin typeface="Georgia"/>
               </a:rPr>
-              <a:t>Our New Home Online: hnfamilyreunion.com 💻</a:t>
+              <a:t>Where We Meet Next 🗺 — Halfway Between Jackson, MS &amp; Cleveland, OH</a:t>
             </a:r>
           </a:p>
         </p:txBody>
@@ -9722,7 +9918,46 @@
         </p:nvSpPr>
         <p:spPr>
           <a:xfrm>
-            <a:off x="640080" y="1737360"/>
+            <a:off x="640080" y="1554480"/>
+            <a:ext cx="10911535" cy="548640"/>
+          </a:xfrm>
+          <a:prstGeom prst="rect">
+            <a:avLst/>
+          </a:prstGeom>
+          <a:noFill/>
+        </p:spPr>
+        <p:txBody>
+          <a:bodyPr wrap="square">
+            <a:spAutoFit/>
+          </a:bodyPr>
+          <a:lstStyle/>
+          <a:p>
+            <a:pPr algn="l">
+              <a:spcAft>
+                <a:spcPts val="600"/>
+              </a:spcAft>
+            </a:pPr>
+            <a:r>
+              <a:rPr sz="1500" b="0">
+                <a:solidFill>
+                  <a:srgbClr val="6B6355"/>
+                </a:solidFill>
+                <a:latin typeface="Georgia"/>
+              </a:rPr>
+              <a:t>The drive is ~930 miles, so the halfway point lands around Nashville, TN / Bowling Green, KY.</a:t>
+            </a:r>
+          </a:p>
+        </p:txBody>
+      </p:sp>
+      <p:sp>
+        <p:nvSpPr>
+          <p:cNvPr id="5" name="TextBox 4"/>
+          <p:cNvSpPr txBox="1"/>
+          <p:nvPr/>
+        </p:nvSpPr>
+        <p:spPr>
+          <a:xfrm>
+            <a:off x="640080" y="2194560"/>
             <a:ext cx="3657600" cy="4114800"/>
           </a:xfrm>
           <a:prstGeom prst="rect">
@@ -9742,90 +9977,58 @@
               </a:spcAft>
             </a:pPr>
             <a:r>
-              <a:rPr sz="1600" b="1">
+              <a:rPr sz="1500" b="1">
                 <a:solidFill>
                   <a:srgbClr val="2E7D32"/>
                 </a:solidFill>
                 <a:latin typeface="Georgia"/>
               </a:rPr>
-              <a:t>Everything reunion</a:t>
-            </a:r>
-          </a:p>
-          <a:p>
-            <a:pPr algn="l">
-              <a:spcAft>
-                <a:spcPts val="600"/>
-              </a:spcAft>
-            </a:pPr>
-            <a:r>
-              <a:rPr sz="1400" b="0">
-                <a:solidFill>
-                  <a:srgbClr val="26221B"/>
-                </a:solidFill>
-                <a:latin typeface="Georgia"/>
-              </a:rPr>
-              <a:t>• Announcements &amp; event schedule</a:t>
-            </a:r>
-          </a:p>
-          <a:p>
-            <a:pPr algn="l">
-              <a:spcAft>
-                <a:spcPts val="600"/>
-              </a:spcAft>
-            </a:pPr>
-            <a:r>
-              <a:rPr sz="1400" b="0">
-                <a:solidFill>
-                  <a:srgbClr val="26221B"/>
-                </a:solidFill>
-                <a:latin typeface="Georgia"/>
-              </a:rPr>
-              <a:t>• Family history &amp; photo gallery</a:t>
-            </a:r>
-          </a:p>
-          <a:p>
-            <a:pPr algn="l">
-              <a:spcAft>
-                <a:spcPts val="600"/>
-              </a:spcAft>
-            </a:pPr>
-            <a:r>
-              <a:rPr sz="1400" b="0">
-                <a:solidFill>
-                  <a:srgbClr val="26221B"/>
-                </a:solidFill>
-                <a:latin typeface="Georgia"/>
-              </a:rPr>
-              <a:t>• 2024 slideshow &amp; yearbook archive</a:t>
-            </a:r>
-          </a:p>
-          <a:p>
-            <a:pPr algn="l">
-              <a:spcAft>
-                <a:spcPts val="600"/>
-              </a:spcAft>
-            </a:pPr>
-            <a:r>
-              <a:rPr sz="1400" b="0">
-                <a:solidFill>
-                  <a:srgbClr val="26221B"/>
-                </a:solidFill>
-                <a:latin typeface="Georgia"/>
-              </a:rPr>
-              <a:t>• Memorial page</a:t>
-            </a:r>
-          </a:p>
-        </p:txBody>
-      </p:sp>
-      <p:sp>
-        <p:nvSpPr>
-          <p:cNvPr id="5" name="TextBox 4"/>
-          <p:cNvSpPr txBox="1"/>
-          <p:nvPr/>
-        </p:nvSpPr>
-        <p:spPr>
-          <a:xfrm>
-            <a:off x="4434840" y="1737360"/>
+              <a:t>🎯 At the halfway mark</a:t>
+            </a:r>
+          </a:p>
+          <a:p>
+            <a:pPr algn="l">
+              <a:spcAft>
+                <a:spcPts val="600"/>
+              </a:spcAft>
+            </a:pPr>
+            <a:r>
+              <a:rPr sz="1300" b="0">
+                <a:solidFill>
+                  <a:srgbClr val="26221B"/>
+                </a:solidFill>
+                <a:latin typeface="Georgia"/>
+              </a:rPr>
+              <a:t>• Montgomery Bell State Park — Burns, TN: 117 lakefront lodge rooms, 7,000+ sq ft event space</a:t>
+            </a:r>
+          </a:p>
+          <a:p>
+            <a:pPr algn="l">
+              <a:spcAft>
+                <a:spcPts val="600"/>
+              </a:spcAft>
+            </a:pPr>
+            <a:r>
+              <a:rPr sz="1300" b="0">
+                <a:solidFill>
+                  <a:srgbClr val="26221B"/>
+                </a:solidFill>
+                <a:latin typeface="Georgia"/>
+              </a:rPr>
+              <a:t>• Barren River Lake State Resort Park — Bowling Green, KY: banquet room seats 224–400</a:t>
+            </a:r>
+          </a:p>
+        </p:txBody>
+      </p:sp>
+      <p:sp>
+        <p:nvSpPr>
+          <p:cNvPr id="6" name="TextBox 5"/>
+          <p:cNvSpPr txBox="1"/>
+          <p:nvPr/>
+        </p:nvSpPr>
+        <p:spPr>
+          <a:xfrm>
+            <a:off x="4434840" y="2194560"/>
             <a:ext cx="3657600" cy="4114800"/>
           </a:xfrm>
           <a:prstGeom prst="rect">
@@ -9845,74 +10048,90 @@
               </a:spcAft>
             </a:pPr>
             <a:r>
-              <a:rPr sz="1600" b="1">
+              <a:rPr sz="1500" b="1">
                 <a:solidFill>
                   <a:srgbClr val="E65100"/>
                 </a:solidFill>
                 <a:latin typeface="Georgia"/>
               </a:rPr>
-              <a:t>Payments &amp; shop</a:t>
-            </a:r>
-          </a:p>
-          <a:p>
-            <a:pPr algn="l">
-              <a:spcAft>
-                <a:spcPts val="600"/>
-              </a:spcAft>
-            </a:pPr>
-            <a:r>
-              <a:rPr sz="1400" b="0">
-                <a:solidFill>
-                  <a:srgbClr val="26221B"/>
-                </a:solidFill>
-                <a:latin typeface="Georgia"/>
-              </a:rPr>
-              <a:t>• Registration &amp; dues online</a:t>
-            </a:r>
-          </a:p>
-          <a:p>
-            <a:pPr algn="l">
-              <a:spcAft>
-                <a:spcPts val="600"/>
-              </a:spcAft>
-            </a:pPr>
-            <a:r>
-              <a:rPr sz="1400" b="0">
-                <a:solidFill>
-                  <a:srgbClr val="26221B"/>
-                </a:solidFill>
-                <a:latin typeface="Georgia"/>
-              </a:rPr>
-              <a:t>• T-shirt orders</a:t>
-            </a:r>
-          </a:p>
-          <a:p>
-            <a:pPr algn="l">
-              <a:spcAft>
-                <a:spcPts val="600"/>
-              </a:spcAft>
-            </a:pPr>
-            <a:r>
-              <a:rPr sz="1400" b="0">
-                <a:solidFill>
-                  <a:srgbClr val="26221B"/>
-                </a:solidFill>
-                <a:latin typeface="Georgia"/>
-              </a:rPr>
-              <a:t>• Donations to the Land &amp; Scholarship funds</a:t>
-            </a:r>
-          </a:p>
-        </p:txBody>
-      </p:sp>
-      <p:sp>
-        <p:nvSpPr>
-          <p:cNvPr id="6" name="TextBox 5"/>
-          <p:cNvSpPr txBox="1"/>
-          <p:nvPr/>
-        </p:nvSpPr>
-        <p:spPr>
-          <a:xfrm>
-            <a:off x="8229600" y="1737360"/>
+              <a:t>🚗 Along the route</a:t>
+            </a:r>
+          </a:p>
+          <a:p>
+            <a:pPr algn="l">
+              <a:spcAft>
+                <a:spcPts val="600"/>
+              </a:spcAft>
+            </a:pPr>
+            <a:r>
+              <a:rPr sz="1300" b="0">
+                <a:solidFill>
+                  <a:srgbClr val="26221B"/>
+                </a:solidFill>
+                <a:latin typeface="Georgia"/>
+              </a:rPr>
+              <a:t>• Kentucky Dam Village State Resort Park — Gilbertsville, KY</a:t>
+            </a:r>
+          </a:p>
+          <a:p>
+            <a:pPr algn="l">
+              <a:spcAft>
+                <a:spcPts val="600"/>
+              </a:spcAft>
+            </a:pPr>
+            <a:r>
+              <a:rPr sz="1300" b="0">
+                <a:solidFill>
+                  <a:srgbClr val="26221B"/>
+                </a:solidFill>
+                <a:latin typeface="Georgia"/>
+              </a:rPr>
+              <a:t>• General Butler State Resort Park — off I-71, Louisville↔Cincinnati</a:t>
+            </a:r>
+          </a:p>
+          <a:p>
+            <a:pPr algn="l">
+              <a:spcAft>
+                <a:spcPts val="600"/>
+              </a:spcAft>
+            </a:pPr>
+            <a:r>
+              <a:rPr sz="1300" b="0">
+                <a:solidFill>
+                  <a:srgbClr val="26221B"/>
+                </a:solidFill>
+                <a:latin typeface="Georgia"/>
+              </a:rPr>
+              <a:t>• Brown County / Abe Martin Lodge — IN (indoor water park!)</a:t>
+            </a:r>
+          </a:p>
+          <a:p>
+            <a:pPr algn="l">
+              <a:spcAft>
+                <a:spcPts val="600"/>
+              </a:spcAft>
+            </a:pPr>
+            <a:r>
+              <a:rPr sz="1300" b="0">
+                <a:solidFill>
+                  <a:srgbClr val="26221B"/>
+                </a:solidFill>
+                <a:latin typeface="Georgia"/>
+              </a:rPr>
+              <a:t>• Hueston Woods Lodge — College Corner, OH</a:t>
+            </a:r>
+          </a:p>
+        </p:txBody>
+      </p:sp>
+      <p:sp>
+        <p:nvSpPr>
+          <p:cNvPr id="7" name="TextBox 6"/>
+          <p:cNvSpPr txBox="1"/>
+          <p:nvPr/>
+        </p:nvSpPr>
+        <p:spPr>
+          <a:xfrm>
+            <a:off x="8229600" y="2194560"/>
             <a:ext cx="3566160" cy="4114800"/>
           </a:xfrm>
           <a:prstGeom prst="rect">
@@ -9932,84 +10151,68 @@
               </a:spcAft>
             </a:pPr>
             <a:r>
-              <a:rPr sz="1600" b="1">
+              <a:rPr sz="1500" b="1">
                 <a:solidFill>
                   <a:srgbClr val="B71C1C"/>
                 </a:solidFill>
                 <a:latin typeface="Georgia"/>
               </a:rPr>
-              <a:t>Get involved</a:t>
-            </a:r>
-          </a:p>
-          <a:p>
-            <a:pPr algn="l">
-              <a:spcAft>
-                <a:spcPts val="600"/>
-              </a:spcAft>
-            </a:pPr>
-            <a:r>
-              <a:rPr sz="1400" b="0">
-                <a:solidFill>
-                  <a:srgbClr val="26221B"/>
-                </a:solidFill>
-                <a:latin typeface="Georgia"/>
-              </a:rPr>
-              <a:t>• Committee &amp; chair sign-up</a:t>
-            </a:r>
-          </a:p>
-          <a:p>
-            <a:pPr algn="l">
-              <a:spcAft>
-                <a:spcPts val="600"/>
-              </a:spcAft>
-            </a:pPr>
-            <a:r>
-              <a:rPr sz="1400" b="0">
-                <a:solidFill>
-                  <a:srgbClr val="26221B"/>
-                </a:solidFill>
-                <a:latin typeface="Georgia"/>
-              </a:rPr>
-              <a:t>• Superlatives voting</a:t>
-            </a:r>
-          </a:p>
-          <a:p>
-            <a:pPr algn="l">
-              <a:spcAft>
-                <a:spcPts val="600"/>
-              </a:spcAft>
-            </a:pPr>
-            <a:r>
-              <a:rPr sz="1400" b="0">
-                <a:solidFill>
-                  <a:srgbClr val="26221B"/>
-                </a:solidFill>
-                <a:latin typeface="Georgia"/>
-              </a:rPr>
-              <a:t>• Family tree submission form</a:t>
-            </a:r>
-          </a:p>
-          <a:p>
-            <a:pPr algn="l">
-              <a:spcAft>
-                <a:spcPts val="600"/>
-              </a:spcAft>
-            </a:pPr>
-            <a:r>
-              <a:rPr sz="1400" b="0">
-                <a:solidFill>
-                  <a:srgbClr val="26221B"/>
-                </a:solidFill>
-                <a:latin typeface="Georgia"/>
-              </a:rPr>
-              <a:t>• Contact the officers</a:t>
-            </a:r>
-          </a:p>
-        </p:txBody>
-      </p:sp>
-      <p:sp>
-        <p:nvSpPr>
-          <p:cNvPr id="7" name="TextBox 6"/>
+              <a:t>🏙 Closer to Cleveland</a:t>
+            </a:r>
+          </a:p>
+          <a:p>
+            <a:pPr algn="l">
+              <a:spcAft>
+                <a:spcPts val="600"/>
+              </a:spcAft>
+            </a:pPr>
+            <a:r>
+              <a:rPr sz="1300" b="0">
+                <a:solidFill>
+                  <a:srgbClr val="26221B"/>
+                </a:solidFill>
+                <a:latin typeface="Georgia"/>
+              </a:rPr>
+              <a:t>• Salt Fork State Park Lodge — Lore City, OH</a:t>
+            </a:r>
+          </a:p>
+          <a:p>
+            <a:pPr algn="l">
+              <a:spcAft>
+                <a:spcPts val="600"/>
+              </a:spcAft>
+            </a:pPr>
+            <a:r>
+              <a:rPr sz="1300" b="0">
+                <a:solidFill>
+                  <a:srgbClr val="26221B"/>
+                </a:solidFill>
+                <a:latin typeface="Georgia"/>
+              </a:rPr>
+              <a:t>• Punderson Manor Lodge — Newbury, OH</a:t>
+            </a:r>
+          </a:p>
+          <a:p>
+            <a:pPr algn="l">
+              <a:spcAft>
+                <a:spcPts val="600"/>
+              </a:spcAft>
+            </a:pPr>
+            <a:r>
+              <a:rPr sz="1300" b="0">
+                <a:solidFill>
+                  <a:srgbClr val="26221B"/>
+                </a:solidFill>
+                <a:latin typeface="Georgia"/>
+              </a:rPr>
+              <a:t>• The Lodge at Geneva-on-the-Lake — Lake Erie shore</a:t>
+            </a:r>
+          </a:p>
+        </p:txBody>
+      </p:sp>
+      <p:sp>
+        <p:nvSpPr>
+          <p:cNvPr id="8" name="TextBox 7"/>
           <p:cNvSpPr txBox="1"/>
           <p:nvPr/>
         </p:nvSpPr>
@@ -10041,7 +10244,7 @@
                 </a:solidFill>
                 <a:latin typeface="Verdana"/>
               </a:rPr>
-              <a:t>The Technology Committee launches from starter code already written (in the family GitHub repo). Payments run through Zelle/Cash App and a secure processor — we never store card numbers.</a:t>
+              <a:t>The Planning Committee gets group-rate quotes from the top three picks; we choose by member vote. Decade planning = we rotate.</a:t>
             </a:r>
           </a:p>
         </p:txBody>
@@ -10106,7 +10309,7 @@
                 </a:solidFill>
                 <a:latin typeface="Verdana"/>
               </a:rPr>
-              <a:t>FAMILY BUSINESS · OUR LAND</a:t>
+              <a:t>FAMILY BUSINESS · TECHNOLOGY</a:t>
             </a:r>
           </a:p>
         </p:txBody>
@@ -10145,7 +10348,7 @@
                 </a:solidFill>
                 <a:latin typeface="Georgia"/>
               </a:rPr>
-              <a:t>Getting Our Family Land Back 🏡</a:t>
+              <a:t>Our New Home Online: hnfamilyreunion.com 💻</a:t>
             </a:r>
           </a:p>
         </p:txBody>
@@ -10158,57 +10361,97 @@
         </p:nvSpPr>
         <p:spPr>
           <a:xfrm>
-            <a:off x="640080" y="1645920"/>
-            <a:ext cx="5669280" cy="2377440"/>
-          </a:xfrm>
-          <a:prstGeom prst="rect">
-            <a:avLst/>
-          </a:prstGeom>
-          <a:noFill/>
-        </p:spPr>
-        <p:txBody>
-          <a:bodyPr wrap="square">
-            <a:spAutoFit/>
-          </a:bodyPr>
-          <a:lstStyle/>
-          <a:p>
-            <a:pPr algn="l">
-              <a:spcAft>
-                <a:spcPts val="1000"/>
-              </a:spcAft>
-            </a:pPr>
-            <a:r>
-              <a:rPr sz="1600" b="0">
-                <a:solidFill>
-                  <a:srgbClr val="26221B"/>
-                </a:solidFill>
-                <a:latin typeface="Georgia"/>
-              </a:rPr>
-              <a:t>We are partnering with Where Is My Land (whereismyland.com) — an organization that helps Black families research, document, and reclaim land that was taken from them.</a:t>
-            </a:r>
-          </a:p>
-          <a:p>
-            <a:pPr algn="l">
-              <a:spcAft>
-                <a:spcPts val="600"/>
-              </a:spcAft>
-            </a:pPr>
-            <a:r>
-              <a:rPr sz="1500" b="0">
-                <a:solidFill>
-                  <a:srgbClr val="26221B"/>
-                </a:solidFill>
-                <a:latin typeface="Georgia"/>
-              </a:rPr>
-              <a:t>Step 1: gather deeds, tax records &amp; oral history</a:t>
-            </a:r>
-            <a:br/>
-            <a:r>
-              <a:t>Step 2: fund the RETAINER through reunion fundraising</a:t>
-            </a:r>
-            <a:br/>
-            <a:r>
-              <a:t>Step 3: family volunteers support the research</a:t>
+            <a:off x="640080" y="1737360"/>
+            <a:ext cx="3657600" cy="4114800"/>
+          </a:xfrm>
+          <a:prstGeom prst="rect">
+            <a:avLst/>
+          </a:prstGeom>
+          <a:noFill/>
+        </p:spPr>
+        <p:txBody>
+          <a:bodyPr wrap="square">
+            <a:spAutoFit/>
+          </a:bodyPr>
+          <a:lstStyle/>
+          <a:p>
+            <a:pPr algn="l">
+              <a:spcAft>
+                <a:spcPts val="800"/>
+              </a:spcAft>
+            </a:pPr>
+            <a:r>
+              <a:rPr sz="1600" b="1">
+                <a:solidFill>
+                  <a:srgbClr val="2E7D32"/>
+                </a:solidFill>
+                <a:latin typeface="Georgia"/>
+              </a:rPr>
+              <a:t>Everything reunion</a:t>
+            </a:r>
+          </a:p>
+          <a:p>
+            <a:pPr algn="l">
+              <a:spcAft>
+                <a:spcPts val="600"/>
+              </a:spcAft>
+            </a:pPr>
+            <a:r>
+              <a:rPr sz="1400" b="0">
+                <a:solidFill>
+                  <a:srgbClr val="26221B"/>
+                </a:solidFill>
+                <a:latin typeface="Georgia"/>
+              </a:rPr>
+              <a:t>• Announcements &amp; event schedule</a:t>
+            </a:r>
+          </a:p>
+          <a:p>
+            <a:pPr algn="l">
+              <a:spcAft>
+                <a:spcPts val="600"/>
+              </a:spcAft>
+            </a:pPr>
+            <a:r>
+              <a:rPr sz="1400" b="0">
+                <a:solidFill>
+                  <a:srgbClr val="26221B"/>
+                </a:solidFill>
+                <a:latin typeface="Georgia"/>
+              </a:rPr>
+              <a:t>• Family history &amp; photo gallery</a:t>
+            </a:r>
+          </a:p>
+          <a:p>
+            <a:pPr algn="l">
+              <a:spcAft>
+                <a:spcPts val="600"/>
+              </a:spcAft>
+            </a:pPr>
+            <a:r>
+              <a:rPr sz="1400" b="0">
+                <a:solidFill>
+                  <a:srgbClr val="26221B"/>
+                </a:solidFill>
+                <a:latin typeface="Georgia"/>
+              </a:rPr>
+              <a:t>• 2024 slideshow &amp; yearbook archive</a:t>
+            </a:r>
+          </a:p>
+          <a:p>
+            <a:pPr algn="l">
+              <a:spcAft>
+                <a:spcPts val="600"/>
+              </a:spcAft>
+            </a:pPr>
+            <a:r>
+              <a:rPr sz="1400" b="0">
+                <a:solidFill>
+                  <a:srgbClr val="26221B"/>
+                </a:solidFill>
+                <a:latin typeface="Georgia"/>
+              </a:rPr>
+              <a:t>• Memorial page</a:t>
             </a:r>
           </a:p>
         </p:txBody>
@@ -10221,8 +10464,8 @@
         </p:nvSpPr>
         <p:spPr>
           <a:xfrm>
-            <a:off x="6583680" y="1645920"/>
-            <a:ext cx="4937760" cy="4114800"/>
+            <a:off x="4434840" y="1737360"/>
+            <a:ext cx="3657600" cy="4114800"/>
           </a:xfrm>
           <a:prstGeom prst="rect">
             <a:avLst/>
@@ -10241,77 +10484,61 @@
               </a:spcAft>
             </a:pPr>
             <a:r>
-              <a:rPr sz="1700" b="1">
+              <a:rPr sz="1600" b="1">
                 <a:solidFill>
                   <a:srgbClr val="E65100"/>
                 </a:solidFill>
                 <a:latin typeface="Georgia"/>
               </a:rPr>
-              <a:t>How fundraising is split</a:t>
-            </a:r>
-          </a:p>
-          <a:p>
-            <a:pPr algn="l">
-              <a:spcAft>
-                <a:spcPts val="600"/>
-              </a:spcAft>
-            </a:pPr>
-            <a:r>
-              <a:rPr sz="1500" b="0">
-                <a:solidFill>
-                  <a:srgbClr val="26221B"/>
-                </a:solidFill>
-                <a:latin typeface="Georgia"/>
-              </a:rPr>
-              <a:t>• 🏡 A share of every fundraiser → the land-back fund (retainer + renovation &amp; revitalization of our land)</a:t>
-            </a:r>
-          </a:p>
-          <a:p>
-            <a:pPr algn="l">
-              <a:spcAft>
-                <a:spcPts val="600"/>
-              </a:spcAft>
-            </a:pPr>
-            <a:r>
-              <a:rPr sz="1500" b="0">
-                <a:solidFill>
-                  <a:srgbClr val="26221B"/>
-                </a:solidFill>
-                <a:latin typeface="Georgia"/>
-              </a:rPr>
-              <a:t>• 🛠 A share → the OPERATING FUND (strictly operating costs: website hosting, printing, permits + seed money for future reunions)</a:t>
-            </a:r>
-          </a:p>
-          <a:p>
-            <a:pPr algn="l">
-              <a:spcAft>
-                <a:spcPts val="600"/>
-              </a:spcAft>
-            </a:pPr>
-            <a:r>
-              <a:rPr sz="1500" b="0">
-                <a:solidFill>
-                  <a:srgbClr val="26221B"/>
-                </a:solidFill>
-                <a:latin typeface="Georgia"/>
-              </a:rPr>
-              <a:t>• 🎓 A share → the scholarship fund</a:t>
-            </a:r>
-          </a:p>
-          <a:p>
-            <a:pPr algn="l">
-              <a:spcAft>
-                <a:spcPts val="600"/>
-              </a:spcAft>
-            </a:pPr>
-            <a:r>
-              <a:rPr sz="1500" b="0">
-                <a:solidFill>
-                  <a:srgbClr val="26221B"/>
-                </a:solidFill>
-                <a:latin typeface="Georgia"/>
-              </a:rPr>
-              <a:t>• Exact percentages set by member vote today — chair, entertain a motion!</a:t>
+              <a:t>Payments &amp; shop</a:t>
+            </a:r>
+          </a:p>
+          <a:p>
+            <a:pPr algn="l">
+              <a:spcAft>
+                <a:spcPts val="600"/>
+              </a:spcAft>
+            </a:pPr>
+            <a:r>
+              <a:rPr sz="1400" b="0">
+                <a:solidFill>
+                  <a:srgbClr val="26221B"/>
+                </a:solidFill>
+                <a:latin typeface="Georgia"/>
+              </a:rPr>
+              <a:t>• Registration &amp; dues online</a:t>
+            </a:r>
+          </a:p>
+          <a:p>
+            <a:pPr algn="l">
+              <a:spcAft>
+                <a:spcPts val="600"/>
+              </a:spcAft>
+            </a:pPr>
+            <a:r>
+              <a:rPr sz="1400" b="0">
+                <a:solidFill>
+                  <a:srgbClr val="26221B"/>
+                </a:solidFill>
+                <a:latin typeface="Georgia"/>
+              </a:rPr>
+              <a:t>• T-shirt orders</a:t>
+            </a:r>
+          </a:p>
+          <a:p>
+            <a:pPr algn="l">
+              <a:spcAft>
+                <a:spcPts val="600"/>
+              </a:spcAft>
+            </a:pPr>
+            <a:r>
+              <a:rPr sz="1400" b="0">
+                <a:solidFill>
+                  <a:srgbClr val="26221B"/>
+                </a:solidFill>
+                <a:latin typeface="Georgia"/>
+              </a:rPr>
+              <a:t>• Donations to the Land &amp; Scholarship funds</a:t>
             </a:r>
           </a:p>
         </p:txBody>
@@ -10319,6 +10546,109 @@
       <p:sp>
         <p:nvSpPr>
           <p:cNvPr id="6" name="TextBox 5"/>
+          <p:cNvSpPr txBox="1"/>
+          <p:nvPr/>
+        </p:nvSpPr>
+        <p:spPr>
+          <a:xfrm>
+            <a:off x="8229600" y="1737360"/>
+            <a:ext cx="3566160" cy="4114800"/>
+          </a:xfrm>
+          <a:prstGeom prst="rect">
+            <a:avLst/>
+          </a:prstGeom>
+          <a:noFill/>
+        </p:spPr>
+        <p:txBody>
+          <a:bodyPr wrap="square">
+            <a:spAutoFit/>
+          </a:bodyPr>
+          <a:lstStyle/>
+          <a:p>
+            <a:pPr algn="l">
+              <a:spcAft>
+                <a:spcPts val="800"/>
+              </a:spcAft>
+            </a:pPr>
+            <a:r>
+              <a:rPr sz="1600" b="1">
+                <a:solidFill>
+                  <a:srgbClr val="B71C1C"/>
+                </a:solidFill>
+                <a:latin typeface="Georgia"/>
+              </a:rPr>
+              <a:t>Get involved</a:t>
+            </a:r>
+          </a:p>
+          <a:p>
+            <a:pPr algn="l">
+              <a:spcAft>
+                <a:spcPts val="600"/>
+              </a:spcAft>
+            </a:pPr>
+            <a:r>
+              <a:rPr sz="1400" b="0">
+                <a:solidFill>
+                  <a:srgbClr val="26221B"/>
+                </a:solidFill>
+                <a:latin typeface="Georgia"/>
+              </a:rPr>
+              <a:t>• Committee &amp; chair sign-up</a:t>
+            </a:r>
+          </a:p>
+          <a:p>
+            <a:pPr algn="l">
+              <a:spcAft>
+                <a:spcPts val="600"/>
+              </a:spcAft>
+            </a:pPr>
+            <a:r>
+              <a:rPr sz="1400" b="0">
+                <a:solidFill>
+                  <a:srgbClr val="26221B"/>
+                </a:solidFill>
+                <a:latin typeface="Georgia"/>
+              </a:rPr>
+              <a:t>• Superlatives voting</a:t>
+            </a:r>
+          </a:p>
+          <a:p>
+            <a:pPr algn="l">
+              <a:spcAft>
+                <a:spcPts val="600"/>
+              </a:spcAft>
+            </a:pPr>
+            <a:r>
+              <a:rPr sz="1400" b="0">
+                <a:solidFill>
+                  <a:srgbClr val="26221B"/>
+                </a:solidFill>
+                <a:latin typeface="Georgia"/>
+              </a:rPr>
+              <a:t>• Family tree submission form</a:t>
+            </a:r>
+          </a:p>
+          <a:p>
+            <a:pPr algn="l">
+              <a:spcAft>
+                <a:spcPts val="600"/>
+              </a:spcAft>
+            </a:pPr>
+            <a:r>
+              <a:rPr sz="1400" b="0">
+                <a:solidFill>
+                  <a:srgbClr val="26221B"/>
+                </a:solidFill>
+                <a:latin typeface="Georgia"/>
+              </a:rPr>
+              <a:t>• Contact the officers</a:t>
+            </a:r>
+          </a:p>
+        </p:txBody>
+      </p:sp>
+      <p:sp>
+        <p:nvSpPr>
+          <p:cNvPr id="7" name="TextBox 6"/>
           <p:cNvSpPr txBox="1"/>
           <p:nvPr/>
         </p:nvSpPr>
@@ -10350,7 +10680,7 @@
                 </a:solidFill>
                 <a:latin typeface="Verdana"/>
               </a:rPr>
-              <a:t>If our claim succeeds, recovered land/proceeds are stewarded by the family foundation.</a:t>
+              <a:t>The Technology Committee launches from starter code already written (in the family GitHub repo). Payments run through Zelle/Cash App and a secure processor — we never store card numbers.</a:t>
             </a:r>
           </a:p>
         </p:txBody>
@@ -10415,7 +10745,7 @@
                 </a:solidFill>
                 <a:latin typeface="Verdana"/>
               </a:rPr>
-              <a:t>FAMILY BUSINESS · EDUCATION</a:t>
+              <a:t>FAMILY BUSINESS · OUR LAND</a:t>
             </a:r>
           </a:p>
         </p:txBody>
@@ -10454,7 +10784,7 @@
                 </a:solidFill>
                 <a:latin typeface="Georgia"/>
               </a:rPr>
-              <a:t>The Harris-Nelson Scholarship Fund 🎓</a:t>
+              <a:t>Getting Our Family Land Back 🏡</a:t>
             </a:r>
           </a:p>
         </p:txBody>
@@ -10468,7 +10798,70 @@
         <p:spPr>
           <a:xfrm>
             <a:off x="640080" y="1645920"/>
-            <a:ext cx="5486400" cy="4114800"/>
+            <a:ext cx="5669280" cy="2377440"/>
+          </a:xfrm>
+          <a:prstGeom prst="rect">
+            <a:avLst/>
+          </a:prstGeom>
+          <a:noFill/>
+        </p:spPr>
+        <p:txBody>
+          <a:bodyPr wrap="square">
+            <a:spAutoFit/>
+          </a:bodyPr>
+          <a:lstStyle/>
+          <a:p>
+            <a:pPr algn="l">
+              <a:spcAft>
+                <a:spcPts val="1000"/>
+              </a:spcAft>
+            </a:pPr>
+            <a:r>
+              <a:rPr sz="1600" b="0">
+                <a:solidFill>
+                  <a:srgbClr val="26221B"/>
+                </a:solidFill>
+                <a:latin typeface="Georgia"/>
+              </a:rPr>
+              <a:t>We are partnering with Where Is My Land (whereismyland.com) — an organization that helps Black families research, document, and reclaim land that was taken from them.</a:t>
+            </a:r>
+          </a:p>
+          <a:p>
+            <a:pPr algn="l">
+              <a:spcAft>
+                <a:spcPts val="600"/>
+              </a:spcAft>
+            </a:pPr>
+            <a:r>
+              <a:rPr sz="1500" b="0">
+                <a:solidFill>
+                  <a:srgbClr val="26221B"/>
+                </a:solidFill>
+                <a:latin typeface="Georgia"/>
+              </a:rPr>
+              <a:t>Step 1: gather deeds, tax records &amp; oral history</a:t>
+            </a:r>
+            <a:br/>
+            <a:r>
+              <a:t>Step 2: fund the RETAINER through reunion fundraising</a:t>
+            </a:r>
+            <a:br/>
+            <a:r>
+              <a:t>Step 3: family volunteers support the research</a:t>
+            </a:r>
+          </a:p>
+        </p:txBody>
+      </p:sp>
+      <p:sp>
+        <p:nvSpPr>
+          <p:cNvPr id="5" name="TextBox 4"/>
+          <p:cNvSpPr txBox="1"/>
+          <p:nvPr/>
+        </p:nvSpPr>
+        <p:spPr>
+          <a:xfrm>
+            <a:off x="6583680" y="1645920"/>
+            <a:ext cx="4937760" cy="4114800"/>
           </a:xfrm>
           <a:prstGeom prst="rect">
             <a:avLst/>
@@ -10489,11 +10882,11 @@
             <a:r>
               <a:rPr sz="1700" b="1">
                 <a:solidFill>
-                  <a:srgbClr val="2E7D32"/>
-                </a:solidFill>
-                <a:latin typeface="Georgia"/>
-              </a:rPr>
-              <a:t>A scholarship for descendants of our ancestors</a:t>
+                  <a:srgbClr val="E65100"/>
+                </a:solidFill>
+                <a:latin typeface="Georgia"/>
+              </a:rPr>
+              <a:t>How fundraising is split</a:t>
             </a:r>
           </a:p>
           <a:p>
@@ -10509,7 +10902,7 @@
                 </a:solidFill>
                 <a:latin typeface="Georgia"/>
               </a:rPr>
-              <a:t>• Who: any descendant enrolled (or enrolling) in an accredited program — college, trade school, certifications</a:t>
+              <a:t>• 🏡 A share of every fundraiser → the land-back fund (retainer + renovation &amp; revitalization of our land)</a:t>
             </a:r>
           </a:p>
           <a:p>
@@ -10525,7 +10918,7 @@
                 </a:solidFill>
                 <a:latin typeface="Georgia"/>
               </a:rPr>
-              <a:t>• How: short application + one-page essay on what family legacy means to you</a:t>
+              <a:t>• 🛠 A share → the OPERATING FUND (strictly operating costs: website hosting, printing, permits + seed money for future reunions)</a:t>
             </a:r>
           </a:p>
           <a:p>
@@ -10541,46 +10934,7 @@
                 </a:solidFill>
                 <a:latin typeface="Georgia"/>
               </a:rPr>
-              <a:t>• Selection: Philanthropy &amp; Fundraising Committee reviews; officers ratify; awarded at the banquet</a:t>
-            </a:r>
-          </a:p>
-        </p:txBody>
-      </p:sp>
-      <p:sp>
-        <p:nvSpPr>
-          <p:cNvPr id="5" name="TextBox 4"/>
-          <p:cNvSpPr txBox="1"/>
-          <p:nvPr/>
-        </p:nvSpPr>
-        <p:spPr>
-          <a:xfrm>
-            <a:off x="6400800" y="1645920"/>
-            <a:ext cx="5120640" cy="4114800"/>
-          </a:xfrm>
-          <a:prstGeom prst="rect">
-            <a:avLst/>
-          </a:prstGeom>
-          <a:noFill/>
-        </p:spPr>
-        <p:txBody>
-          <a:bodyPr wrap="square">
-            <a:spAutoFit/>
-          </a:bodyPr>
-          <a:lstStyle/>
-          <a:p>
-            <a:pPr algn="l">
-              <a:spcAft>
-                <a:spcPts val="800"/>
-              </a:spcAft>
-            </a:pPr>
-            <a:r>
-              <a:rPr sz="1700" b="1">
-                <a:solidFill>
-                  <a:srgbClr val="B71C1C"/>
-                </a:solidFill>
-                <a:latin typeface="Georgia"/>
-              </a:rPr>
-              <a:t>How we'll fund it</a:t>
+              <a:t>• 🎓 A share → the scholarship fund</a:t>
             </a:r>
           </a:p>
           <a:p>
@@ -10596,55 +10950,7 @@
                 </a:solidFill>
                 <a:latin typeface="Georgia"/>
               </a:rPr>
-              <a:t>• A set share of all reunion fundraising (vote today)</a:t>
-            </a:r>
-          </a:p>
-          <a:p>
-            <a:pPr algn="l">
-              <a:spcAft>
-                <a:spcPts val="600"/>
-              </a:spcAft>
-            </a:pPr>
-            <a:r>
-              <a:rPr sz="1500" b="0">
-                <a:solidFill>
-                  <a:srgbClr val="26221B"/>
-                </a:solidFill>
-                <a:latin typeface="Georgia"/>
-              </a:rPr>
-              <a:t>• Dedicated fundraisers: raffle, fish fry, walk-a-thon, souvenirs</a:t>
-            </a:r>
-          </a:p>
-          <a:p>
-            <a:pPr algn="l">
-              <a:spcAft>
-                <a:spcPts val="600"/>
-              </a:spcAft>
-            </a:pPr>
-            <a:r>
-              <a:rPr sz="1500" b="0">
-                <a:solidFill>
-                  <a:srgbClr val="26221B"/>
-                </a:solidFill>
-                <a:latin typeface="Georgia"/>
-              </a:rPr>
-              <a:t>• Online giving — in honor or in memory of a loved one</a:t>
-            </a:r>
-          </a:p>
-          <a:p>
-            <a:pPr algn="l">
-              <a:spcAft>
-                <a:spcPts val="600"/>
-              </a:spcAft>
-            </a:pPr>
-            <a:r>
-              <a:rPr sz="1500" b="0">
-                <a:solidFill>
-                  <a:srgbClr val="26221B"/>
-                </a:solidFill>
-                <a:latin typeface="Georgia"/>
-              </a:rPr>
-              <a:t>• Tax-deductible once the 501(c)(3) is approved</a:t>
+              <a:t>• Exact percentages set by member vote today — chair, entertain a motion!</a:t>
             </a:r>
           </a:p>
         </p:txBody>
@@ -10683,7 +10989,7 @@
                 </a:solidFill>
                 <a:latin typeface="Verdana"/>
               </a:rPr>
-              <a:t>Goal: award our first scholarship(s) at the next reunion.</a:t>
+              <a:t>If our claim succeeds, recovered land/proceeds are stewarded by the family foundation.</a:t>
             </a:r>
           </a:p>
         </p:txBody>
@@ -10748,7 +11054,7 @@
                 </a:solidFill>
                 <a:latin typeface="Verdana"/>
               </a:rPr>
-              <a:t>FAMILY BUSINESS · NEW PROGRAM</a:t>
+              <a:t>FAMILY BUSINESS · EDUCATION</a:t>
             </a:r>
           </a:p>
         </p:txBody>
@@ -10787,7 +11093,7 @@
                 </a:solidFill>
                 <a:latin typeface="Georgia"/>
               </a:rPr>
-              <a:t>Helping Hands — the Family Hardship Fund 🤝</a:t>
+              <a:t>The Harris-Nelson Scholarship Fund 🎓</a:t>
             </a:r>
           </a:p>
         </p:txBody>
@@ -10801,7 +11107,7 @@
         <p:spPr>
           <a:xfrm>
             <a:off x="640080" y="1645920"/>
-            <a:ext cx="3657600" cy="4114800"/>
+            <a:ext cx="5486400" cy="4114800"/>
           </a:xfrm>
           <a:prstGeom prst="rect">
             <a:avLst/>
@@ -10820,61 +11126,61 @@
               </a:spcAft>
             </a:pPr>
             <a:r>
-              <a:rPr sz="1500" b="1">
+              <a:rPr sz="1700" b="1">
                 <a:solidFill>
                   <a:srgbClr val="2E7D32"/>
                 </a:solidFill>
                 <a:latin typeface="Georgia"/>
               </a:rPr>
-              <a:t>Who can apply</a:t>
-            </a:r>
-          </a:p>
-          <a:p>
-            <a:pPr algn="l">
-              <a:spcAft>
-                <a:spcPts val="600"/>
-              </a:spcAft>
-            </a:pPr>
-            <a:r>
-              <a:rPr sz="1300" b="0">
-                <a:solidFill>
-                  <a:srgbClr val="26221B"/>
-                </a:solidFill>
-                <a:latin typeface="Georgia"/>
-              </a:rPr>
-              <a:t>• Any descendant, spouse/partner, or child (minors via a guardian) — or apply on behalf of a relative</a:t>
-            </a:r>
-          </a:p>
-          <a:p>
-            <a:pPr algn="l">
-              <a:spcAft>
-                <a:spcPts val="600"/>
-              </a:spcAft>
-            </a:pPr>
-            <a:r>
-              <a:rPr sz="1300" b="0">
-                <a:solidFill>
-                  <a:srgbClr val="26221B"/>
-                </a:solidFill>
-                <a:latin typeface="Georgia"/>
-              </a:rPr>
-              <a:t>• Hardship within the past 12 months: medical, job loss, housing/disaster, funeral, caregiving, education emergency</a:t>
-            </a:r>
-          </a:p>
-          <a:p>
-            <a:pPr algn="l">
-              <a:spcAft>
-                <a:spcPts val="600"/>
-              </a:spcAft>
-            </a:pPr>
-            <a:r>
-              <a:rPr sz="1300" b="0">
-                <a:solidFill>
-                  <a:srgbClr val="26221B"/>
-                </a:solidFill>
-                <a:latin typeface="Georgia"/>
-              </a:rPr>
-              <a:t>• One award per household per cycle; dues status does NOT affect eligibility</a:t>
+              <a:t>A scholarship for descendants of our ancestors</a:t>
+            </a:r>
+          </a:p>
+          <a:p>
+            <a:pPr algn="l">
+              <a:spcAft>
+                <a:spcPts val="600"/>
+              </a:spcAft>
+            </a:pPr>
+            <a:r>
+              <a:rPr sz="1500" b="0">
+                <a:solidFill>
+                  <a:srgbClr val="26221B"/>
+                </a:solidFill>
+                <a:latin typeface="Georgia"/>
+              </a:rPr>
+              <a:t>• Who: any descendant enrolled (or enrolling) in an accredited program — college, trade school, certifications</a:t>
+            </a:r>
+          </a:p>
+          <a:p>
+            <a:pPr algn="l">
+              <a:spcAft>
+                <a:spcPts val="600"/>
+              </a:spcAft>
+            </a:pPr>
+            <a:r>
+              <a:rPr sz="1500" b="0">
+                <a:solidFill>
+                  <a:srgbClr val="26221B"/>
+                </a:solidFill>
+                <a:latin typeface="Georgia"/>
+              </a:rPr>
+              <a:t>• How: short application + one-page essay on what family legacy means to you</a:t>
+            </a:r>
+          </a:p>
+          <a:p>
+            <a:pPr algn="l">
+              <a:spcAft>
+                <a:spcPts val="600"/>
+              </a:spcAft>
+            </a:pPr>
+            <a:r>
+              <a:rPr sz="1500" b="0">
+                <a:solidFill>
+                  <a:srgbClr val="26221B"/>
+                </a:solidFill>
+                <a:latin typeface="Georgia"/>
+              </a:rPr>
+              <a:t>• Selection: Philanthropy &amp; Fundraising Committee reviews; officers ratify; awarded at the banquet</a:t>
             </a:r>
           </a:p>
         </p:txBody>
@@ -10887,8 +11193,8 @@
         </p:nvSpPr>
         <p:spPr>
           <a:xfrm>
-            <a:off x="4434840" y="1645920"/>
-            <a:ext cx="3657600" cy="4114800"/>
+            <a:off x="6400800" y="1645920"/>
+            <a:ext cx="5120640" cy="4114800"/>
           </a:xfrm>
           <a:prstGeom prst="rect">
             <a:avLst/>
@@ -10907,77 +11213,77 @@
               </a:spcAft>
             </a:pPr>
             <a:r>
-              <a:rPr sz="1500" b="1">
-                <a:solidFill>
-                  <a:srgbClr val="E65100"/>
-                </a:solidFill>
-                <a:latin typeface="Georgia"/>
-              </a:rPr>
-              <a:t>How the recipient is chosen</a:t>
-            </a:r>
-          </a:p>
-          <a:p>
-            <a:pPr algn="l">
-              <a:spcAft>
-                <a:spcPts val="600"/>
-              </a:spcAft>
-            </a:pPr>
-            <a:r>
-              <a:rPr sz="1300" b="0">
-                <a:solidFill>
-                  <a:srgbClr val="26221B"/>
-                </a:solidFill>
-                <a:latin typeface="Georgia"/>
-              </a:rPr>
-              <a:t>• Confidential application → Philanthropy &amp; Fundraising Committee scores it</a:t>
-            </a:r>
-          </a:p>
-          <a:p>
-            <a:pPr algn="l">
-              <a:spcAft>
-                <a:spcPts val="600"/>
-              </a:spcAft>
-            </a:pPr>
-            <a:r>
-              <a:rPr sz="1300" b="0">
-                <a:solidFill>
-                  <a:srgbClr val="26221B"/>
-                </a:solidFill>
-                <a:latin typeface="Georgia"/>
-              </a:rPr>
-              <a:t>• Rubric: severity &amp; urgency 40% · impact 30% · clarity &amp; completeness 20% · discretion 10%</a:t>
-            </a:r>
-          </a:p>
-          <a:p>
-            <a:pPr algn="l">
-              <a:spcAft>
-                <a:spcPts val="600"/>
-              </a:spcAft>
-            </a:pPr>
-            <a:r>
-              <a:rPr sz="1300" b="0">
-                <a:solidFill>
-                  <a:srgbClr val="26221B"/>
-                </a:solidFill>
-                <a:latin typeface="Georgia"/>
-              </a:rPr>
-              <a:t>• 3+ independent scorers; household conflicts recuse; officers ratify</a:t>
-            </a:r>
-          </a:p>
-          <a:p>
-            <a:pPr algn="l">
-              <a:spcAft>
-                <a:spcPts val="600"/>
-              </a:spcAft>
-            </a:pPr>
-            <a:r>
-              <a:rPr sz="1300" b="0">
-                <a:solidFill>
-                  <a:srgbClr val="26221B"/>
-                </a:solidFill>
-                <a:latin typeface="Georgia"/>
-              </a:rPr>
-              <a:t>• Recipient may stay ANONYMOUS — always their choice</a:t>
+              <a:rPr sz="1700" b="1">
+                <a:solidFill>
+                  <a:srgbClr val="B71C1C"/>
+                </a:solidFill>
+                <a:latin typeface="Georgia"/>
+              </a:rPr>
+              <a:t>How we'll fund it</a:t>
+            </a:r>
+          </a:p>
+          <a:p>
+            <a:pPr algn="l">
+              <a:spcAft>
+                <a:spcPts val="600"/>
+              </a:spcAft>
+            </a:pPr>
+            <a:r>
+              <a:rPr sz="1500" b="0">
+                <a:solidFill>
+                  <a:srgbClr val="26221B"/>
+                </a:solidFill>
+                <a:latin typeface="Georgia"/>
+              </a:rPr>
+              <a:t>• A set share of all reunion fundraising (vote today)</a:t>
+            </a:r>
+          </a:p>
+          <a:p>
+            <a:pPr algn="l">
+              <a:spcAft>
+                <a:spcPts val="600"/>
+              </a:spcAft>
+            </a:pPr>
+            <a:r>
+              <a:rPr sz="1500" b="0">
+                <a:solidFill>
+                  <a:srgbClr val="26221B"/>
+                </a:solidFill>
+                <a:latin typeface="Georgia"/>
+              </a:rPr>
+              <a:t>• Dedicated fundraisers: raffle, fish fry, walk-a-thon, souvenirs</a:t>
+            </a:r>
+          </a:p>
+          <a:p>
+            <a:pPr algn="l">
+              <a:spcAft>
+                <a:spcPts val="600"/>
+              </a:spcAft>
+            </a:pPr>
+            <a:r>
+              <a:rPr sz="1500" b="0">
+                <a:solidFill>
+                  <a:srgbClr val="26221B"/>
+                </a:solidFill>
+                <a:latin typeface="Georgia"/>
+              </a:rPr>
+              <a:t>• Online giving — in honor or in memory of a loved one</a:t>
+            </a:r>
+          </a:p>
+          <a:p>
+            <a:pPr algn="l">
+              <a:spcAft>
+                <a:spcPts val="600"/>
+              </a:spcAft>
+            </a:pPr>
+            <a:r>
+              <a:rPr sz="1500" b="0">
+                <a:solidFill>
+                  <a:srgbClr val="26221B"/>
+                </a:solidFill>
+                <a:latin typeface="Georgia"/>
+              </a:rPr>
+              <a:t>• Tax-deductible once the 501(c)(3) is approved</a:t>
             </a:r>
           </a:p>
         </p:txBody>
@@ -10985,109 +11291,6 @@
       <p:sp>
         <p:nvSpPr>
           <p:cNvPr id="6" name="TextBox 5"/>
-          <p:cNvSpPr txBox="1"/>
-          <p:nvPr/>
-        </p:nvSpPr>
-        <p:spPr>
-          <a:xfrm>
-            <a:off x="8229600" y="1645920"/>
-            <a:ext cx="3566160" cy="4114800"/>
-          </a:xfrm>
-          <a:prstGeom prst="rect">
-            <a:avLst/>
-          </a:prstGeom>
-          <a:noFill/>
-        </p:spPr>
-        <p:txBody>
-          <a:bodyPr wrap="square">
-            <a:spAutoFit/>
-          </a:bodyPr>
-          <a:lstStyle/>
-          <a:p>
-            <a:pPr algn="l">
-              <a:spcAft>
-                <a:spcPts val="800"/>
-              </a:spcAft>
-            </a:pPr>
-            <a:r>
-              <a:rPr sz="1500" b="1">
-                <a:solidFill>
-                  <a:srgbClr val="B71C1C"/>
-                </a:solidFill>
-                <a:latin typeface="Georgia"/>
-              </a:rPr>
-              <a:t>Deadlines each cycle</a:t>
-            </a:r>
-          </a:p>
-          <a:p>
-            <a:pPr algn="l">
-              <a:spcAft>
-                <a:spcPts val="600"/>
-              </a:spcAft>
-            </a:pPr>
-            <a:r>
-              <a:rPr sz="1300" b="0">
-                <a:solidFill>
-                  <a:srgbClr val="26221B"/>
-                </a:solidFill>
-                <a:latin typeface="Georgia"/>
-              </a:rPr>
-              <a:t>• Applications open January 1 of the reunion year</a:t>
-            </a:r>
-          </a:p>
-          <a:p>
-            <a:pPr algn="l">
-              <a:spcAft>
-                <a:spcPts val="600"/>
-              </a:spcAft>
-            </a:pPr>
-            <a:r>
-              <a:rPr sz="1300" b="0">
-                <a:solidFill>
-                  <a:srgbClr val="26221B"/>
-                </a:solidFill>
-                <a:latin typeface="Georgia"/>
-              </a:rPr>
-              <a:t>• Deadline: 30 days before the reunion</a:t>
-            </a:r>
-          </a:p>
-          <a:p>
-            <a:pPr algn="l">
-              <a:spcAft>
-                <a:spcPts val="600"/>
-              </a:spcAft>
-            </a:pPr>
-            <a:r>
-              <a:rPr sz="1300" b="0">
-                <a:solidFill>
-                  <a:srgbClr val="26221B"/>
-                </a:solidFill>
-                <a:latin typeface="Georgia"/>
-              </a:rPr>
-              <a:t>• Committee scores by 14 days out; officers ratify by 7</a:t>
-            </a:r>
-          </a:p>
-          <a:p>
-            <a:pPr algn="l">
-              <a:spcAft>
-                <a:spcPts val="600"/>
-              </a:spcAft>
-            </a:pPr>
-            <a:r>
-              <a:rPr sz="1300" b="0">
-                <a:solidFill>
-                  <a:srgbClr val="26221B"/>
-                </a:solidFill>
-                <a:latin typeface="Georgia"/>
-              </a:rPr>
-              <a:t>• Award presented at Sunday brunch</a:t>
-            </a:r>
-          </a:p>
-        </p:txBody>
-      </p:sp>
-      <p:sp>
-        <p:nvSpPr>
-          <p:cNvPr id="7" name="TextBox 6"/>
           <p:cNvSpPr txBox="1"/>
           <p:nvPr/>
         </p:nvSpPr>
@@ -11119,7 +11322,7 @@
                 </a:solidFill>
                 <a:latin typeface="Verdana"/>
               </a:rPr>
-              <a:t>Apply at hnfamilyreunion.com (Hardship Fund page) or on paper from any officer. Award amount set by the Treasurer's budget each cycle — funded from the fundraising split.</a:t>
+              <a:t>Goal: award our first scholarship(s) at the next reunion.</a:t>
             </a:r>
           </a:p>
         </p:txBody>
@@ -11184,7 +11387,7 @@
                 </a:solidFill>
                 <a:latin typeface="Verdana"/>
               </a:rPr>
-              <a:t>FAMILY BUSINESS · THE FOUNDATION</a:t>
+              <a:t>FAMILY BUSINESS · NEW PROGRAM</a:t>
             </a:r>
           </a:p>
         </p:txBody>
@@ -11223,7 +11426,7 @@
                 </a:solidFill>
                 <a:latin typeface="Georgia"/>
               </a:rPr>
-              <a:t>Starting Our Family Foundation — a 501(c)(3) 🏛</a:t>
+              <a:t>Helping Hands — the Family Hardship Fund 🤝</a:t>
             </a:r>
           </a:p>
         </p:txBody>
@@ -11237,7 +11440,7 @@
         <p:spPr>
           <a:xfrm>
             <a:off x="640080" y="1645920"/>
-            <a:ext cx="5486400" cy="4114800"/>
+            <a:ext cx="3657600" cy="4114800"/>
           </a:xfrm>
           <a:prstGeom prst="rect">
             <a:avLst/>
@@ -11256,77 +11459,61 @@
               </a:spcAft>
             </a:pPr>
             <a:r>
-              <a:rPr sz="1700" b="1">
+              <a:rPr sz="1500" b="1">
                 <a:solidFill>
                   <a:srgbClr val="2E7D32"/>
                 </a:solidFill>
                 <a:latin typeface="Georgia"/>
               </a:rPr>
-              <a:t>The process (next few months)</a:t>
-            </a:r>
-          </a:p>
-          <a:p>
-            <a:pPr algn="l">
-              <a:spcAft>
-                <a:spcPts val="600"/>
-              </a:spcAft>
-            </a:pPr>
-            <a:r>
-              <a:rPr sz="1500" b="0">
-                <a:solidFill>
-                  <a:srgbClr val="26221B"/>
-                </a:solidFill>
-                <a:latin typeface="Georgia"/>
-              </a:rPr>
-              <a:t>• Month 1: choose the name, elect the founding board, draft bylaws &amp; conflict-of-interest policy</a:t>
-            </a:r>
-          </a:p>
-          <a:p>
-            <a:pPr algn="l">
-              <a:spcAft>
-                <a:spcPts val="600"/>
-              </a:spcAft>
-            </a:pPr>
-            <a:r>
-              <a:rPr sz="1500" b="0">
-                <a:solidFill>
-                  <a:srgbClr val="26221B"/>
-                </a:solidFill>
-                <a:latin typeface="Georgia"/>
-              </a:rPr>
-              <a:t>• Month 1–2: file Articles of Incorporation; get an EIN (free, IRS.gov)</a:t>
-            </a:r>
-          </a:p>
-          <a:p>
-            <a:pPr algn="l">
-              <a:spcAft>
-                <a:spcPts val="600"/>
-              </a:spcAft>
-            </a:pPr>
-            <a:r>
-              <a:rPr sz="1500" b="0">
-                <a:solidFill>
-                  <a:srgbClr val="26221B"/>
-                </a:solidFill>
-                <a:latin typeface="Georgia"/>
-              </a:rPr>
-              <a:t>• Month 2–3: file IRS Form 1023-EZ (if eligible) or Form 1023</a:t>
-            </a:r>
-          </a:p>
-          <a:p>
-            <a:pPr algn="l">
-              <a:spcAft>
-                <a:spcPts val="600"/>
-              </a:spcAft>
-            </a:pPr>
-            <a:r>
-              <a:rPr sz="1500" b="0">
-                <a:solidFill>
-                  <a:srgbClr val="26221B"/>
-                </a:solidFill>
-                <a:latin typeface="Georgia"/>
-              </a:rPr>
-              <a:t>• Month 3+: state charity registration, bank account, annual budget</a:t>
+              <a:t>Who can apply</a:t>
+            </a:r>
+          </a:p>
+          <a:p>
+            <a:pPr algn="l">
+              <a:spcAft>
+                <a:spcPts val="600"/>
+              </a:spcAft>
+            </a:pPr>
+            <a:r>
+              <a:rPr sz="1300" b="0">
+                <a:solidFill>
+                  <a:srgbClr val="26221B"/>
+                </a:solidFill>
+                <a:latin typeface="Georgia"/>
+              </a:rPr>
+              <a:t>• Any descendant, spouse/partner, or child (minors via a guardian) — or apply on behalf of a relative</a:t>
+            </a:r>
+          </a:p>
+          <a:p>
+            <a:pPr algn="l">
+              <a:spcAft>
+                <a:spcPts val="600"/>
+              </a:spcAft>
+            </a:pPr>
+            <a:r>
+              <a:rPr sz="1300" b="0">
+                <a:solidFill>
+                  <a:srgbClr val="26221B"/>
+                </a:solidFill>
+                <a:latin typeface="Georgia"/>
+              </a:rPr>
+              <a:t>• Hardship within the past 12 months: medical, job loss, housing/disaster, funeral, caregiving, education emergency</a:t>
+            </a:r>
+          </a:p>
+          <a:p>
+            <a:pPr algn="l">
+              <a:spcAft>
+                <a:spcPts val="600"/>
+              </a:spcAft>
+            </a:pPr>
+            <a:r>
+              <a:rPr sz="1300" b="0">
+                <a:solidFill>
+                  <a:srgbClr val="26221B"/>
+                </a:solidFill>
+                <a:latin typeface="Georgia"/>
+              </a:rPr>
+              <a:t>• One award per household per cycle; dues status does NOT affect eligibility</a:t>
             </a:r>
           </a:p>
         </p:txBody>
@@ -11339,8 +11526,8 @@
         </p:nvSpPr>
         <p:spPr>
           <a:xfrm>
-            <a:off x="6400800" y="1645920"/>
-            <a:ext cx="5120640" cy="4114800"/>
+            <a:off x="4434840" y="1645920"/>
+            <a:ext cx="3657600" cy="4114800"/>
           </a:xfrm>
           <a:prstGeom prst="rect">
             <a:avLst/>
@@ -11359,77 +11546,77 @@
               </a:spcAft>
             </a:pPr>
             <a:r>
-              <a:rPr sz="1700" b="1">
+              <a:rPr sz="1500" b="1">
                 <a:solidFill>
                   <a:srgbClr val="E65100"/>
                 </a:solidFill>
                 <a:latin typeface="Georgia"/>
               </a:rPr>
-              <a:t>Foundation board (to be elected)</a:t>
-            </a:r>
-          </a:p>
-          <a:p>
-            <a:pPr algn="l">
-              <a:spcAft>
-                <a:spcPts val="600"/>
-              </a:spcAft>
-            </a:pPr>
-            <a:r>
-              <a:rPr sz="1500" b="0">
-                <a:solidFill>
-                  <a:srgbClr val="26221B"/>
-                </a:solidFill>
-                <a:latin typeface="Georgia"/>
-              </a:rPr>
-              <a:t>• Board Chair · Vice Chair · Board Secretary · Board Treasurer</a:t>
-            </a:r>
-          </a:p>
-          <a:p>
-            <a:pPr algn="l">
-              <a:spcAft>
-                <a:spcPts val="600"/>
-              </a:spcAft>
-            </a:pPr>
-            <a:r>
-              <a:rPr sz="1500" b="0">
-                <a:solidFill>
-                  <a:srgbClr val="26221B"/>
-                </a:solidFill>
-                <a:latin typeface="Georgia"/>
-              </a:rPr>
-              <a:t>• 3–5 at-large directors — one from each generation if we can</a:t>
-            </a:r>
-          </a:p>
-          <a:p>
-            <a:pPr algn="l">
-              <a:spcAft>
-                <a:spcPts val="600"/>
-              </a:spcAft>
-            </a:pPr>
-            <a:r>
-              <a:rPr sz="1500" b="0">
-                <a:solidFill>
-                  <a:srgbClr val="26221B"/>
-                </a:solidFill>
-                <a:latin typeface="Georgia"/>
-              </a:rPr>
-              <a:t>• Its own body with its own votes, separate from reunion officers</a:t>
-            </a:r>
-          </a:p>
-          <a:p>
-            <a:pPr algn="l">
-              <a:spcAft>
-                <a:spcPts val="600"/>
-              </a:spcAft>
-            </a:pPr>
-            <a:r>
-              <a:rPr sz="1500" b="0">
-                <a:solidFill>
-                  <a:srgbClr val="26221B"/>
-                </a:solidFill>
-                <a:latin typeface="Georgia"/>
-              </a:rPr>
-              <a:t>• Board meets quarterly; minutes published to the family</a:t>
+              <a:t>How the recipient is chosen</a:t>
+            </a:r>
+          </a:p>
+          <a:p>
+            <a:pPr algn="l">
+              <a:spcAft>
+                <a:spcPts val="600"/>
+              </a:spcAft>
+            </a:pPr>
+            <a:r>
+              <a:rPr sz="1300" b="0">
+                <a:solidFill>
+                  <a:srgbClr val="26221B"/>
+                </a:solidFill>
+                <a:latin typeface="Georgia"/>
+              </a:rPr>
+              <a:t>• Confidential application → Philanthropy &amp; Fundraising Committee scores it</a:t>
+            </a:r>
+          </a:p>
+          <a:p>
+            <a:pPr algn="l">
+              <a:spcAft>
+                <a:spcPts val="600"/>
+              </a:spcAft>
+            </a:pPr>
+            <a:r>
+              <a:rPr sz="1300" b="0">
+                <a:solidFill>
+                  <a:srgbClr val="26221B"/>
+                </a:solidFill>
+                <a:latin typeface="Georgia"/>
+              </a:rPr>
+              <a:t>• Rubric: severity &amp; urgency 40% · impact 30% · clarity &amp; completeness 20% · discretion 10%</a:t>
+            </a:r>
+          </a:p>
+          <a:p>
+            <a:pPr algn="l">
+              <a:spcAft>
+                <a:spcPts val="600"/>
+              </a:spcAft>
+            </a:pPr>
+            <a:r>
+              <a:rPr sz="1300" b="0">
+                <a:solidFill>
+                  <a:srgbClr val="26221B"/>
+                </a:solidFill>
+                <a:latin typeface="Georgia"/>
+              </a:rPr>
+              <a:t>• 3+ independent scorers; household conflicts recuse; officers ratify</a:t>
+            </a:r>
+          </a:p>
+          <a:p>
+            <a:pPr algn="l">
+              <a:spcAft>
+                <a:spcPts val="600"/>
+              </a:spcAft>
+            </a:pPr>
+            <a:r>
+              <a:rPr sz="1300" b="0">
+                <a:solidFill>
+                  <a:srgbClr val="26221B"/>
+                </a:solidFill>
+                <a:latin typeface="Georgia"/>
+              </a:rPr>
+              <a:t>• Recipient may stay ANONYMOUS — always their choice</a:t>
             </a:r>
           </a:p>
         </p:txBody>
@@ -11437,6 +11624,109 @@
       <p:sp>
         <p:nvSpPr>
           <p:cNvPr id="6" name="TextBox 5"/>
+          <p:cNvSpPr txBox="1"/>
+          <p:nvPr/>
+        </p:nvSpPr>
+        <p:spPr>
+          <a:xfrm>
+            <a:off x="8229600" y="1645920"/>
+            <a:ext cx="3566160" cy="4114800"/>
+          </a:xfrm>
+          <a:prstGeom prst="rect">
+            <a:avLst/>
+          </a:prstGeom>
+          <a:noFill/>
+        </p:spPr>
+        <p:txBody>
+          <a:bodyPr wrap="square">
+            <a:spAutoFit/>
+          </a:bodyPr>
+          <a:lstStyle/>
+          <a:p>
+            <a:pPr algn="l">
+              <a:spcAft>
+                <a:spcPts val="800"/>
+              </a:spcAft>
+            </a:pPr>
+            <a:r>
+              <a:rPr sz="1500" b="1">
+                <a:solidFill>
+                  <a:srgbClr val="B71C1C"/>
+                </a:solidFill>
+                <a:latin typeface="Georgia"/>
+              </a:rPr>
+              <a:t>Deadlines each cycle</a:t>
+            </a:r>
+          </a:p>
+          <a:p>
+            <a:pPr algn="l">
+              <a:spcAft>
+                <a:spcPts val="600"/>
+              </a:spcAft>
+            </a:pPr>
+            <a:r>
+              <a:rPr sz="1300" b="0">
+                <a:solidFill>
+                  <a:srgbClr val="26221B"/>
+                </a:solidFill>
+                <a:latin typeface="Georgia"/>
+              </a:rPr>
+              <a:t>• Applications open January 1 of the reunion year</a:t>
+            </a:r>
+          </a:p>
+          <a:p>
+            <a:pPr algn="l">
+              <a:spcAft>
+                <a:spcPts val="600"/>
+              </a:spcAft>
+            </a:pPr>
+            <a:r>
+              <a:rPr sz="1300" b="0">
+                <a:solidFill>
+                  <a:srgbClr val="26221B"/>
+                </a:solidFill>
+                <a:latin typeface="Georgia"/>
+              </a:rPr>
+              <a:t>• Deadline: 30 days before the reunion</a:t>
+            </a:r>
+          </a:p>
+          <a:p>
+            <a:pPr algn="l">
+              <a:spcAft>
+                <a:spcPts val="600"/>
+              </a:spcAft>
+            </a:pPr>
+            <a:r>
+              <a:rPr sz="1300" b="0">
+                <a:solidFill>
+                  <a:srgbClr val="26221B"/>
+                </a:solidFill>
+                <a:latin typeface="Georgia"/>
+              </a:rPr>
+              <a:t>• Committee scores by 14 days out; officers ratify by 7</a:t>
+            </a:r>
+          </a:p>
+          <a:p>
+            <a:pPr algn="l">
+              <a:spcAft>
+                <a:spcPts val="600"/>
+              </a:spcAft>
+            </a:pPr>
+            <a:r>
+              <a:rPr sz="1300" b="0">
+                <a:solidFill>
+                  <a:srgbClr val="26221B"/>
+                </a:solidFill>
+                <a:latin typeface="Georgia"/>
+              </a:rPr>
+              <a:t>• Award presented at Sunday brunch</a:t>
+            </a:r>
+          </a:p>
+        </p:txBody>
+      </p:sp>
+      <p:sp>
+        <p:nvSpPr>
+          <p:cNvPr id="7" name="TextBox 6"/>
           <p:cNvSpPr txBox="1"/>
           <p:nvPr/>
         </p:nvSpPr>
@@ -11468,7 +11758,7 @@
                 </a:solidFill>
                 <a:latin typeface="Verdana"/>
               </a:rPr>
-              <a:t>Nominations open today — see the Secretary. We ratify the founding board by motion and vote.</a:t>
+              <a:t>Apply at hnfamilyreunion.com (Hardship Fund page) or on paper from any officer. Award amount set by the Treasurer's budget each cycle — funded from the fundraising split.</a:t>
             </a:r>
           </a:p>
         </p:txBody>
@@ -11533,7 +11823,7 @@
                 </a:solidFill>
                 <a:latin typeface="Verdana"/>
               </a:rPr>
-              <a:t>ALL WEEKEND LONG</a:t>
+              <a:t>FAMILY BUSINESS · THE FOUNDATION</a:t>
             </a:r>
           </a:p>
         </p:txBody>
@@ -11572,7 +11862,7 @@
                 </a:solidFill>
                 <a:latin typeface="Georgia"/>
               </a:rPr>
-              <a:t>The Family Tree Project — Add Yourself! 🌳</a:t>
+              <a:t>Starting Our Family Foundation — a 501(c)(3) 🏛</a:t>
             </a:r>
           </a:p>
         </p:txBody>
@@ -11611,7 +11901,7 @@
                 </a:solidFill>
                 <a:latin typeface="Georgia"/>
               </a:rPr>
-              <a:t>Four easy steps</a:t>
+              <a:t>The process (next few months)</a:t>
             </a:r>
           </a:p>
           <a:p>
@@ -11627,7 +11917,7 @@
                 </a:solidFill>
                 <a:latin typeface="Georgia"/>
               </a:rPr>
-              <a:t>• Stop by the Family Tree table (or scan the QR code)</a:t>
+              <a:t>• Month 1: choose the name, elect the founding board, draft bylaws &amp; conflict-of-interest policy</a:t>
             </a:r>
           </a:p>
           <a:p>
@@ -11643,7 +11933,7 @@
                 </a:solidFill>
                 <a:latin typeface="Georgia"/>
               </a:rPr>
-              <a:t>• Fill out the short form — name, birthday, parents, branch, children</a:t>
+              <a:t>• Month 1–2: file Articles of Incorporation; get an EIN (free, IRS.gov)</a:t>
             </a:r>
           </a:p>
           <a:p>
@@ -11659,7 +11949,7 @@
                 </a:solidFill>
                 <a:latin typeface="Georgia"/>
               </a:rPr>
-              <a:t>• The Historian (Shone) adds you to the Ancestry tree</a:t>
+              <a:t>• Month 2–3: file IRS Form 1023-EZ (if eligible) or Form 1023</a:t>
             </a:r>
           </a:p>
           <a:p>
@@ -11675,7 +11965,7 @@
                 </a:solidFill>
                 <a:latin typeface="Georgia"/>
               </a:rPr>
-              <a:t>• A large family tree poster gets printed with EVERYONE listed</a:t>
+              <a:t>• Month 3+: state charity registration, bank account, annual budget</a:t>
             </a:r>
           </a:p>
         </p:txBody>
@@ -11714,7 +12004,7 @@
                 </a:solidFill>
                 <a:latin typeface="Georgia"/>
               </a:rPr>
-              <a:t>Ways to submit</a:t>
+              <a:t>Foundation board (to be elected)</a:t>
             </a:r>
           </a:p>
           <a:p>
@@ -11730,7 +12020,7 @@
                 </a:solidFill>
                 <a:latin typeface="Georgia"/>
               </a:rPr>
-              <a:t>• Online: the Family Tree Google Form, or the matching form on hnfamilyreunion.com</a:t>
+              <a:t>• Board Chair · Vice Chair · Board Secretary · Board Treasurer</a:t>
             </a:r>
           </a:p>
           <a:p>
@@ -11746,7 +12036,7 @@
                 </a:solidFill>
                 <a:latin typeface="Georgia"/>
               </a:rPr>
-              <a:t>• Paper: forms at the Family Tree table all weekend</a:t>
+              <a:t>• 3–5 at-large directors — one from each generation if we can</a:t>
             </a:r>
           </a:p>
           <a:p>
@@ -11762,7 +12052,62 @@
                 </a:solidFill>
                 <a:latin typeface="Georgia"/>
               </a:rPr>
-              <a:t>• Bring old photos, obituaries, bibles, deeds — we scan them on the spot (you keep the originals)</a:t>
+              <a:t>• Its own body with its own votes, separate from reunion officers</a:t>
+            </a:r>
+          </a:p>
+          <a:p>
+            <a:pPr algn="l">
+              <a:spcAft>
+                <a:spcPts val="600"/>
+              </a:spcAft>
+            </a:pPr>
+            <a:r>
+              <a:rPr sz="1500" b="0">
+                <a:solidFill>
+                  <a:srgbClr val="26221B"/>
+                </a:solidFill>
+                <a:latin typeface="Georgia"/>
+              </a:rPr>
+              <a:t>• Board meets quarterly; minutes published to the family</a:t>
+            </a:r>
+          </a:p>
+        </p:txBody>
+      </p:sp>
+      <p:sp>
+        <p:nvSpPr>
+          <p:cNvPr id="6" name="TextBox 5"/>
+          <p:cNvSpPr txBox="1"/>
+          <p:nvPr/>
+        </p:nvSpPr>
+        <p:spPr>
+          <a:xfrm>
+            <a:off x="640080" y="6291072"/>
+            <a:ext cx="10911535" cy="457200"/>
+          </a:xfrm>
+          <a:prstGeom prst="rect">
+            <a:avLst/>
+          </a:prstGeom>
+          <a:noFill/>
+        </p:spPr>
+        <p:txBody>
+          <a:bodyPr wrap="square">
+            <a:spAutoFit/>
+          </a:bodyPr>
+          <a:lstStyle/>
+          <a:p>
+            <a:pPr algn="l">
+              <a:spcAft>
+                <a:spcPts val="600"/>
+              </a:spcAft>
+            </a:pPr>
+            <a:r>
+              <a:rPr sz="1100" b="0">
+                <a:solidFill>
+                  <a:srgbClr val="6B6355"/>
+                </a:solidFill>
+                <a:latin typeface="Verdana"/>
+              </a:rPr>
+              <a:t>Nominations open today — see the Secretary. We ratify the founding board by motion and vote.</a:t>
             </a:r>
           </a:p>
         </p:txBody>
@@ -11776,6 +12121,300 @@
 </file>
 
 <file path=ppt/slides/slide27.xml><?xml version="1.0" encoding="utf-8"?>
+<p:sld xmlns:a="http://schemas.openxmlformats.org/drawingml/2006/main" xmlns:p="http://schemas.openxmlformats.org/presentationml/2006/main" xmlns:r="http://schemas.openxmlformats.org/officeDocument/2006/relationships">
+  <p:cSld>
+    <p:bg>
+      <p:bgPr>
+        <a:solidFill>
+          <a:srgbClr val="FAF6EE"/>
+        </a:solidFill>
+        <a:effectLst/>
+      </p:bgPr>
+    </p:bg>
+    <p:spTree>
+      <p:nvGrpSpPr>
+        <p:cNvPr id="1" name=""/>
+        <p:cNvGrpSpPr/>
+        <p:nvPr/>
+      </p:nvGrpSpPr>
+      <p:grpSpPr/>
+      <p:sp>
+        <p:nvSpPr>
+          <p:cNvPr id="2" name="TextBox 1"/>
+          <p:cNvSpPr txBox="1"/>
+          <p:nvPr/>
+        </p:nvSpPr>
+        <p:spPr>
+          <a:xfrm>
+            <a:off x="640080" y="320040"/>
+            <a:ext cx="10911535" cy="365760"/>
+          </a:xfrm>
+          <a:prstGeom prst="rect">
+            <a:avLst/>
+          </a:prstGeom>
+          <a:noFill/>
+        </p:spPr>
+        <p:txBody>
+          <a:bodyPr wrap="square">
+            <a:spAutoFit/>
+          </a:bodyPr>
+          <a:lstStyle/>
+          <a:p>
+            <a:pPr algn="l">
+              <a:spcAft>
+                <a:spcPts val="600"/>
+              </a:spcAft>
+            </a:pPr>
+            <a:r>
+              <a:rPr sz="1300" b="1">
+                <a:solidFill>
+                  <a:srgbClr val="E65100"/>
+                </a:solidFill>
+                <a:latin typeface="Verdana"/>
+              </a:rPr>
+              <a:t>ALL WEEKEND LONG</a:t>
+            </a:r>
+          </a:p>
+        </p:txBody>
+      </p:sp>
+      <p:sp>
+        <p:nvSpPr>
+          <p:cNvPr id="3" name="TextBox 2"/>
+          <p:cNvSpPr txBox="1"/>
+          <p:nvPr/>
+        </p:nvSpPr>
+        <p:spPr>
+          <a:xfrm>
+            <a:off x="640080" y="685800"/>
+            <a:ext cx="10911535" cy="822960"/>
+          </a:xfrm>
+          <a:prstGeom prst="rect">
+            <a:avLst/>
+          </a:prstGeom>
+          <a:noFill/>
+        </p:spPr>
+        <p:txBody>
+          <a:bodyPr wrap="square">
+            <a:spAutoFit/>
+          </a:bodyPr>
+          <a:lstStyle/>
+          <a:p>
+            <a:pPr algn="l">
+              <a:spcAft>
+                <a:spcPts val="600"/>
+              </a:spcAft>
+            </a:pPr>
+            <a:r>
+              <a:rPr sz="3400" b="1">
+                <a:solidFill>
+                  <a:srgbClr val="1B5E20"/>
+                </a:solidFill>
+                <a:latin typeface="Georgia"/>
+              </a:rPr>
+              <a:t>The Family Tree Project — Add Yourself! 🌳</a:t>
+            </a:r>
+          </a:p>
+        </p:txBody>
+      </p:sp>
+      <p:sp>
+        <p:nvSpPr>
+          <p:cNvPr id="4" name="TextBox 3"/>
+          <p:cNvSpPr txBox="1"/>
+          <p:nvPr/>
+        </p:nvSpPr>
+        <p:spPr>
+          <a:xfrm>
+            <a:off x="640080" y="1645920"/>
+            <a:ext cx="5486400" cy="4114800"/>
+          </a:xfrm>
+          <a:prstGeom prst="rect">
+            <a:avLst/>
+          </a:prstGeom>
+          <a:noFill/>
+        </p:spPr>
+        <p:txBody>
+          <a:bodyPr wrap="square">
+            <a:spAutoFit/>
+          </a:bodyPr>
+          <a:lstStyle/>
+          <a:p>
+            <a:pPr algn="l">
+              <a:spcAft>
+                <a:spcPts val="800"/>
+              </a:spcAft>
+            </a:pPr>
+            <a:r>
+              <a:rPr sz="1700" b="1">
+                <a:solidFill>
+                  <a:srgbClr val="2E7D32"/>
+                </a:solidFill>
+                <a:latin typeface="Georgia"/>
+              </a:rPr>
+              <a:t>Four easy steps</a:t>
+            </a:r>
+          </a:p>
+          <a:p>
+            <a:pPr algn="l">
+              <a:spcAft>
+                <a:spcPts val="600"/>
+              </a:spcAft>
+            </a:pPr>
+            <a:r>
+              <a:rPr sz="1500" b="0">
+                <a:solidFill>
+                  <a:srgbClr val="26221B"/>
+                </a:solidFill>
+                <a:latin typeface="Georgia"/>
+              </a:rPr>
+              <a:t>• Stop by the Family Tree table (or scan the QR code)</a:t>
+            </a:r>
+          </a:p>
+          <a:p>
+            <a:pPr algn="l">
+              <a:spcAft>
+                <a:spcPts val="600"/>
+              </a:spcAft>
+            </a:pPr>
+            <a:r>
+              <a:rPr sz="1500" b="0">
+                <a:solidFill>
+                  <a:srgbClr val="26221B"/>
+                </a:solidFill>
+                <a:latin typeface="Georgia"/>
+              </a:rPr>
+              <a:t>• Fill out the short form — name, birthday, parents, branch, children</a:t>
+            </a:r>
+          </a:p>
+          <a:p>
+            <a:pPr algn="l">
+              <a:spcAft>
+                <a:spcPts val="600"/>
+              </a:spcAft>
+            </a:pPr>
+            <a:r>
+              <a:rPr sz="1500" b="0">
+                <a:solidFill>
+                  <a:srgbClr val="26221B"/>
+                </a:solidFill>
+                <a:latin typeface="Georgia"/>
+              </a:rPr>
+              <a:t>• The Historian (Shone) adds you to the Ancestry tree</a:t>
+            </a:r>
+          </a:p>
+          <a:p>
+            <a:pPr algn="l">
+              <a:spcAft>
+                <a:spcPts val="600"/>
+              </a:spcAft>
+            </a:pPr>
+            <a:r>
+              <a:rPr sz="1500" b="0">
+                <a:solidFill>
+                  <a:srgbClr val="26221B"/>
+                </a:solidFill>
+                <a:latin typeface="Georgia"/>
+              </a:rPr>
+              <a:t>• A large family tree poster gets printed with EVERYONE listed</a:t>
+            </a:r>
+          </a:p>
+        </p:txBody>
+      </p:sp>
+      <p:sp>
+        <p:nvSpPr>
+          <p:cNvPr id="5" name="TextBox 4"/>
+          <p:cNvSpPr txBox="1"/>
+          <p:nvPr/>
+        </p:nvSpPr>
+        <p:spPr>
+          <a:xfrm>
+            <a:off x="6400800" y="1645920"/>
+            <a:ext cx="5120640" cy="4114800"/>
+          </a:xfrm>
+          <a:prstGeom prst="rect">
+            <a:avLst/>
+          </a:prstGeom>
+          <a:noFill/>
+        </p:spPr>
+        <p:txBody>
+          <a:bodyPr wrap="square">
+            <a:spAutoFit/>
+          </a:bodyPr>
+          <a:lstStyle/>
+          <a:p>
+            <a:pPr algn="l">
+              <a:spcAft>
+                <a:spcPts val="800"/>
+              </a:spcAft>
+            </a:pPr>
+            <a:r>
+              <a:rPr sz="1700" b="1">
+                <a:solidFill>
+                  <a:srgbClr val="E65100"/>
+                </a:solidFill>
+                <a:latin typeface="Georgia"/>
+              </a:rPr>
+              <a:t>Ways to submit</a:t>
+            </a:r>
+          </a:p>
+          <a:p>
+            <a:pPr algn="l">
+              <a:spcAft>
+                <a:spcPts val="600"/>
+              </a:spcAft>
+            </a:pPr>
+            <a:r>
+              <a:rPr sz="1500" b="0">
+                <a:solidFill>
+                  <a:srgbClr val="26221B"/>
+                </a:solidFill>
+                <a:latin typeface="Georgia"/>
+              </a:rPr>
+              <a:t>• Online: the Family Tree Google Form, or the matching form on hnfamilyreunion.com</a:t>
+            </a:r>
+          </a:p>
+          <a:p>
+            <a:pPr algn="l">
+              <a:spcAft>
+                <a:spcPts val="600"/>
+              </a:spcAft>
+            </a:pPr>
+            <a:r>
+              <a:rPr sz="1500" b="0">
+                <a:solidFill>
+                  <a:srgbClr val="26221B"/>
+                </a:solidFill>
+                <a:latin typeface="Georgia"/>
+              </a:rPr>
+              <a:t>• Paper: forms at the Family Tree table all weekend</a:t>
+            </a:r>
+          </a:p>
+          <a:p>
+            <a:pPr algn="l">
+              <a:spcAft>
+                <a:spcPts val="600"/>
+              </a:spcAft>
+            </a:pPr>
+            <a:r>
+              <a:rPr sz="1500" b="0">
+                <a:solidFill>
+                  <a:srgbClr val="26221B"/>
+                </a:solidFill>
+                <a:latin typeface="Georgia"/>
+              </a:rPr>
+              <a:t>• Bring old photos, obituaries, bibles, deeds — we scan them on the spot (you keep the originals)</a:t>
+            </a:r>
+          </a:p>
+        </p:txBody>
+      </p:sp>
+    </p:spTree>
+  </p:cSld>
+  <p:clrMapOvr>
+    <a:masterClrMapping/>
+  </p:clrMapOvr>
+</p:sld>
+</file>
+
+<file path=ppt/slides/slide28.xml><?xml version="1.0" encoding="utf-8"?>
 <p:sld xmlns:a="http://schemas.openxmlformats.org/drawingml/2006/main" xmlns:p="http://schemas.openxmlformats.org/presentationml/2006/main" xmlns:r="http://schemas.openxmlformats.org/officeDocument/2006/relationships">
   <p:cSld>
     <p:bg>
@@ -12273,7 +12912,7 @@
 </p:sld>
 </file>
 
-<file path=ppt/slides/slide28.xml><?xml version="1.0" encoding="utf-8"?>
+<file path=ppt/slides/slide29.xml><?xml version="1.0" encoding="utf-8"?>
 <p:sld xmlns:a="http://schemas.openxmlformats.org/drawingml/2006/main" xmlns:p="http://schemas.openxmlformats.org/presentationml/2006/main" xmlns:r="http://schemas.openxmlformats.org/officeDocument/2006/relationships">
   <p:cSld>
     <p:bg>

</xml_diff>

<commit_message>
Update questionnaire data to 8 responses (adds Marcelette)
- Stats slide & charts: 8 responses, 7% participation
- Spotlights: VSU '12 + WashU Master's '17, Alpha Kappa Alpha, the all-M
  household; foundation volunteers now Toni, Dennis Jr. & Marcelette
- data/questionnaire-2026.csv regenerated (payment/receipt/dues columns
  removed); genealogy verified against the GEDCOM (already matching)

Co-Authored-By: Claude Fable 5 <noreply@anthropic.com>
Claude-Session: https://claude.ai/code/session_01NPnb9BRrqaoMRYjtDyxgui
</commit_message>
<xml_diff>
--- a/presentation/Harris-Nelson-Reunion-2026.pptx
+++ b/presentation/Harris-Nelson-Reunion-2026.pptx
@@ -3988,6 +3988,22 @@
               <a:t>• Dennis Jr. — serves special-needs students</a:t>
             </a:r>
           </a:p>
+          <a:p>
+            <a:pPr algn="l">
+              <a:spcAft>
+                <a:spcPts val="600"/>
+              </a:spcAft>
+            </a:pPr>
+            <a:r>
+              <a:rPr sz="1200" b="0">
+                <a:solidFill>
+                  <a:srgbClr val="26221B"/>
+                </a:solidFill>
+                <a:latin typeface="Georgia"/>
+              </a:rPr>
+              <a:t>• Marcelette — Virginia State '12, Master's from WashU St. Louis '17 (Alpha Kappa Alpha)</a:t>
+            </a:r>
+          </a:p>
         </p:txBody>
       </p:sp>
       <p:sp>
@@ -4091,6 +4107,22 @@
               <a:t>• Miesha researched the census from when Grandma Lela Mae was a baby</a:t>
             </a:r>
           </a:p>
+          <a:p>
+            <a:pPr algn="l">
+              <a:spcAft>
+                <a:spcPts val="600"/>
+              </a:spcAft>
+            </a:pPr>
+            <a:r>
+              <a:rPr sz="1200" b="0">
+                <a:solidFill>
+                  <a:srgbClr val="26221B"/>
+                </a:solidFill>
+                <a:latin typeface="Georgia"/>
+              </a:rPr>
+              <a:t>• Everyone in Marcelette's house has an M name — including the dogs, Mitchell &amp; Maximus</a:t>
+            </a:r>
+          </a:p>
         </p:txBody>
       </p:sp>
       <p:sp>
@@ -4246,7 +4278,7 @@
                 </a:solidFill>
                 <a:latin typeface="Verdana"/>
               </a:rPr>
-              <a:t>From the 2026 Family Questionnaire (7 responses so far). Genealogy answers went straight to the Historian for the family tree.</a:t>
+              <a:t>From the 2026 Family Questionnaire (8 responses so far). Genealogy answers went straight to the Historian for the family tree.</a:t>
             </a:r>
           </a:p>
         </p:txBody>
@@ -4350,7 +4382,7 @@
                 </a:solidFill>
                 <a:latin typeface="Georgia"/>
               </a:rPr>
-              <a:t>115 of Us Showed Up. 7 Filled Out the Questionnaire. 😬</a:t>
+              <a:t>115 of Us Showed Up. 8 Filled Out the Questionnaire. 😬</a:t>
             </a:r>
           </a:p>
         </p:txBody>
@@ -4444,7 +4476,7 @@
                 </a:solidFill>
                 <a:latin typeface="Georgia"/>
               </a:rPr>
-              <a:t>7</a:t>
+              <a:t>8</a:t>
             </a:r>
           </a:p>
           <a:p>
@@ -4499,7 +4531,7 @@
                 </a:solidFill>
                 <a:latin typeface="Georgia"/>
               </a:rPr>
-              <a:t>6%</a:t>
+              <a:t>7%</a:t>
             </a:r>
           </a:p>
           <a:p>
@@ -4849,7 +4881,7 @@
         <p:spPr>
           <a:xfrm>
             <a:off x="3063239" y="3739896"/>
-            <a:ext cx="137160" cy="201168"/>
+            <a:ext cx="160020" cy="201168"/>
           </a:xfrm>
           <a:prstGeom prst="rect">
             <a:avLst/>
@@ -4917,7 +4949,7 @@
                 </a:solidFill>
                 <a:latin typeface="Verdana"/>
               </a:rPr>
-              <a:t>7</a:t>
+              <a:t>8</a:t>
             </a:r>
           </a:p>
         </p:txBody>
@@ -5460,7 +5492,7 @@
                 </a:solidFill>
                 <a:latin typeface="Georgia"/>
               </a:rPr>
-              <a:t>• The yearbook, tree poster, acknowledgments &amp; trivia were ALL built from those 7 responses</a:t>
+              <a:t>• The yearbook, tree poster, acknowledgments &amp; trivia were ALL built from those 8 responses</a:t>
             </a:r>
           </a:p>
           <a:p>
@@ -13933,7 +13965,7 @@
                 </a:solidFill>
                 <a:latin typeface="Verdana"/>
               </a:rPr>
-              <a:t>Nominations open today — see the Secretary. Already raised their hands on the questionnaire: Toni Nelson &amp; Dennis Derrick Jr. We ratify the founding board by motion and vote.</a:t>
+              <a:t>Nominations open today — see the Secretary. Already raised their hands on the questionnaire: Toni Nelson, Dennis Derrick Jr. &amp; Marcelette We ratify the founding board by motion and vote.</a:t>
             </a:r>
           </a:p>
         </p:txBody>

</xml_diff>

<commit_message>
Point site at hnreunion.com and add GitHub Pages auto-deploy
- All domain references updated hnfamilyreunion.com -> hnreunion.com
  (family email unchanged)
- .github/workflows/deploy-pages.yml: deploys website/ to GitHub Pages on
  every push to main

Co-Authored-By: Claude Fable 5 <noreply@anthropic.com>
Claude-Session: https://claude.ai/code/session_01NPnb9BRrqaoMRYjtDyxgui
</commit_message>
<xml_diff>
--- a/presentation/Harris-Nelson-Reunion-2026.pptx
+++ b/presentation/Harris-Nelson-Reunion-2026.pptx
@@ -3281,7 +3281,7 @@
                 </a:solidFill>
                 <a:latin typeface="Verdana"/>
               </a:rPr>
-              <a:t>Cleveland, Ohio · July 17–19, 2026 · hnfamilyreunion.com</a:t>
+              <a:t>Cleveland, Ohio · July 17–19, 2026 · hnreunion.com</a:t>
             </a:r>
           </a:p>
         </p:txBody>
@@ -9661,7 +9661,7 @@
                 </a:solidFill>
                 <a:latin typeface="Georgia"/>
               </a:rPr>
-              <a:t>12.  Our New Website: hnfamilyreunion.com</a:t>
+              <a:t>12.  Our New Website: hnreunion.com</a:t>
             </a:r>
           </a:p>
           <a:p>
@@ -10737,7 +10737,7 @@
                 </a:solidFill>
                 <a:latin typeface="Georgia"/>
               </a:rPr>
-              <a:t>hnfamilyreunion.com, online payments &amp; shirts, tree tools</a:t>
+              <a:t>hnreunion.com, online payments &amp; shirts, tree tools</a:t>
             </a:r>
           </a:p>
         </p:txBody>
@@ -11643,7 +11643,7 @@
                 </a:solidFill>
                 <a:latin typeface="Georgia"/>
               </a:rPr>
-              <a:t>• Online: Committee Sign-Up form on hnfamilyreunion.com</a:t>
+              <a:t>• Online: Committee Sign-Up form on hnreunion.com</a:t>
             </a:r>
           </a:p>
           <a:p>
@@ -12206,7 +12206,7 @@
                 </a:solidFill>
                 <a:latin typeface="Georgia"/>
               </a:rPr>
-              <a:t>Our New Home Online: hnfamilyreunion.com 💻</a:t>
+              <a:t>Our New Home Online: hnreunion.com 💻</a:t>
             </a:r>
           </a:p>
         </p:txBody>
@@ -13616,7 +13616,7 @@
                 </a:solidFill>
                 <a:latin typeface="Verdana"/>
               </a:rPr>
-              <a:t>Apply at hnfamilyreunion.com (Hardship Fund page) or on paper from any officer. Award amount set by the Treasurer's budget each cycle — funded from the fundraising split.</a:t>
+              <a:t>Apply at hnreunion.com (Hardship Fund page) or on paper from any officer. Award amount set by the Treasurer's budget each cycle — funded from the fundraising split.</a:t>
             </a:r>
           </a:p>
         </p:txBody>
@@ -14227,7 +14227,7 @@
                 </a:solidFill>
                 <a:latin typeface="Georgia"/>
               </a:rPr>
-              <a:t>• Online: the Family Tree Google Form, or the matching form on hnfamilyreunion.com</a:t>
+              <a:t>• Online: the Family Tree Google Form, or the matching form on hnreunion.com</a:t>
             </a:r>
           </a:p>
           <a:p>
@@ -14915,7 +14915,7 @@
                             <a:srgbClr val="26221B"/>
                           </a:solidFill>
                         </a:rPr>
-                        <a:t>hnfamilyreunion.com (launching soon)</a:t>
+                        <a:t>hnreunion.com (launching soon)</a:t>
                       </a:r>
                     </a:p>
                   </a:txBody>
@@ -15360,7 +15360,7 @@
                 </a:solidFill>
                 <a:latin typeface="Verdana"/>
               </a:rPr>
-              <a:t>Harris-Nelson Family Reunion · hnfamilyreunion.com · harrisnelsonfamilyreunion@gmail.com</a:t>
+              <a:t>Harris-Nelson Family Reunion · hnreunion.com · harrisnelsonfamilyreunion@gmail.com</a:t>
             </a:r>
           </a:p>
         </p:txBody>
@@ -17477,7 +17477,7 @@
                 </a:solidFill>
                 <a:latin typeface="Georgia"/>
               </a:rPr>
-              <a:t>• All 123 slides play fullscreen on the Photos page of hnfamilyreunion.com</a:t>
+              <a:t>• All 123 slides play fullscreen on the Photos page of hnreunion.com</a:t>
             </a:r>
           </a:p>
           <a:p>

</xml_diff>

<commit_message>
Add WordPress handoff package for Claude Chrome
wordpress/: all 13 pages converted to paste-ready Custom-HTML fragments
(links mapped to WP permalinks, photos served from raw GitHub URLs, static
forms swapped for Fluent Forms placeholders; interactive tree and gallery
keep their working JS), scoped additional.css for the theme customizer, and
RUNBOOK-WORDPRESS.md covering pages, menus, Ultimate Member registration
fields (generalized questionnaire, profiles behind login, registration
doubles as the family-tree entry), the four Fluent Forms, WooCommerce
dues/shirt products with a repeatable installment product, and GiveWP goal
meters for the three funds.

Co-Authored-By: Claude Fable 5 <noreply@anthropic.com>
Claude-Session: https://claude.ai/code/session_01NPnb9BRrqaoMRYjtDyxgui
</commit_message>
<xml_diff>
--- a/presentation/Harris-Nelson-Reunion-2026.pptx
+++ b/presentation/Harris-Nelson-Reunion-2026.pptx
@@ -3281,7 +3281,7 @@
                 </a:solidFill>
                 <a:latin typeface="Verdana"/>
               </a:rPr>
-              <a:t>Cleveland, Ohio · July 17–19, 2026 · hnreunion.com</a:t>
+              <a:t>Cleveland, Ohio · July 17–19, 2026 · hnfamilyreunion.com</a:t>
             </a:r>
           </a:p>
         </p:txBody>
@@ -9661,7 +9661,7 @@
                 </a:solidFill>
                 <a:latin typeface="Georgia"/>
               </a:rPr>
-              <a:t>12.  Our New Website: hnreunion.com</a:t>
+              <a:t>12.  Our New Website: hnfamilyreunion.com</a:t>
             </a:r>
           </a:p>
           <a:p>
@@ -10737,7 +10737,7 @@
                 </a:solidFill>
                 <a:latin typeface="Georgia"/>
               </a:rPr>
-              <a:t>hnreunion.com, online payments &amp; shirts, tree tools</a:t>
+              <a:t>hnfamilyreunion.com, online payments &amp; shirts, tree tools</a:t>
             </a:r>
           </a:p>
         </p:txBody>
@@ -11643,7 +11643,7 @@
                 </a:solidFill>
                 <a:latin typeface="Georgia"/>
               </a:rPr>
-              <a:t>• Online: Committee Sign-Up form on hnreunion.com</a:t>
+              <a:t>• Online: Committee Sign-Up form on hnfamilyreunion.com</a:t>
             </a:r>
           </a:p>
           <a:p>
@@ -12206,7 +12206,7 @@
                 </a:solidFill>
                 <a:latin typeface="Georgia"/>
               </a:rPr>
-              <a:t>Our New Home Online: hnreunion.com 💻</a:t>
+              <a:t>Our New Home Online: hnfamilyreunion.com 💻</a:t>
             </a:r>
           </a:p>
         </p:txBody>
@@ -13616,7 +13616,7 @@
                 </a:solidFill>
                 <a:latin typeface="Verdana"/>
               </a:rPr>
-              <a:t>Apply at hnreunion.com (Hardship Fund page) or on paper from any officer. Award amount set by the Treasurer's budget each cycle — funded from the fundraising split.</a:t>
+              <a:t>Apply at hnfamilyreunion.com (Hardship Fund page) or on paper from any officer. Award amount set by the Treasurer's budget each cycle — funded from the fundraising split.</a:t>
             </a:r>
           </a:p>
         </p:txBody>
@@ -14227,7 +14227,7 @@
                 </a:solidFill>
                 <a:latin typeface="Georgia"/>
               </a:rPr>
-              <a:t>• Online: the Family Tree Google Form, or the matching form on hnreunion.com</a:t>
+              <a:t>• Online: the Family Tree Google Form, or the matching form on hnfamilyreunion.com</a:t>
             </a:r>
           </a:p>
           <a:p>
@@ -14915,7 +14915,7 @@
                             <a:srgbClr val="26221B"/>
                           </a:solidFill>
                         </a:rPr>
-                        <a:t>hnreunion.com (launching soon)</a:t>
+                        <a:t>hnfamilyreunion.com (launching soon)</a:t>
                       </a:r>
                     </a:p>
                   </a:txBody>
@@ -15360,7 +15360,7 @@
                 </a:solidFill>
                 <a:latin typeface="Verdana"/>
               </a:rPr>
-              <a:t>Harris-Nelson Family Reunion · hnreunion.com · harrisnelsonfamilyreunion@gmail.com</a:t>
+              <a:t>Harris-Nelson Family Reunion · hnfamilyreunion.com · harrisnelsonfamilyreunion@gmail.com</a:t>
             </a:r>
           </a:p>
         </p:txBody>
@@ -17477,7 +17477,7 @@
                 </a:solidFill>
                 <a:latin typeface="Georgia"/>
               </a:rPr>
-              <a:t>• All 123 slides play fullscreen on the Photos page of hnreunion.com</a:t>
+              <a:t>• All 123 slides play fullscreen on the Photos page of hnfamilyreunion.com</a:t>
             </a:r>
           </a:p>
           <a:p>

</xml_diff>

<commit_message>
Design system v2 'Sunday Best' + venue corrections
- New site-wide typography: Fraunces headings + Nunito body (ends the
  font collision with the theme); larger type, darker muted for contrast
- Razzle: gradient hero headline + confetti sun-glow, card hover lifts
  with gradient ribbons, sunset-gradient buttons, zebra tables, gradient
  nav band, styled dropdowns, footer gradient trim, focus-visible states,
  reduced-motion guard; WooCommerce/UM/GiveWP controls match the system
- Friday: Andrews Osborne Park 'at the front pavilion' (was 'in back');
  Saturday: 11 AM-8 PM (was 10 AM-3 PM) across site, deck, and PPTX

Co-Authored-By: Claude Fable 5 <noreply@anthropic.com>
Claude-Session: https://claude.ai/code/session_01NPnb9BRrqaoMRYjtDyxgui
</commit_message>
<xml_diff>
--- a/presentation/Harris-Nelson-Reunion-2026.pptx
+++ b/presentation/Harris-Nelson-Reunion-2026.pptx
@@ -14418,7 +14418,7 @@
                 </a:solidFill>
                 <a:latin typeface="Georgia"/>
               </a:rPr>
-              <a:t>• Andrews Osborne Park (in back), 38575 Lakeshore Blvd, Willoughby OH 44094</a:t>
+              <a:t>• Andrews Osborne Park — at the front pavilion, 38575 Lakeshore Blvd, Willoughby OH 44094</a:t>
             </a:r>
           </a:p>
           <a:p>
@@ -14505,7 +14505,7 @@
                 </a:solidFill>
                 <a:latin typeface="Georgia"/>
               </a:rPr>
-              <a:t>SATURDAY 7/18 · 10 AM–3 PM · Family Fun</a:t>
+              <a:t>SATURDAY 7/18 · 11 AM–8 PM · Family Fun</a:t>
             </a:r>
           </a:p>
           <a:p>

</xml_diff>